<commit_message>
Istanbul deck: wavelength sweep and buffered results (5 slides)
Co-Authored-By: Claude Opus 5.5 <noreply@anthropic.com>
Claude-Session: https://claude.ai/code/session_01EHQDy7yrZwCZyHELu6KFb3
</commit_message>
<xml_diff>
--- a/results/istanbul/Istanbul_results_AFR.pptx
+++ b/results/istanbul/Istanbul_results_AFR.pptx
@@ -10,6 +10,9 @@
   <p:sldIdLst>
     <p:sldId id="276" r:id="rId27"/>
     <p:sldId id="277" r:id="rId28"/>
+    <p:sldId id="278" r:id="rId29"/>
+    <p:sldId id="279" r:id="rId30"/>
+    <p:sldId id="280" r:id="rId31"/>
   </p:sldIdLst>
   <p:sldSz cx="12192000" cy="6858000"/>
   <p:notesSz cx="6858000" cy="9144000"/>
@@ -655,6 +658,3078 @@
                 </c:pt>
                 <c:pt idx="1">
                   <c:v>1.1</c:v>
+                </c:pt>
+              </c:numCache>
+            </c:numRef>
+          </c:yVal>
+          <c:smooth val="0"/>
+        </c:ser>
+        <c:axId val="-2128940872"/>
+        <c:axId val="-2129643912"/>
+      </c:scatterChart>
+      <c:valAx>
+        <c:axId val="-2128940872"/>
+        <c:scaling>
+          <c:orientation val="minMax"/>
+          <c:max val="13.0"/>
+          <c:min val="5.0"/>
+        </c:scaling>
+        <c:delete val="0"/>
+        <c:axPos val="b"/>
+        <c:title>
+          <c:tx>
+            <c:rich>
+              <a:bodyPr/>
+              <a:lstStyle/>
+              <a:p>
+                <a:r>
+                  <a:rPr sz="1100" b="0">
+                    <a:latin typeface="Arial"/>
+                  </a:rPr>
+                  <a:t>Slab width (µm)</a:t>
+                </a:r>
+              </a:p>
+            </c:rich>
+          </c:tx>
+          <c:layout/>
+          <c:overlay val="0"/>
+        </c:title>
+        <c:numFmt formatCode="General" sourceLinked="1"/>
+        <c:majorTickMark val="out"/>
+        <c:minorTickMark val="none"/>
+        <c:tickLblPos val="nextTo"/>
+        <c:txPr>
+          <a:bodyPr/>
+          <a:lstStyle/>
+          <a:p>
+            <a:pPr>
+              <a:defRPr sz="1000">
+                <a:latin typeface="Arial"/>
+              </a:defRPr>
+            </a:pPr>
+          </a:p>
+        </c:txPr>
+        <c:crossAx val="-2129643912"/>
+        <c:crosses val="autoZero"/>
+        <c:crossBetween val="midCat"/>
+        <c:majorUnit val="1.0"/>
+      </c:valAx>
+      <c:valAx>
+        <c:axId val="-2129643912"/>
+        <c:scaling>
+          <c:orientation val="minMax"/>
+          <c:max val="1.1"/>
+          <c:min val="0.0"/>
+        </c:scaling>
+        <c:delete val="0"/>
+        <c:axPos val="l"/>
+        <c:majorGridlines>
+          <c:spPr>
+            <a:ln>
+              <a:solidFill>
+                <a:srgbClr val="E3E3E3"/>
+              </a:solidFill>
+            </a:ln>
+          </c:spPr>
+        </c:majorGridlines>
+        <c:title>
+          <c:tx>
+            <c:rich>
+              <a:bodyPr/>
+              <a:lstStyle/>
+              <a:p>
+                <a:r>
+                  <a:rPr sz="1100" b="0">
+                    <a:latin typeface="Arial"/>
+                  </a:rPr>
+                  <a:t>Insertion loss (dB/cm)</a:t>
+                </a:r>
+              </a:p>
+            </c:rich>
+          </c:tx>
+          <c:layout/>
+          <c:overlay val="0"/>
+        </c:title>
+        <c:numFmt formatCode="General" sourceLinked="0"/>
+        <c:majorTickMark val="out"/>
+        <c:minorTickMark val="none"/>
+        <c:tickLblPos val="nextTo"/>
+        <c:txPr>
+          <a:bodyPr/>
+          <a:lstStyle/>
+          <a:p>
+            <a:pPr>
+              <a:defRPr sz="1000">
+                <a:latin typeface="Arial"/>
+              </a:defRPr>
+            </a:pPr>
+          </a:p>
+        </c:txPr>
+        <c:crossAx val="-2128940872"/>
+        <c:crosses val="autoZero"/>
+        <c:crossBetween val="midCat"/>
+        <c:majorUnit val="0.1"/>
+      </c:valAx>
+    </c:plotArea>
+    <c:legend>
+      <c:legendPos val="t"/>
+      <c:layout/>
+      <c:overlay val="0"/>
+      <c:txPr>
+        <a:bodyPr/>
+        <a:lstStyle/>
+        <a:p>
+          <a:pPr>
+            <a:defRPr sz="1000">
+              <a:latin typeface="Arial"/>
+            </a:defRPr>
+          </a:pPr>
+        </a:p>
+      </c:txPr>
+    </c:legend>
+    <c:plotVisOnly val="1"/>
+    <c:dispBlanksAs val="gap"/>
+    <c:showDLblsOverMax val="0"/>
+  </c:chart>
+  <c:txPr>
+    <a:bodyPr/>
+    <a:lstStyle/>
+    <a:p>
+      <a:pPr>
+        <a:defRPr sz="1800"/>
+      </a:pPr>
+      <a:endParaRPr lang="en-US"/>
+    </a:p>
+  </c:txPr>
+  <c:externalData r:id="rId1">
+    <c:autoUpdate val="0"/>
+  </c:externalData>
+</c:chartSpace>
+</file>
+
+<file path=ppt/charts/chart19.xml><?xml version="1.0" encoding="utf-8"?>
+<c:chartSpace xmlns:c="http://schemas.openxmlformats.org/drawingml/2006/chart" xmlns:a="http://schemas.openxmlformats.org/drawingml/2006/main" xmlns:r="http://schemas.openxmlformats.org/officeDocument/2006/relationships">
+  <c:chart>
+    <c:plotArea>
+      <c:scatterChart>
+        <c:scatterStyle val="lineMarker"/>
+        <c:varyColors val="0"/>
+        <c:ser>
+          <c:idx val="0"/>
+          <c:order val="0"/>
+          <c:tx>
+            <c:strRef>
+              <c:f>Sheet1!$B$1</c:f>
+              <c:strCache>
+                <c:ptCount val="1"/>
+                <c:pt idx="0">
+                  <c:v>1575 nm</c:v>
+                </c:pt>
+              </c:strCache>
+            </c:strRef>
+          </c:tx>
+          <c:spPr>
+            <a:ln w="22225">
+              <a:solidFill>
+                <a:srgbClr val="C0392B"/>
+              </a:solidFill>
+            </a:ln>
+          </c:spPr>
+          <c:marker>
+            <c:symbol val="circle"/>
+            <c:size val="4"/>
+            <c:spPr>
+              <a:solidFill>
+                <a:srgbClr val="C0392B"/>
+              </a:solidFill>
+              <a:ln>
+                <a:solidFill>
+                  <a:srgbClr val="C0392B"/>
+                </a:solidFill>
+              </a:ln>
+            </c:spPr>
+          </c:marker>
+          <c:xVal>
+            <c:numRef>
+              <c:f>Sheet1!$A$2:$A$72</c:f>
+              <c:numCache>
+                <c:formatCode>General</c:formatCode>
+                <c:ptCount val="71"/>
+                <c:pt idx="0">
+                  <c:v>5.45</c:v>
+                </c:pt>
+                <c:pt idx="1">
+                  <c:v>5.55</c:v>
+                </c:pt>
+                <c:pt idx="2">
+                  <c:v>5.65</c:v>
+                </c:pt>
+                <c:pt idx="3">
+                  <c:v>5.75</c:v>
+                </c:pt>
+                <c:pt idx="4">
+                  <c:v>5.85</c:v>
+                </c:pt>
+                <c:pt idx="5">
+                  <c:v>5.95</c:v>
+                </c:pt>
+                <c:pt idx="6">
+                  <c:v>6.05</c:v>
+                </c:pt>
+                <c:pt idx="7">
+                  <c:v>6.15</c:v>
+                </c:pt>
+                <c:pt idx="8">
+                  <c:v>6.25</c:v>
+                </c:pt>
+                <c:pt idx="9">
+                  <c:v>6.35</c:v>
+                </c:pt>
+                <c:pt idx="10">
+                  <c:v>6.45</c:v>
+                </c:pt>
+                <c:pt idx="11">
+                  <c:v>6.55</c:v>
+                </c:pt>
+                <c:pt idx="12">
+                  <c:v>6.65</c:v>
+                </c:pt>
+                <c:pt idx="13">
+                  <c:v>6.75</c:v>
+                </c:pt>
+                <c:pt idx="14">
+                  <c:v>6.85</c:v>
+                </c:pt>
+                <c:pt idx="15">
+                  <c:v>6.95</c:v>
+                </c:pt>
+                <c:pt idx="16">
+                  <c:v>7.05</c:v>
+                </c:pt>
+                <c:pt idx="17">
+                  <c:v>7.15</c:v>
+                </c:pt>
+                <c:pt idx="18">
+                  <c:v>7.25</c:v>
+                </c:pt>
+                <c:pt idx="19">
+                  <c:v>7.35</c:v>
+                </c:pt>
+                <c:pt idx="20">
+                  <c:v>7.45</c:v>
+                </c:pt>
+                <c:pt idx="21">
+                  <c:v>7.55</c:v>
+                </c:pt>
+                <c:pt idx="22">
+                  <c:v>7.65</c:v>
+                </c:pt>
+                <c:pt idx="23">
+                  <c:v>7.75</c:v>
+                </c:pt>
+                <c:pt idx="24">
+                  <c:v>7.85</c:v>
+                </c:pt>
+                <c:pt idx="25">
+                  <c:v>7.95</c:v>
+                </c:pt>
+                <c:pt idx="26">
+                  <c:v>8.05</c:v>
+                </c:pt>
+                <c:pt idx="27">
+                  <c:v>8.15</c:v>
+                </c:pt>
+                <c:pt idx="28">
+                  <c:v>8.25</c:v>
+                </c:pt>
+                <c:pt idx="29">
+                  <c:v>8.35</c:v>
+                </c:pt>
+                <c:pt idx="30">
+                  <c:v>8.45</c:v>
+                </c:pt>
+                <c:pt idx="31">
+                  <c:v>8.55</c:v>
+                </c:pt>
+                <c:pt idx="32">
+                  <c:v>8.65</c:v>
+                </c:pt>
+                <c:pt idx="33">
+                  <c:v>8.75</c:v>
+                </c:pt>
+                <c:pt idx="34">
+                  <c:v>8.85</c:v>
+                </c:pt>
+                <c:pt idx="35">
+                  <c:v>8.95</c:v>
+                </c:pt>
+                <c:pt idx="36">
+                  <c:v>9.05</c:v>
+                </c:pt>
+                <c:pt idx="37">
+                  <c:v>9.15</c:v>
+                </c:pt>
+                <c:pt idx="38">
+                  <c:v>9.25</c:v>
+                </c:pt>
+                <c:pt idx="39">
+                  <c:v>9.35</c:v>
+                </c:pt>
+                <c:pt idx="40">
+                  <c:v>9.45</c:v>
+                </c:pt>
+                <c:pt idx="41">
+                  <c:v>9.55</c:v>
+                </c:pt>
+                <c:pt idx="42">
+                  <c:v>9.65</c:v>
+                </c:pt>
+                <c:pt idx="43">
+                  <c:v>9.75</c:v>
+                </c:pt>
+                <c:pt idx="44">
+                  <c:v>9.85</c:v>
+                </c:pt>
+                <c:pt idx="45">
+                  <c:v>9.95</c:v>
+                </c:pt>
+                <c:pt idx="46">
+                  <c:v>10.05</c:v>
+                </c:pt>
+                <c:pt idx="47">
+                  <c:v>10.15</c:v>
+                </c:pt>
+                <c:pt idx="48">
+                  <c:v>10.25</c:v>
+                </c:pt>
+                <c:pt idx="49">
+                  <c:v>10.35</c:v>
+                </c:pt>
+                <c:pt idx="50">
+                  <c:v>10.45</c:v>
+                </c:pt>
+                <c:pt idx="51">
+                  <c:v>10.55</c:v>
+                </c:pt>
+                <c:pt idx="52">
+                  <c:v>10.65</c:v>
+                </c:pt>
+                <c:pt idx="53">
+                  <c:v>10.75</c:v>
+                </c:pt>
+                <c:pt idx="54">
+                  <c:v>10.85</c:v>
+                </c:pt>
+                <c:pt idx="55">
+                  <c:v>10.95</c:v>
+                </c:pt>
+                <c:pt idx="56">
+                  <c:v>11.05</c:v>
+                </c:pt>
+                <c:pt idx="57">
+                  <c:v>11.15</c:v>
+                </c:pt>
+                <c:pt idx="58">
+                  <c:v>11.25</c:v>
+                </c:pt>
+                <c:pt idx="59">
+                  <c:v>11.35</c:v>
+                </c:pt>
+                <c:pt idx="60">
+                  <c:v>11.45</c:v>
+                </c:pt>
+                <c:pt idx="61">
+                  <c:v>11.55</c:v>
+                </c:pt>
+                <c:pt idx="62">
+                  <c:v>11.65</c:v>
+                </c:pt>
+                <c:pt idx="63">
+                  <c:v>11.75</c:v>
+                </c:pt>
+                <c:pt idx="64">
+                  <c:v>11.85</c:v>
+                </c:pt>
+                <c:pt idx="65">
+                  <c:v>11.95</c:v>
+                </c:pt>
+                <c:pt idx="66">
+                  <c:v>12.05</c:v>
+                </c:pt>
+                <c:pt idx="67">
+                  <c:v>12.15</c:v>
+                </c:pt>
+                <c:pt idx="68">
+                  <c:v>12.25</c:v>
+                </c:pt>
+                <c:pt idx="69">
+                  <c:v>12.35</c:v>
+                </c:pt>
+                <c:pt idx="70">
+                  <c:v>12.45</c:v>
+                </c:pt>
+              </c:numCache>
+            </c:numRef>
+          </c:xVal>
+          <c:yVal>
+            <c:numRef>
+              <c:f>Sheet1!$B$2:$B$72</c:f>
+              <c:numCache>
+                <c:formatCode>General</c:formatCode>
+                <c:ptCount val="71"/>
+                <c:pt idx="0">
+                  <c:v>0.08872534541296766</c:v>
+                </c:pt>
+                <c:pt idx="1">
+                  <c:v>0.05091125228581376</c:v>
+                </c:pt>
+                <c:pt idx="2">
+                  <c:v>0.034449366507472295</c:v>
+                </c:pt>
+                <c:pt idx="3">
+                  <c:v>0.025855998935702004</c:v>
+                </c:pt>
+                <c:pt idx="4">
+                  <c:v>0.02100556675269085</c:v>
+                </c:pt>
+                <c:pt idx="5">
+                  <c:v>0.018231772287063342</c:v>
+                </c:pt>
+                <c:pt idx="6">
+                  <c:v>0.016882978491484048</c:v>
+                </c:pt>
+                <c:pt idx="7">
+                  <c:v>0.016733568307219365</c:v>
+                </c:pt>
+                <c:pt idx="8">
+                  <c:v>0.01783643633994232</c:v>
+                </c:pt>
+                <c:pt idx="9">
+                  <c:v>0.020606503343521286</c:v>
+                </c:pt>
+                <c:pt idx="10">
+                  <c:v>0.02610540183636762</c:v>
+                </c:pt>
+                <c:pt idx="11">
+                  <c:v>0.036460688833222295</c:v>
+                </c:pt>
+                <c:pt idx="12">
+                  <c:v>0.057759383349128425</c:v>
+                </c:pt>
+                <c:pt idx="13">
+                  <c:v>0.10792131654404673</c:v>
+                </c:pt>
+                <c:pt idx="14">
+                  <c:v>0.2593420599041353</c:v>
+                </c:pt>
+                <c:pt idx="15">
+                  <c:v>0.8518568844317698</c:v>
+                </c:pt>
+                <c:pt idx="16">
+                  <c:v>1.029144907307609</c:v>
+                </c:pt>
+                <c:pt idx="17">
+                  <c:v>0.3518612567853239</c:v>
+                </c:pt>
+                <c:pt idx="18">
+                  <c:v>0.15858751889084632</c:v>
+                </c:pt>
+                <c:pt idx="19">
+                  <c:v>0.09192706794247414</c:v>
+                </c:pt>
+                <c:pt idx="20">
+                  <c:v>0.06236795377839927</c:v>
+                </c:pt>
+                <c:pt idx="21">
+                  <c:v>0.046928398906736</c:v>
+                </c:pt>
+                <c:pt idx="22">
+                  <c:v>0.03850081723166634</c:v>
+                </c:pt>
+                <c:pt idx="23">
+                  <c:v>0.03369809968070464</c:v>
+                </c:pt>
+                <c:pt idx="24">
+                  <c:v>0.03144085814594755</c:v>
+                </c:pt>
+                <c:pt idx="25">
+                  <c:v>0.03148258283859044</c:v>
+                </c:pt>
+                <c:pt idx="26">
+                  <c:v>0.03359061077340244</c:v>
+                </c:pt>
+                <c:pt idx="27">
+                  <c:v>0.038542226342439326</c:v>
+                </c:pt>
+                <c:pt idx="28">
+                  <c:v>0.04764055363143606</c:v>
+                </c:pt>
+                <c:pt idx="29">
+                  <c:v>0.06470872276082545</c:v>
+                </c:pt>
+                <c:pt idx="30">
+                  <c:v>0.09768557030919518</c:v>
+                </c:pt>
+                <c:pt idx="31">
+                  <c:v>0.16967640596422848</c:v>
+                </c:pt>
+                <c:pt idx="32">
+                  <c:v>0.3460720567410094</c:v>
+                </c:pt>
+                <c:pt idx="33">
+                  <c:v>0.7261308856555284</c:v>
+                </c:pt>
+                <c:pt idx="34">
+                  <c:v>0.7215694871441569</c:v>
+                </c:pt>
+                <c:pt idx="35">
+                  <c:v>0.36794367439534925</c:v>
+                </c:pt>
+                <c:pt idx="36">
+                  <c:v>0.19560877667044452</c:v>
+                </c:pt>
+                <c:pt idx="37">
+                  <c:v>0.1215277482826157</c:v>
+                </c:pt>
+                <c:pt idx="38">
+                  <c:v>0.08516218504055369</c:v>
+                </c:pt>
+                <c:pt idx="39">
+                  <c:v>0.06568116833992256</c:v>
+                </c:pt>
+                <c:pt idx="40">
+                  <c:v>0.05454747140106628</c:v>
+                </c:pt>
+                <c:pt idx="41">
+                  <c:v>0.048454575529414685</c:v>
+                </c:pt>
+                <c:pt idx="42">
+                  <c:v>0.04582187473697675</c:v>
+                </c:pt>
+                <c:pt idx="43">
+                  <c:v>0.04598893293048975</c:v>
+                </c:pt>
+                <c:pt idx="44">
+                  <c:v>0.049061899634206894</c:v>
+                </c:pt>
+                <c:pt idx="45">
+                  <c:v>0.0561691325984867</c:v>
+                </c:pt>
+                <c:pt idx="46">
+                  <c:v>0.06886767656072448</c:v>
+                </c:pt>
+                <c:pt idx="47">
+                  <c:v>0.0916959697045315</c:v>
+                </c:pt>
+                <c:pt idx="48">
+                  <c:v>0.1348165500023665</c:v>
+                </c:pt>
+                <c:pt idx="49">
+                  <c:v>0.21614990482654733</c:v>
+                </c:pt>
+                <c:pt idx="50">
+                  <c:v>0.37991095016080156</c:v>
+                </c:pt>
+                <c:pt idx="51">
+                  <c:v>0.5967046924289567</c:v>
+                </c:pt>
+                <c:pt idx="52">
+                  <c:v>0.5519200796673431</c:v>
+                </c:pt>
+                <c:pt idx="53">
+                  <c:v>0.3482922751924493</c:v>
+                </c:pt>
+                <c:pt idx="54">
+                  <c:v>0.2151660448905787</c:v>
+                </c:pt>
+                <c:pt idx="55">
+                  <c:v>0.14343771464759553</c:v>
+                </c:pt>
+                <c:pt idx="56">
+                  <c:v>0.10445175139974353</c:v>
+                </c:pt>
+                <c:pt idx="57">
+                  <c:v>0.08214921936967311</c:v>
+                </c:pt>
+                <c:pt idx="58">
+                  <c:v>0.06947065972636988</c:v>
+                </c:pt>
+                <c:pt idx="59">
+                  <c:v>0.0623388775927847</c:v>
+                </c:pt>
+                <c:pt idx="60">
+                  <c:v>0.05938081329876724</c:v>
+                </c:pt>
+                <c:pt idx="61">
+                  <c:v>0.059843365789566214</c:v>
+                </c:pt>
+                <c:pt idx="62">
+                  <c:v>0.0641627201045212</c:v>
+                </c:pt>
+                <c:pt idx="63">
+                  <c:v>0.07293322044854653</c:v>
+                </c:pt>
+                <c:pt idx="64">
+                  <c:v>0.08894376958305936</c:v>
+                </c:pt>
+                <c:pt idx="65">
+                  <c:v>0.11613327129001685</c:v>
+                </c:pt>
+                <c:pt idx="66">
+                  <c:v>0.16332798616880725</c:v>
+                </c:pt>
+                <c:pt idx="67">
+                  <c:v>0.24734891605783446</c:v>
+                </c:pt>
+                <c:pt idx="68">
+                  <c:v>0.377172194417475</c:v>
+                </c:pt>
+                <c:pt idx="69">
+                  <c:v>0.4920545644224204</c:v>
+                </c:pt>
+                <c:pt idx="70">
+                  <c:v>0.4540654849760811</c:v>
+                </c:pt>
+              </c:numCache>
+            </c:numRef>
+          </c:yVal>
+          <c:smooth val="0"/>
+        </c:ser>
+        <c:ser>
+          <c:idx val="1"/>
+          <c:order val="1"/>
+          <c:tx>
+            <c:strRef>
+              <c:f>Sheet1!$B$74</c:f>
+              <c:strCache>
+                <c:ptCount val="1"/>
+                <c:pt idx="0">
+                  <c:v>1525 nm</c:v>
+                </c:pt>
+              </c:strCache>
+            </c:strRef>
+          </c:tx>
+          <c:spPr>
+            <a:ln w="22225">
+              <a:solidFill>
+                <a:srgbClr val="2A78D6"/>
+              </a:solidFill>
+            </a:ln>
+          </c:spPr>
+          <c:marker>
+            <c:symbol val="circle"/>
+            <c:size val="4"/>
+            <c:spPr>
+              <a:solidFill>
+                <a:srgbClr val="2A78D6"/>
+              </a:solidFill>
+              <a:ln>
+                <a:solidFill>
+                  <a:srgbClr val="2A78D6"/>
+                </a:solidFill>
+              </a:ln>
+            </c:spPr>
+          </c:marker>
+          <c:xVal>
+            <c:numRef>
+              <c:f>Sheet1!$A$75:$A$145</c:f>
+              <c:numCache>
+                <c:formatCode>General</c:formatCode>
+                <c:ptCount val="71"/>
+                <c:pt idx="0">
+                  <c:v>5.45</c:v>
+                </c:pt>
+                <c:pt idx="1">
+                  <c:v>5.55</c:v>
+                </c:pt>
+                <c:pt idx="2">
+                  <c:v>5.65</c:v>
+                </c:pt>
+                <c:pt idx="3">
+                  <c:v>5.75</c:v>
+                </c:pt>
+                <c:pt idx="4">
+                  <c:v>5.85</c:v>
+                </c:pt>
+                <c:pt idx="5">
+                  <c:v>5.95</c:v>
+                </c:pt>
+                <c:pt idx="6">
+                  <c:v>6.05</c:v>
+                </c:pt>
+                <c:pt idx="7">
+                  <c:v>6.15</c:v>
+                </c:pt>
+                <c:pt idx="8">
+                  <c:v>6.25</c:v>
+                </c:pt>
+                <c:pt idx="9">
+                  <c:v>6.35</c:v>
+                </c:pt>
+                <c:pt idx="10">
+                  <c:v>6.45</c:v>
+                </c:pt>
+                <c:pt idx="11">
+                  <c:v>6.55</c:v>
+                </c:pt>
+                <c:pt idx="12">
+                  <c:v>6.65</c:v>
+                </c:pt>
+                <c:pt idx="13">
+                  <c:v>6.75</c:v>
+                </c:pt>
+                <c:pt idx="14">
+                  <c:v>6.85</c:v>
+                </c:pt>
+                <c:pt idx="15">
+                  <c:v>6.95</c:v>
+                </c:pt>
+                <c:pt idx="16">
+                  <c:v>7.05</c:v>
+                </c:pt>
+                <c:pt idx="17">
+                  <c:v>7.15</c:v>
+                </c:pt>
+                <c:pt idx="18">
+                  <c:v>7.25</c:v>
+                </c:pt>
+                <c:pt idx="19">
+                  <c:v>7.35</c:v>
+                </c:pt>
+                <c:pt idx="20">
+                  <c:v>7.45</c:v>
+                </c:pt>
+                <c:pt idx="21">
+                  <c:v>7.55</c:v>
+                </c:pt>
+                <c:pt idx="22">
+                  <c:v>7.65</c:v>
+                </c:pt>
+                <c:pt idx="23">
+                  <c:v>7.75</c:v>
+                </c:pt>
+                <c:pt idx="24">
+                  <c:v>7.85</c:v>
+                </c:pt>
+                <c:pt idx="25">
+                  <c:v>7.95</c:v>
+                </c:pt>
+                <c:pt idx="26">
+                  <c:v>8.05</c:v>
+                </c:pt>
+                <c:pt idx="27">
+                  <c:v>8.15</c:v>
+                </c:pt>
+                <c:pt idx="28">
+                  <c:v>8.25</c:v>
+                </c:pt>
+                <c:pt idx="29">
+                  <c:v>8.35</c:v>
+                </c:pt>
+                <c:pt idx="30">
+                  <c:v>8.45</c:v>
+                </c:pt>
+                <c:pt idx="31">
+                  <c:v>8.55</c:v>
+                </c:pt>
+                <c:pt idx="32">
+                  <c:v>8.65</c:v>
+                </c:pt>
+                <c:pt idx="33">
+                  <c:v>8.75</c:v>
+                </c:pt>
+                <c:pt idx="34">
+                  <c:v>8.85</c:v>
+                </c:pt>
+                <c:pt idx="35">
+                  <c:v>8.95</c:v>
+                </c:pt>
+                <c:pt idx="36">
+                  <c:v>9.05</c:v>
+                </c:pt>
+                <c:pt idx="37">
+                  <c:v>9.15</c:v>
+                </c:pt>
+                <c:pt idx="38">
+                  <c:v>9.25</c:v>
+                </c:pt>
+                <c:pt idx="39">
+                  <c:v>9.35</c:v>
+                </c:pt>
+                <c:pt idx="40">
+                  <c:v>9.45</c:v>
+                </c:pt>
+                <c:pt idx="41">
+                  <c:v>9.55</c:v>
+                </c:pt>
+                <c:pt idx="42">
+                  <c:v>9.65</c:v>
+                </c:pt>
+                <c:pt idx="43">
+                  <c:v>9.75</c:v>
+                </c:pt>
+                <c:pt idx="44">
+                  <c:v>9.85</c:v>
+                </c:pt>
+                <c:pt idx="45">
+                  <c:v>9.95</c:v>
+                </c:pt>
+                <c:pt idx="46">
+                  <c:v>10.05</c:v>
+                </c:pt>
+                <c:pt idx="47">
+                  <c:v>10.15</c:v>
+                </c:pt>
+                <c:pt idx="48">
+                  <c:v>10.25</c:v>
+                </c:pt>
+                <c:pt idx="49">
+                  <c:v>10.35</c:v>
+                </c:pt>
+                <c:pt idx="50">
+                  <c:v>10.45</c:v>
+                </c:pt>
+                <c:pt idx="51">
+                  <c:v>10.55</c:v>
+                </c:pt>
+                <c:pt idx="52">
+                  <c:v>10.65</c:v>
+                </c:pt>
+                <c:pt idx="53">
+                  <c:v>10.75</c:v>
+                </c:pt>
+                <c:pt idx="54">
+                  <c:v>10.85</c:v>
+                </c:pt>
+                <c:pt idx="55">
+                  <c:v>10.95</c:v>
+                </c:pt>
+                <c:pt idx="56">
+                  <c:v>11.05</c:v>
+                </c:pt>
+                <c:pt idx="57">
+                  <c:v>11.15</c:v>
+                </c:pt>
+                <c:pt idx="58">
+                  <c:v>11.25</c:v>
+                </c:pt>
+                <c:pt idx="59">
+                  <c:v>11.35</c:v>
+                </c:pt>
+                <c:pt idx="60">
+                  <c:v>11.45</c:v>
+                </c:pt>
+                <c:pt idx="61">
+                  <c:v>11.55</c:v>
+                </c:pt>
+                <c:pt idx="62">
+                  <c:v>11.65</c:v>
+                </c:pt>
+                <c:pt idx="63">
+                  <c:v>11.75</c:v>
+                </c:pt>
+                <c:pt idx="64">
+                  <c:v>11.85</c:v>
+                </c:pt>
+                <c:pt idx="65">
+                  <c:v>11.95</c:v>
+                </c:pt>
+                <c:pt idx="66">
+                  <c:v>12.05</c:v>
+                </c:pt>
+                <c:pt idx="67">
+                  <c:v>12.15</c:v>
+                </c:pt>
+                <c:pt idx="68">
+                  <c:v>12.25</c:v>
+                </c:pt>
+                <c:pt idx="69">
+                  <c:v>12.35</c:v>
+                </c:pt>
+                <c:pt idx="70">
+                  <c:v>12.45</c:v>
+                </c:pt>
+              </c:numCache>
+            </c:numRef>
+          </c:xVal>
+          <c:yVal>
+            <c:numRef>
+              <c:f>Sheet1!$B$75:$B$145</c:f>
+              <c:numCache>
+                <c:formatCode>General</c:formatCode>
+                <c:ptCount val="71"/>
+                <c:pt idx="0">
+                  <c:v>0.03932058062554764</c:v>
+                </c:pt>
+                <c:pt idx="1">
+                  <c:v>0.024433000620674626</c:v>
+                </c:pt>
+                <c:pt idx="2">
+                  <c:v>0.01741497518143272</c:v>
+                </c:pt>
+                <c:pt idx="3">
+                  <c:v>0.013635364605416447</c:v>
+                </c:pt>
+                <c:pt idx="4">
+                  <c:v>0.011550308007481745</c:v>
+                </c:pt>
+                <c:pt idx="5">
+                  <c:v>0.010514145137054565</c:v>
+                </c:pt>
+                <c:pt idx="6">
+                  <c:v>0.010319354551238398</c:v>
+                </c:pt>
+                <c:pt idx="7">
+                  <c:v>0.010993326672265482</c:v>
+                </c:pt>
+                <c:pt idx="8">
+                  <c:v>0.012803283243312667</c:v>
+                </c:pt>
+                <c:pt idx="9">
+                  <c:v>0.01646283989926439</c:v>
+                </c:pt>
+                <c:pt idx="10">
+                  <c:v>0.02383885653781031</c:v>
+                </c:pt>
+                <c:pt idx="11">
+                  <c:v>0.03946452505544354</c:v>
+                </c:pt>
+                <c:pt idx="12">
+                  <c:v>0.08003524954732548</c:v>
+                </c:pt>
+                <c:pt idx="13">
+                  <c:v>0.22116252701636563</c:v>
+                </c:pt>
+                <c:pt idx="14">
+                  <c:v>0.7466341815790882</c:v>
+                </c:pt>
+                <c:pt idx="15">
+                  <c:v>0.417981692639179</c:v>
+                </c:pt>
+                <c:pt idx="16">
+                  <c:v>0.1462375631550864</c:v>
+                </c:pt>
+                <c:pt idx="17">
+                  <c:v>0.07239566781083108</c:v>
+                </c:pt>
+                <c:pt idx="18">
+                  <c:v>0.044769587478217486</c:v>
+                </c:pt>
+                <c:pt idx="19">
+                  <c:v>0.03185909025438282</c:v>
+                </c:pt>
+                <c:pt idx="20">
+                  <c:v>0.02505502366271365</c:v>
+                </c:pt>
+                <c:pt idx="21">
+                  <c:v>0.02131772245185963</c:v>
+                </c:pt>
+                <c:pt idx="22">
+                  <c:v>0.019564810122964446</c:v>
+                </c:pt>
+                <c:pt idx="23">
+                  <c:v>0.019242770848676583</c:v>
+                </c:pt>
+                <c:pt idx="24">
+                  <c:v>0.020459982979236055</c:v>
+                </c:pt>
+                <c:pt idx="25">
+                  <c:v>0.023484969671128057</c:v>
+                </c:pt>
+                <c:pt idx="26">
+                  <c:v>0.029552192760981585</c:v>
+                </c:pt>
+                <c:pt idx="27">
+                  <c:v>0.04117043434553888</c:v>
+                </c:pt>
+                <c:pt idx="28">
+                  <c:v>0.06419511456614671</c:v>
+                </c:pt>
+                <c:pt idx="29">
+                  <c:v>0.11826688884027682</c:v>
+                </c:pt>
+                <c:pt idx="30">
+                  <c:v>0.25924635895799897</c:v>
+                </c:pt>
+                <c:pt idx="31">
+                  <c:v>0.5117404378947565</c:v>
+                </c:pt>
+                <c:pt idx="32">
+                  <c:v>0.3737873806083058</c:v>
+                </c:pt>
+                <c:pt idx="33">
+                  <c:v>0.1753709252050042</c:v>
+                </c:pt>
+                <c:pt idx="34">
+                  <c:v>0.09626702712692477</c:v>
+                </c:pt>
+                <c:pt idx="35">
+                  <c:v>0.06184698462070722</c:v>
+                </c:pt>
+                <c:pt idx="36">
+                  <c:v>0.044865485930191545</c:v>
+                </c:pt>
+                <c:pt idx="37">
+                  <c:v>0.03574878568098939</c:v>
+                </c:pt>
+                <c:pt idx="38">
+                  <c:v>0.030755176064026397</c:v>
+                </c:pt>
+                <c:pt idx="39">
+                  <c:v>0.028386823992982188</c:v>
+                </c:pt>
+                <c:pt idx="40">
+                  <c:v>0.02803483340299516</c:v>
+                </c:pt>
+                <c:pt idx="41">
+                  <c:v>0.029675204406928654</c:v>
+                </c:pt>
+                <c:pt idx="42">
+                  <c:v>0.03379782264048058</c:v>
+                </c:pt>
+                <c:pt idx="43">
+                  <c:v>0.04190860587656529</c:v>
+                </c:pt>
+                <c:pt idx="44">
+                  <c:v>0.056451679771187396</c:v>
+                </c:pt>
+                <c:pt idx="45">
+                  <c:v>0.08544505597309618</c:v>
+                </c:pt>
+                <c:pt idx="46">
+                  <c:v>0.14360546422938456</c:v>
+                </c:pt>
+                <c:pt idx="47">
+                  <c:v>0.2617194281894804</c:v>
+                </c:pt>
+                <c:pt idx="48">
+                  <c:v>0.3910418550792821</c:v>
+                </c:pt>
+                <c:pt idx="49">
+                  <c:v>0.31641020546839</c:v>
+                </c:pt>
+                <c:pt idx="50">
+                  <c:v>0.1845528307166586</c:v>
+                </c:pt>
+                <c:pt idx="51">
+                  <c:v>0.1109127592726066</c:v>
+                </c:pt>
+                <c:pt idx="52">
+                  <c:v>0.07512308615300416</c:v>
+                </c:pt>
+                <c:pt idx="53">
+                  <c:v>0.05616659218342761</c:v>
+                </c:pt>
+                <c:pt idx="54">
+                  <c:v>0.045643277899773516</c:v>
+                </c:pt>
+                <c:pt idx="55">
+                  <c:v>0.03972193535674862</c:v>
+                </c:pt>
+                <c:pt idx="56">
+                  <c:v>0.0368507050088838</c:v>
+                </c:pt>
+                <c:pt idx="57">
+                  <c:v>0.03652460162402475</c:v>
+                </c:pt>
+                <c:pt idx="58">
+                  <c:v>0.038742015007195825</c:v>
+                </c:pt>
+                <c:pt idx="59">
+                  <c:v>0.04370860192704556</c:v>
+                </c:pt>
+                <c:pt idx="60">
+                  <c:v>0.05319184611310472</c:v>
+                </c:pt>
+                <c:pt idx="61">
+                  <c:v>0.06977004169257599</c:v>
+                </c:pt>
+                <c:pt idx="62">
+                  <c:v>0.10097518503716527</c:v>
+                </c:pt>
+                <c:pt idx="63">
+                  <c:v>0.15677747163279443</c:v>
+                </c:pt>
+                <c:pt idx="64">
+                  <c:v>0.24697822653697124</c:v>
+                </c:pt>
+                <c:pt idx="65">
+                  <c:v>0.3163713496365366</c:v>
+                </c:pt>
+                <c:pt idx="66">
+                  <c:v>0.27134943154441865</c:v>
+                </c:pt>
+                <c:pt idx="67">
+                  <c:v>0.18230404735390415</c:v>
+                </c:pt>
+                <c:pt idx="68">
+                  <c:v>0.12069973696583831</c:v>
+                </c:pt>
+                <c:pt idx="69">
+                  <c:v>0.08576416657992599</c:v>
+                </c:pt>
+                <c:pt idx="70">
+                  <c:v>0.06586091047662662</c:v>
+                </c:pt>
+              </c:numCache>
+            </c:numRef>
+          </c:yVal>
+          <c:smooth val="0"/>
+        </c:ser>
+        <c:ser>
+          <c:idx val="2"/>
+          <c:order val="2"/>
+          <c:tx>
+            <c:strRef>
+              <c:f>Sheet1!$B$147</c:f>
+              <c:strCache>
+                <c:ptCount val="1"/>
+                <c:pt idx="0">
+                  <c:v>1625 nm</c:v>
+                </c:pt>
+              </c:strCache>
+            </c:strRef>
+          </c:tx>
+          <c:spPr>
+            <a:ln w="22225">
+              <a:solidFill>
+                <a:srgbClr val="1B9E77"/>
+              </a:solidFill>
+            </a:ln>
+          </c:spPr>
+          <c:marker>
+            <c:symbol val="circle"/>
+            <c:size val="4"/>
+            <c:spPr>
+              <a:solidFill>
+                <a:srgbClr val="1B9E77"/>
+              </a:solidFill>
+              <a:ln>
+                <a:solidFill>
+                  <a:srgbClr val="1B9E77"/>
+                </a:solidFill>
+              </a:ln>
+            </c:spPr>
+          </c:marker>
+          <c:xVal>
+            <c:numRef>
+              <c:f>Sheet1!$A$148:$A$218</c:f>
+              <c:numCache>
+                <c:formatCode>General</c:formatCode>
+                <c:ptCount val="71"/>
+                <c:pt idx="0">
+                  <c:v>5.45</c:v>
+                </c:pt>
+                <c:pt idx="1">
+                  <c:v>5.55</c:v>
+                </c:pt>
+                <c:pt idx="2">
+                  <c:v>5.65</c:v>
+                </c:pt>
+                <c:pt idx="3">
+                  <c:v>5.75</c:v>
+                </c:pt>
+                <c:pt idx="4">
+                  <c:v>5.85</c:v>
+                </c:pt>
+                <c:pt idx="5">
+                  <c:v>5.95</c:v>
+                </c:pt>
+                <c:pt idx="6">
+                  <c:v>6.05</c:v>
+                </c:pt>
+                <c:pt idx="7">
+                  <c:v>6.15</c:v>
+                </c:pt>
+                <c:pt idx="8">
+                  <c:v>6.25</c:v>
+                </c:pt>
+                <c:pt idx="9">
+                  <c:v>6.35</c:v>
+                </c:pt>
+                <c:pt idx="10">
+                  <c:v>6.45</c:v>
+                </c:pt>
+                <c:pt idx="11">
+                  <c:v>6.55</c:v>
+                </c:pt>
+                <c:pt idx="12">
+                  <c:v>6.65</c:v>
+                </c:pt>
+                <c:pt idx="13">
+                  <c:v>6.75</c:v>
+                </c:pt>
+                <c:pt idx="14">
+                  <c:v>6.85</c:v>
+                </c:pt>
+                <c:pt idx="15">
+                  <c:v>6.95</c:v>
+                </c:pt>
+                <c:pt idx="16">
+                  <c:v>7.05</c:v>
+                </c:pt>
+                <c:pt idx="17">
+                  <c:v>7.15</c:v>
+                </c:pt>
+                <c:pt idx="18">
+                  <c:v>7.25</c:v>
+                </c:pt>
+                <c:pt idx="19">
+                  <c:v>7.35</c:v>
+                </c:pt>
+                <c:pt idx="20">
+                  <c:v>7.45</c:v>
+                </c:pt>
+                <c:pt idx="21">
+                  <c:v>7.55</c:v>
+                </c:pt>
+                <c:pt idx="22">
+                  <c:v>7.65</c:v>
+                </c:pt>
+                <c:pt idx="23">
+                  <c:v>7.75</c:v>
+                </c:pt>
+                <c:pt idx="24">
+                  <c:v>7.85</c:v>
+                </c:pt>
+                <c:pt idx="25">
+                  <c:v>7.95</c:v>
+                </c:pt>
+                <c:pt idx="26">
+                  <c:v>8.05</c:v>
+                </c:pt>
+                <c:pt idx="27">
+                  <c:v>8.15</c:v>
+                </c:pt>
+                <c:pt idx="28">
+                  <c:v>8.25</c:v>
+                </c:pt>
+                <c:pt idx="29">
+                  <c:v>8.35</c:v>
+                </c:pt>
+                <c:pt idx="30">
+                  <c:v>8.45</c:v>
+                </c:pt>
+                <c:pt idx="31">
+                  <c:v>8.55</c:v>
+                </c:pt>
+                <c:pt idx="32">
+                  <c:v>8.65</c:v>
+                </c:pt>
+                <c:pt idx="33">
+                  <c:v>8.75</c:v>
+                </c:pt>
+                <c:pt idx="34">
+                  <c:v>8.85</c:v>
+                </c:pt>
+                <c:pt idx="35">
+                  <c:v>8.95</c:v>
+                </c:pt>
+                <c:pt idx="36">
+                  <c:v>9.05</c:v>
+                </c:pt>
+                <c:pt idx="37">
+                  <c:v>9.15</c:v>
+                </c:pt>
+                <c:pt idx="38">
+                  <c:v>9.25</c:v>
+                </c:pt>
+                <c:pt idx="39">
+                  <c:v>9.35</c:v>
+                </c:pt>
+                <c:pt idx="40">
+                  <c:v>9.45</c:v>
+                </c:pt>
+                <c:pt idx="41">
+                  <c:v>9.55</c:v>
+                </c:pt>
+                <c:pt idx="42">
+                  <c:v>9.65</c:v>
+                </c:pt>
+                <c:pt idx="43">
+                  <c:v>9.75</c:v>
+                </c:pt>
+                <c:pt idx="44">
+                  <c:v>9.85</c:v>
+                </c:pt>
+                <c:pt idx="45">
+                  <c:v>9.95</c:v>
+                </c:pt>
+                <c:pt idx="46">
+                  <c:v>10.05</c:v>
+                </c:pt>
+                <c:pt idx="47">
+                  <c:v>10.15</c:v>
+                </c:pt>
+                <c:pt idx="48">
+                  <c:v>10.25</c:v>
+                </c:pt>
+                <c:pt idx="49">
+                  <c:v>10.35</c:v>
+                </c:pt>
+                <c:pt idx="50">
+                  <c:v>10.45</c:v>
+                </c:pt>
+                <c:pt idx="51">
+                  <c:v>10.55</c:v>
+                </c:pt>
+                <c:pt idx="52">
+                  <c:v>10.65</c:v>
+                </c:pt>
+                <c:pt idx="53">
+                  <c:v>10.75</c:v>
+                </c:pt>
+                <c:pt idx="54">
+                  <c:v>10.85</c:v>
+                </c:pt>
+                <c:pt idx="55">
+                  <c:v>10.95</c:v>
+                </c:pt>
+                <c:pt idx="56">
+                  <c:v>11.05</c:v>
+                </c:pt>
+                <c:pt idx="57">
+                  <c:v>11.15</c:v>
+                </c:pt>
+                <c:pt idx="58">
+                  <c:v>11.25</c:v>
+                </c:pt>
+                <c:pt idx="59">
+                  <c:v>11.35</c:v>
+                </c:pt>
+                <c:pt idx="60">
+                  <c:v>11.45</c:v>
+                </c:pt>
+                <c:pt idx="61">
+                  <c:v>11.55</c:v>
+                </c:pt>
+                <c:pt idx="62">
+                  <c:v>11.65</c:v>
+                </c:pt>
+                <c:pt idx="63">
+                  <c:v>11.75</c:v>
+                </c:pt>
+                <c:pt idx="64">
+                  <c:v>11.85</c:v>
+                </c:pt>
+                <c:pt idx="65">
+                  <c:v>11.95</c:v>
+                </c:pt>
+                <c:pt idx="66">
+                  <c:v>12.05</c:v>
+                </c:pt>
+                <c:pt idx="67">
+                  <c:v>12.15</c:v>
+                </c:pt>
+                <c:pt idx="68">
+                  <c:v>12.25</c:v>
+                </c:pt>
+                <c:pt idx="69">
+                  <c:v>12.35</c:v>
+                </c:pt>
+                <c:pt idx="70">
+                  <c:v>12.45</c:v>
+                </c:pt>
+              </c:numCache>
+            </c:numRef>
+          </c:xVal>
+          <c:yVal>
+            <c:numRef>
+              <c:f>Sheet1!$B$148:$B$218</c:f>
+              <c:numCache>
+                <c:formatCode>General</c:formatCode>
+                <c:ptCount val="71"/>
+                <c:pt idx="0">
+                  <c:v>0.21550404131595224</c:v>
+                </c:pt>
+                <c:pt idx="1">
+                  <c:v>0.11118522018203494</c:v>
+                </c:pt>
+                <c:pt idx="2">
+                  <c:v>0.07069097381748071</c:v>
+                </c:pt>
+                <c:pt idx="3">
+                  <c:v>0.050728902167220535</c:v>
+                </c:pt>
+                <c:pt idx="4">
+                  <c:v>0.03962991713501587</c:v>
+                </c:pt>
+                <c:pt idx="5">
+                  <c:v>0.03303482480250699</c:v>
+                </c:pt>
+                <c:pt idx="6">
+                  <c:v>0.02919859969035338</c:v>
+                </c:pt>
+                <c:pt idx="7">
+                  <c:v>0.02734642869100147</c:v>
+                </c:pt>
+                <c:pt idx="8">
+                  <c:v>0.027188563896339734</c:v>
+                </c:pt>
+                <c:pt idx="9">
+                  <c:v>0.028866554842099056</c:v>
+                </c:pt>
+                <c:pt idx="10">
+                  <c:v>0.032975820375187787</c:v>
+                </c:pt>
+                <c:pt idx="11">
+                  <c:v>0.04069230108260972</c:v>
+                </c:pt>
+                <c:pt idx="12">
+                  <c:v>0.05497869406904249</c:v>
+                </c:pt>
+                <c:pt idx="13">
+                  <c:v>0.08263888229918223</c:v>
+                </c:pt>
+                <c:pt idx="14">
+                  <c:v>0.14253853804948877</c:v>
+                </c:pt>
+                <c:pt idx="15">
+                  <c:v>0.2986461035325525</c:v>
+                </c:pt>
+                <c:pt idx="16">
+                  <c:v>0.8216106650867232</c:v>
+                </c:pt>
+                <c:pt idx="17">
+                  <c:v>1.9493076760685966</c:v>
+                </c:pt>
+                <c:pt idx="18">
+                  <c:v>0.9422659539586705</c:v>
+                </c:pt>
+                <c:pt idx="19">
+                  <c:v>0.38117059418157767</c:v>
+                </c:pt>
+                <c:pt idx="20">
+                  <c:v>0.20263497511820414</c:v>
+                </c:pt>
+                <c:pt idx="21">
+                  <c:v>0.12868801851436099</c:v>
+                </c:pt>
+                <c:pt idx="22">
+                  <c:v>0.09283734059453481</c:v>
+                </c:pt>
+                <c:pt idx="23">
+                  <c:v>0.07252809520965016</c:v>
+                </c:pt>
+                <c:pt idx="24">
+                  <c:v>0.06044944293050771</c:v>
+                </c:pt>
+                <c:pt idx="25">
+                  <c:v>0.05439734396923516</c:v>
+                </c:pt>
+                <c:pt idx="26">
+                  <c:v>0.05131099464022048</c:v>
+                </c:pt>
+                <c:pt idx="27">
+                  <c:v>0.051345465758618</c:v>
+                </c:pt>
+                <c:pt idx="28">
+                  <c:v>0.05451953764613033</c:v>
+                </c:pt>
+                <c:pt idx="29">
+                  <c:v>0.0616641764470348</c:v>
+                </c:pt>
+                <c:pt idx="30">
+                  <c:v>0.07465933030938657</c:v>
+                </c:pt>
+                <c:pt idx="31">
+                  <c:v>0.09802338270829226</c:v>
+                </c:pt>
+                <c:pt idx="32">
+                  <c:v>0.1411838207079126</c:v>
+                </c:pt>
+                <c:pt idx="33">
+                  <c:v>0.23009737361434973</c:v>
+                </c:pt>
+                <c:pt idx="34">
+                  <c:v>0.4251929532617942</c:v>
+                </c:pt>
+                <c:pt idx="35">
+                  <c:v>0.8689967609556218</c:v>
+                </c:pt>
+                <c:pt idx="36">
+                  <c:v>1.2586897486250004</c:v>
+                </c:pt>
+                <c:pt idx="37">
+                  <c:v>0.8247470619310181</c:v>
+                </c:pt>
+                <c:pt idx="38">
+                  <c:v>0.4359950799514714</c:v>
+                </c:pt>
+                <c:pt idx="39">
+                  <c:v>0.2584879286554182</c:v>
+                </c:pt>
+                <c:pt idx="40">
+                  <c:v>0.17274296839984096</c:v>
+                </c:pt>
+                <c:pt idx="41">
+                  <c:v>0.12771969123950297</c:v>
+                </c:pt>
+                <c:pt idx="42">
+                  <c:v>0.10227959508926686</c:v>
+                </c:pt>
+                <c:pt idx="43">
+                  <c:v>0.08688973768324691</c:v>
+                </c:pt>
+                <c:pt idx="44">
+                  <c:v>0.07840328398198429</c:v>
+                </c:pt>
+                <c:pt idx="45">
+                  <c:v>0.07465187449591597</c:v>
+                </c:pt>
+                <c:pt idx="46">
+                  <c:v>0.07508463652706368</c:v>
+                </c:pt>
+                <c:pt idx="47">
+                  <c:v>0.07976670877203607</c:v>
+                </c:pt>
+                <c:pt idx="48">
+                  <c:v>0.08998652868974202</c:v>
+                </c:pt>
+                <c:pt idx="49">
+                  <c:v>0.10760975668678192</c:v>
+                </c:pt>
+                <c:pt idx="50">
+                  <c:v>0.13911235542058947</c:v>
+                </c:pt>
+                <c:pt idx="51">
+                  <c:v>0.19697388285818285</c:v>
+                </c:pt>
+                <c:pt idx="52">
+                  <c:v>0.29955241922430026</c:v>
+                </c:pt>
+                <c:pt idx="53">
+                  <c:v>0.49212525165692866</c:v>
+                </c:pt>
+                <c:pt idx="54">
+                  <c:v>0.7849149579353183</c:v>
+                </c:pt>
+                <c:pt idx="55">
+                  <c:v>0.9368036281680263</c:v>
+                </c:pt>
+                <c:pt idx="56">
+                  <c:v>0.7112422336217163</c:v>
+                </c:pt>
+                <c:pt idx="57">
+                  <c:v>0.44748721712590084</c:v>
+                </c:pt>
+                <c:pt idx="58">
+                  <c:v>0.2918213492509532</c:v>
+                </c:pt>
+                <c:pt idx="59">
+                  <c:v>0.20569329704936756</c:v>
+                </c:pt>
+                <c:pt idx="60">
+                  <c:v>0.15688301154225093</c:v>
+                </c:pt>
+                <c:pt idx="61">
+                  <c:v>0.12830546149249772</c:v>
+                </c:pt>
+                <c:pt idx="62">
+                  <c:v>0.1106724927106576</c:v>
+                </c:pt>
+                <c:pt idx="63">
+                  <c:v>0.10057335502541564</c:v>
+                </c:pt>
+                <c:pt idx="64">
+                  <c:v>0.0968102046884514</c:v>
+                </c:pt>
+                <c:pt idx="65">
+                  <c:v>0.09787070718602667</c:v>
+                </c:pt>
+                <c:pt idx="66">
+                  <c:v>0.10408476293894958</c:v>
+                </c:pt>
+                <c:pt idx="67">
+                  <c:v>0.11713484884774962</c:v>
+                </c:pt>
+                <c:pt idx="68">
+                  <c:v>0.1394316327050688</c:v>
+                </c:pt>
+                <c:pt idx="69">
+                  <c:v>0.176412482804103</c:v>
+                </c:pt>
+                <c:pt idx="70">
+                  <c:v>0.23906221473502004</c:v>
+                </c:pt>
+              </c:numCache>
+            </c:numRef>
+          </c:yVal>
+          <c:smooth val="0"/>
+        </c:ser>
+        <c:ser>
+          <c:idx val="3"/>
+          <c:order val="3"/>
+          <c:tx>
+            <c:strRef>
+              <c:f>Sheet1!$B$220</c:f>
+              <c:strCache>
+                <c:ptCount val="1"/>
+                <c:pt idx="0">
+                  <c:v>Nominal 10.15 µm</c:v>
+                </c:pt>
+              </c:strCache>
+            </c:strRef>
+          </c:tx>
+          <c:spPr>
+            <a:ln w="19050">
+              <a:solidFill>
+                <a:srgbClr val="1F4E79"/>
+              </a:solidFill>
+              <a:prstDash val="dash"/>
+            </a:ln>
+          </c:spPr>
+          <c:marker>
+            <c:symbol val="none"/>
+          </c:marker>
+          <c:xVal>
+            <c:numRef>
+              <c:f>Sheet1!$A$221:$A$222</c:f>
+              <c:numCache>
+                <c:formatCode>General</c:formatCode>
+                <c:ptCount val="2"/>
+                <c:pt idx="0">
+                  <c:v>10.15</c:v>
+                </c:pt>
+                <c:pt idx="1">
+                  <c:v>10.15</c:v>
+                </c:pt>
+              </c:numCache>
+            </c:numRef>
+          </c:xVal>
+          <c:yVal>
+            <c:numRef>
+              <c:f>Sheet1!$B$221:$B$222</c:f>
+              <c:numCache>
+                <c:formatCode>General</c:formatCode>
+                <c:ptCount val="2"/>
+                <c:pt idx="0">
+                  <c:v>0</c:v>
+                </c:pt>
+                <c:pt idx="1">
+                  <c:v>2.0</c:v>
+                </c:pt>
+              </c:numCache>
+            </c:numRef>
+          </c:yVal>
+          <c:smooth val="0"/>
+        </c:ser>
+        <c:axId val="-2128940872"/>
+        <c:axId val="-2129643912"/>
+      </c:scatterChart>
+      <c:valAx>
+        <c:axId val="-2128940872"/>
+        <c:scaling>
+          <c:orientation val="minMax"/>
+          <c:max val="13.0"/>
+          <c:min val="5.0"/>
+        </c:scaling>
+        <c:delete val="0"/>
+        <c:axPos val="b"/>
+        <c:title>
+          <c:tx>
+            <c:rich>
+              <a:bodyPr/>
+              <a:lstStyle/>
+              <a:p>
+                <a:r>
+                  <a:rPr sz="1100" b="0">
+                    <a:latin typeface="Arial"/>
+                  </a:rPr>
+                  <a:t>Slab width (µm)</a:t>
+                </a:r>
+              </a:p>
+            </c:rich>
+          </c:tx>
+          <c:layout/>
+          <c:overlay val="0"/>
+        </c:title>
+        <c:numFmt formatCode="General" sourceLinked="1"/>
+        <c:majorTickMark val="out"/>
+        <c:minorTickMark val="none"/>
+        <c:tickLblPos val="nextTo"/>
+        <c:txPr>
+          <a:bodyPr/>
+          <a:lstStyle/>
+          <a:p>
+            <a:pPr>
+              <a:defRPr sz="1000">
+                <a:latin typeface="Arial"/>
+              </a:defRPr>
+            </a:pPr>
+          </a:p>
+        </c:txPr>
+        <c:crossAx val="-2129643912"/>
+        <c:crosses val="autoZero"/>
+        <c:crossBetween val="midCat"/>
+        <c:majorUnit val="1.0"/>
+      </c:valAx>
+      <c:valAx>
+        <c:axId val="-2129643912"/>
+        <c:scaling>
+          <c:orientation val="minMax"/>
+          <c:max val="2.0"/>
+          <c:min val="0.0"/>
+        </c:scaling>
+        <c:delete val="0"/>
+        <c:axPos val="l"/>
+        <c:majorGridlines>
+          <c:spPr>
+            <a:ln>
+              <a:solidFill>
+                <a:srgbClr val="E3E3E3"/>
+              </a:solidFill>
+            </a:ln>
+          </c:spPr>
+        </c:majorGridlines>
+        <c:title>
+          <c:tx>
+            <c:rich>
+              <a:bodyPr/>
+              <a:lstStyle/>
+              <a:p>
+                <a:r>
+                  <a:rPr sz="1100" b="0">
+                    <a:latin typeface="Arial"/>
+                  </a:rPr>
+                  <a:t>Insertion loss (dB/cm)</a:t>
+                </a:r>
+              </a:p>
+            </c:rich>
+          </c:tx>
+          <c:layout/>
+          <c:overlay val="0"/>
+        </c:title>
+        <c:numFmt formatCode="General" sourceLinked="0"/>
+        <c:majorTickMark val="out"/>
+        <c:minorTickMark val="none"/>
+        <c:tickLblPos val="nextTo"/>
+        <c:txPr>
+          <a:bodyPr/>
+          <a:lstStyle/>
+          <a:p>
+            <a:pPr>
+              <a:defRPr sz="1000">
+                <a:latin typeface="Arial"/>
+              </a:defRPr>
+            </a:pPr>
+          </a:p>
+        </c:txPr>
+        <c:crossAx val="-2128940872"/>
+        <c:crosses val="autoZero"/>
+        <c:crossBetween val="midCat"/>
+        <c:majorUnit val="0.2"/>
+      </c:valAx>
+    </c:plotArea>
+    <c:legend>
+      <c:legendPos val="t"/>
+      <c:layout/>
+      <c:overlay val="0"/>
+      <c:txPr>
+        <a:bodyPr/>
+        <a:lstStyle/>
+        <a:p>
+          <a:pPr>
+            <a:defRPr sz="1000">
+              <a:latin typeface="Arial"/>
+            </a:defRPr>
+          </a:pPr>
+        </a:p>
+      </c:txPr>
+    </c:legend>
+    <c:plotVisOnly val="1"/>
+    <c:dispBlanksAs val="gap"/>
+    <c:showDLblsOverMax val="0"/>
+  </c:chart>
+  <c:txPr>
+    <a:bodyPr/>
+    <a:lstStyle/>
+    <a:p>
+      <a:pPr>
+        <a:defRPr sz="1800"/>
+      </a:pPr>
+      <a:endParaRPr lang="en-US"/>
+    </a:p>
+  </c:txPr>
+  <c:externalData r:id="rId1">
+    <c:autoUpdate val="0"/>
+  </c:externalData>
+</c:chartSpace>
+</file>
+
+<file path=ppt/charts/chart20.xml><?xml version="1.0" encoding="utf-8"?>
+<c:chartSpace xmlns:c="http://schemas.openxmlformats.org/drawingml/2006/chart" xmlns:a="http://schemas.openxmlformats.org/drawingml/2006/main" xmlns:r="http://schemas.openxmlformats.org/officeDocument/2006/relationships">
+  <c:chart>
+    <c:plotArea>
+      <c:scatterChart>
+        <c:scatterStyle val="lineMarker"/>
+        <c:varyColors val="0"/>
+        <c:ser>
+          <c:idx val="0"/>
+          <c:order val="0"/>
+          <c:tx>
+            <c:strRef>
+              <c:f>Sheet1!$B$1</c:f>
+              <c:strCache>
+                <c:ptCount val="1"/>
+                <c:pt idx="0">
+                  <c:v>Vπ·L</c:v>
+                </c:pt>
+              </c:strCache>
+            </c:strRef>
+          </c:tx>
+          <c:spPr>
+            <a:ln w="25400">
+              <a:solidFill>
+                <a:srgbClr val="1F4E79"/>
+              </a:solidFill>
+            </a:ln>
+          </c:spPr>
+          <c:marker>
+            <c:symbol val="circle"/>
+            <c:size val="6"/>
+            <c:spPr>
+              <a:solidFill>
+                <a:srgbClr val="1F4E79"/>
+              </a:solidFill>
+              <a:ln>
+                <a:solidFill>
+                  <a:srgbClr val="1F4E79"/>
+                </a:solidFill>
+              </a:ln>
+            </c:spPr>
+          </c:marker>
+          <c:xVal>
+            <c:numRef>
+              <c:f>Sheet1!$A$2:$A$9</c:f>
+              <c:numCache>
+                <c:formatCode>General</c:formatCode>
+                <c:ptCount val="8"/>
+                <c:pt idx="0">
+                  <c:v>3.55</c:v>
+                </c:pt>
+                <c:pt idx="1">
+                  <c:v>3.6</c:v>
+                </c:pt>
+                <c:pt idx="2">
+                  <c:v>3.65</c:v>
+                </c:pt>
+                <c:pt idx="3">
+                  <c:v>3.7</c:v>
+                </c:pt>
+                <c:pt idx="4">
+                  <c:v>3.75</c:v>
+                </c:pt>
+                <c:pt idx="5">
+                  <c:v>3.85</c:v>
+                </c:pt>
+                <c:pt idx="6">
+                  <c:v>4.15</c:v>
+                </c:pt>
+                <c:pt idx="7">
+                  <c:v>4.45</c:v>
+                </c:pt>
+              </c:numCache>
+            </c:numRef>
+          </c:xVal>
+          <c:yVal>
+            <c:numRef>
+              <c:f>Sheet1!$B$2:$B$9</c:f>
+              <c:numCache>
+                <c:formatCode>General</c:formatCode>
+                <c:ptCount val="8"/>
+                <c:pt idx="0">
+                  <c:v>2.3631382435978754</c:v>
+                </c:pt>
+                <c:pt idx="1">
+                  <c:v>2.393407459935598</c:v>
+                </c:pt>
+                <c:pt idx="2">
+                  <c:v>2.4237411404223774</c:v>
+                </c:pt>
+                <c:pt idx="3">
+                  <c:v>2.4539199780698255</c:v>
+                </c:pt>
+                <c:pt idx="4">
+                  <c:v>2.4841069556580027</c:v>
+                </c:pt>
+                <c:pt idx="5">
+                  <c:v>2.5443552763058435</c:v>
+                </c:pt>
+                <c:pt idx="6">
+                  <c:v>2.724421562984533</c:v>
+                </c:pt>
+                <c:pt idx="7">
+                  <c:v>2.9038109780497776</c:v>
+                </c:pt>
+              </c:numCache>
+            </c:numRef>
+          </c:yVal>
+          <c:smooth val="0"/>
+        </c:ser>
+        <c:ser>
+          <c:idx val="1"/>
+          <c:order val="1"/>
+          <c:tx>
+            <c:strRef>
+              <c:f>Sheet1!$B$11</c:f>
+              <c:strCache>
+                <c:ptCount val="1"/>
+                <c:pt idx="0">
+                  <c:v>No buffer, 4.45 µm</c:v>
+                </c:pt>
+              </c:strCache>
+            </c:strRef>
+          </c:tx>
+          <c:spPr>
+            <a:ln w="19050">
+              <a:solidFill>
+                <a:srgbClr val="C0392B"/>
+              </a:solidFill>
+              <a:prstDash val="dash"/>
+            </a:ln>
+          </c:spPr>
+          <c:marker>
+            <c:symbol val="none"/>
+          </c:marker>
+          <c:xVal>
+            <c:numRef>
+              <c:f>Sheet1!$A$12:$A$13</c:f>
+              <c:numCache>
+                <c:formatCode>General</c:formatCode>
+                <c:ptCount val="2"/>
+                <c:pt idx="0">
+                  <c:v>3.5</c:v>
+                </c:pt>
+                <c:pt idx="1">
+                  <c:v>4.5</c:v>
+                </c:pt>
+              </c:numCache>
+            </c:numRef>
+          </c:xVal>
+          <c:yVal>
+            <c:numRef>
+              <c:f>Sheet1!$B$12:$B$13</c:f>
+              <c:numCache>
+                <c:formatCode>General</c:formatCode>
+                <c:ptCount val="2"/>
+                <c:pt idx="0">
+                  <c:v>2.4215</c:v>
+                </c:pt>
+                <c:pt idx="1">
+                  <c:v>2.4215</c:v>
+                </c:pt>
+              </c:numCache>
+            </c:numRef>
+          </c:yVal>
+          <c:smooth val="0"/>
+        </c:ser>
+        <c:axId val="-2128940872"/>
+        <c:axId val="-2129643912"/>
+      </c:scatterChart>
+      <c:valAx>
+        <c:axId val="-2128940872"/>
+        <c:scaling>
+          <c:orientation val="minMax"/>
+          <c:max val="4.5"/>
+          <c:min val="3.5"/>
+        </c:scaling>
+        <c:delete val="0"/>
+        <c:axPos val="b"/>
+        <c:title>
+          <c:tx>
+            <c:rich>
+              <a:bodyPr/>
+              <a:lstStyle/>
+              <a:p>
+                <a:r>
+                  <a:rPr sz="1100" b="0">
+                    <a:latin typeface="Arial"/>
+                  </a:rPr>
+                  <a:t>Gap on the buffer (µm)</a:t>
+                </a:r>
+              </a:p>
+            </c:rich>
+          </c:tx>
+          <c:layout/>
+          <c:overlay val="0"/>
+        </c:title>
+        <c:numFmt formatCode="General" sourceLinked="1"/>
+        <c:majorTickMark val="out"/>
+        <c:minorTickMark val="none"/>
+        <c:tickLblPos val="nextTo"/>
+        <c:txPr>
+          <a:bodyPr/>
+          <a:lstStyle/>
+          <a:p>
+            <a:pPr>
+              <a:defRPr sz="1000">
+                <a:latin typeface="Arial"/>
+              </a:defRPr>
+            </a:pPr>
+          </a:p>
+        </c:txPr>
+        <c:crossAx val="-2129643912"/>
+        <c:crosses val="autoZero"/>
+        <c:crossBetween val="midCat"/>
+        <c:majorUnit val="0.2"/>
+      </c:valAx>
+      <c:valAx>
+        <c:axId val="-2129643912"/>
+        <c:scaling>
+          <c:orientation val="minMax"/>
+          <c:max val="3.0"/>
+          <c:min val="2.3"/>
+        </c:scaling>
+        <c:delete val="0"/>
+        <c:axPos val="l"/>
+        <c:majorGridlines>
+          <c:spPr>
+            <a:ln>
+              <a:solidFill>
+                <a:srgbClr val="E3E3E3"/>
+              </a:solidFill>
+            </a:ln>
+          </c:spPr>
+        </c:majorGridlines>
+        <c:title>
+          <c:tx>
+            <c:rich>
+              <a:bodyPr/>
+              <a:lstStyle/>
+              <a:p>
+                <a:r>
+                  <a:rPr sz="1100" b="0">
+                    <a:latin typeface="Arial"/>
+                  </a:rPr>
+                  <a:t>Vπ·L (V·cm)</a:t>
+                </a:r>
+              </a:p>
+            </c:rich>
+          </c:tx>
+          <c:layout/>
+          <c:overlay val="0"/>
+        </c:title>
+        <c:numFmt formatCode="General" sourceLinked="0"/>
+        <c:majorTickMark val="out"/>
+        <c:minorTickMark val="none"/>
+        <c:tickLblPos val="nextTo"/>
+        <c:txPr>
+          <a:bodyPr/>
+          <a:lstStyle/>
+          <a:p>
+            <a:pPr>
+              <a:defRPr sz="1000">
+                <a:latin typeface="Arial"/>
+              </a:defRPr>
+            </a:pPr>
+          </a:p>
+        </c:txPr>
+        <c:crossAx val="-2128940872"/>
+        <c:crosses val="autoZero"/>
+        <c:crossBetween val="midCat"/>
+        <c:majorUnit val="0.1"/>
+      </c:valAx>
+    </c:plotArea>
+    <c:legend>
+      <c:legendPos val="t"/>
+      <c:layout/>
+      <c:overlay val="0"/>
+      <c:txPr>
+        <a:bodyPr/>
+        <a:lstStyle/>
+        <a:p>
+          <a:pPr>
+            <a:defRPr sz="1000">
+              <a:latin typeface="Arial"/>
+            </a:defRPr>
+          </a:pPr>
+        </a:p>
+      </c:txPr>
+    </c:legend>
+    <c:plotVisOnly val="1"/>
+    <c:dispBlanksAs val="gap"/>
+    <c:showDLblsOverMax val="0"/>
+  </c:chart>
+  <c:txPr>
+    <a:bodyPr/>
+    <a:lstStyle/>
+    <a:p>
+      <a:pPr>
+        <a:defRPr sz="1800"/>
+      </a:pPr>
+      <a:endParaRPr lang="en-US"/>
+    </a:p>
+  </c:txPr>
+  <c:externalData r:id="rId1">
+    <c:autoUpdate val="0"/>
+  </c:externalData>
+</c:chartSpace>
+</file>
+
+<file path=ppt/charts/chart21.xml><?xml version="1.0" encoding="utf-8"?>
+<c:chartSpace xmlns:c="http://schemas.openxmlformats.org/drawingml/2006/chart" xmlns:a="http://schemas.openxmlformats.org/drawingml/2006/main" xmlns:r="http://schemas.openxmlformats.org/officeDocument/2006/relationships">
+  <c:chart>
+    <c:plotArea>
+      <c:scatterChart>
+        <c:scatterStyle val="lineMarker"/>
+        <c:varyColors val="0"/>
+        <c:ser>
+          <c:idx val="0"/>
+          <c:order val="0"/>
+          <c:tx>
+            <c:strRef>
+              <c:f>Sheet1!$B$1</c:f>
+              <c:strCache>
+                <c:ptCount val="1"/>
+                <c:pt idx="0">
+                  <c:v>No buffer, gap 4.45 µm</c:v>
+                </c:pt>
+              </c:strCache>
+            </c:strRef>
+          </c:tx>
+          <c:spPr>
+            <a:ln w="22225">
+              <a:solidFill>
+                <a:srgbClr val="C0392B"/>
+              </a:solidFill>
+            </a:ln>
+          </c:spPr>
+          <c:marker>
+            <c:symbol val="circle"/>
+            <c:size val="4"/>
+            <c:spPr>
+              <a:solidFill>
+                <a:srgbClr val="C0392B"/>
+              </a:solidFill>
+              <a:ln>
+                <a:solidFill>
+                  <a:srgbClr val="C0392B"/>
+                </a:solidFill>
+              </a:ln>
+            </c:spPr>
+          </c:marker>
+          <c:xVal>
+            <c:numRef>
+              <c:f>Sheet1!$A$2:$A$72</c:f>
+              <c:numCache>
+                <c:formatCode>General</c:formatCode>
+                <c:ptCount val="71"/>
+                <c:pt idx="0">
+                  <c:v>5.45</c:v>
+                </c:pt>
+                <c:pt idx="1">
+                  <c:v>5.55</c:v>
+                </c:pt>
+                <c:pt idx="2">
+                  <c:v>5.65</c:v>
+                </c:pt>
+                <c:pt idx="3">
+                  <c:v>5.75</c:v>
+                </c:pt>
+                <c:pt idx="4">
+                  <c:v>5.85</c:v>
+                </c:pt>
+                <c:pt idx="5">
+                  <c:v>5.95</c:v>
+                </c:pt>
+                <c:pt idx="6">
+                  <c:v>6.05</c:v>
+                </c:pt>
+                <c:pt idx="7">
+                  <c:v>6.15</c:v>
+                </c:pt>
+                <c:pt idx="8">
+                  <c:v>6.25</c:v>
+                </c:pt>
+                <c:pt idx="9">
+                  <c:v>6.35</c:v>
+                </c:pt>
+                <c:pt idx="10">
+                  <c:v>6.45</c:v>
+                </c:pt>
+                <c:pt idx="11">
+                  <c:v>6.55</c:v>
+                </c:pt>
+                <c:pt idx="12">
+                  <c:v>6.65</c:v>
+                </c:pt>
+                <c:pt idx="13">
+                  <c:v>6.75</c:v>
+                </c:pt>
+                <c:pt idx="14">
+                  <c:v>6.85</c:v>
+                </c:pt>
+                <c:pt idx="15">
+                  <c:v>6.95</c:v>
+                </c:pt>
+                <c:pt idx="16">
+                  <c:v>7.05</c:v>
+                </c:pt>
+                <c:pt idx="17">
+                  <c:v>7.15</c:v>
+                </c:pt>
+                <c:pt idx="18">
+                  <c:v>7.25</c:v>
+                </c:pt>
+                <c:pt idx="19">
+                  <c:v>7.35</c:v>
+                </c:pt>
+                <c:pt idx="20">
+                  <c:v>7.45</c:v>
+                </c:pt>
+                <c:pt idx="21">
+                  <c:v>7.55</c:v>
+                </c:pt>
+                <c:pt idx="22">
+                  <c:v>7.65</c:v>
+                </c:pt>
+                <c:pt idx="23">
+                  <c:v>7.75</c:v>
+                </c:pt>
+                <c:pt idx="24">
+                  <c:v>7.85</c:v>
+                </c:pt>
+                <c:pt idx="25">
+                  <c:v>7.95</c:v>
+                </c:pt>
+                <c:pt idx="26">
+                  <c:v>8.05</c:v>
+                </c:pt>
+                <c:pt idx="27">
+                  <c:v>8.15</c:v>
+                </c:pt>
+                <c:pt idx="28">
+                  <c:v>8.25</c:v>
+                </c:pt>
+                <c:pt idx="29">
+                  <c:v>8.35</c:v>
+                </c:pt>
+                <c:pt idx="30">
+                  <c:v>8.45</c:v>
+                </c:pt>
+                <c:pt idx="31">
+                  <c:v>8.55</c:v>
+                </c:pt>
+                <c:pt idx="32">
+                  <c:v>8.65</c:v>
+                </c:pt>
+                <c:pt idx="33">
+                  <c:v>8.75</c:v>
+                </c:pt>
+                <c:pt idx="34">
+                  <c:v>8.85</c:v>
+                </c:pt>
+                <c:pt idx="35">
+                  <c:v>8.95</c:v>
+                </c:pt>
+                <c:pt idx="36">
+                  <c:v>9.05</c:v>
+                </c:pt>
+                <c:pt idx="37">
+                  <c:v>9.15</c:v>
+                </c:pt>
+                <c:pt idx="38">
+                  <c:v>9.25</c:v>
+                </c:pt>
+                <c:pt idx="39">
+                  <c:v>9.35</c:v>
+                </c:pt>
+                <c:pt idx="40">
+                  <c:v>9.45</c:v>
+                </c:pt>
+                <c:pt idx="41">
+                  <c:v>9.55</c:v>
+                </c:pt>
+                <c:pt idx="42">
+                  <c:v>9.65</c:v>
+                </c:pt>
+                <c:pt idx="43">
+                  <c:v>9.75</c:v>
+                </c:pt>
+                <c:pt idx="44">
+                  <c:v>9.85</c:v>
+                </c:pt>
+                <c:pt idx="45">
+                  <c:v>9.95</c:v>
+                </c:pt>
+                <c:pt idx="46">
+                  <c:v>10.05</c:v>
+                </c:pt>
+                <c:pt idx="47">
+                  <c:v>10.15</c:v>
+                </c:pt>
+                <c:pt idx="48">
+                  <c:v>10.25</c:v>
+                </c:pt>
+                <c:pt idx="49">
+                  <c:v>10.35</c:v>
+                </c:pt>
+                <c:pt idx="50">
+                  <c:v>10.45</c:v>
+                </c:pt>
+                <c:pt idx="51">
+                  <c:v>10.55</c:v>
+                </c:pt>
+                <c:pt idx="52">
+                  <c:v>10.65</c:v>
+                </c:pt>
+                <c:pt idx="53">
+                  <c:v>10.75</c:v>
+                </c:pt>
+                <c:pt idx="54">
+                  <c:v>10.85</c:v>
+                </c:pt>
+                <c:pt idx="55">
+                  <c:v>10.95</c:v>
+                </c:pt>
+                <c:pt idx="56">
+                  <c:v>11.05</c:v>
+                </c:pt>
+                <c:pt idx="57">
+                  <c:v>11.15</c:v>
+                </c:pt>
+                <c:pt idx="58">
+                  <c:v>11.25</c:v>
+                </c:pt>
+                <c:pt idx="59">
+                  <c:v>11.35</c:v>
+                </c:pt>
+                <c:pt idx="60">
+                  <c:v>11.45</c:v>
+                </c:pt>
+                <c:pt idx="61">
+                  <c:v>11.55</c:v>
+                </c:pt>
+                <c:pt idx="62">
+                  <c:v>11.65</c:v>
+                </c:pt>
+                <c:pt idx="63">
+                  <c:v>11.75</c:v>
+                </c:pt>
+                <c:pt idx="64">
+                  <c:v>11.85</c:v>
+                </c:pt>
+                <c:pt idx="65">
+                  <c:v>11.95</c:v>
+                </c:pt>
+                <c:pt idx="66">
+                  <c:v>12.05</c:v>
+                </c:pt>
+                <c:pt idx="67">
+                  <c:v>12.15</c:v>
+                </c:pt>
+                <c:pt idx="68">
+                  <c:v>12.25</c:v>
+                </c:pt>
+                <c:pt idx="69">
+                  <c:v>12.35</c:v>
+                </c:pt>
+                <c:pt idx="70">
+                  <c:v>12.45</c:v>
+                </c:pt>
+              </c:numCache>
+            </c:numRef>
+          </c:xVal>
+          <c:yVal>
+            <c:numRef>
+              <c:f>Sheet1!$B$2:$B$72</c:f>
+              <c:numCache>
+                <c:formatCode>General</c:formatCode>
+                <c:ptCount val="71"/>
+                <c:pt idx="0">
+                  <c:v>0.08872534541296766</c:v>
+                </c:pt>
+                <c:pt idx="1">
+                  <c:v>0.05091125228581376</c:v>
+                </c:pt>
+                <c:pt idx="2">
+                  <c:v>0.034449366507472295</c:v>
+                </c:pt>
+                <c:pt idx="3">
+                  <c:v>0.025855998935702004</c:v>
+                </c:pt>
+                <c:pt idx="4">
+                  <c:v>0.02100556675269085</c:v>
+                </c:pt>
+                <c:pt idx="5">
+                  <c:v>0.018231772287063342</c:v>
+                </c:pt>
+                <c:pt idx="6">
+                  <c:v>0.016882978491484048</c:v>
+                </c:pt>
+                <c:pt idx="7">
+                  <c:v>0.016733568307219365</c:v>
+                </c:pt>
+                <c:pt idx="8">
+                  <c:v>0.01783643633994232</c:v>
+                </c:pt>
+                <c:pt idx="9">
+                  <c:v>0.020606503343521286</c:v>
+                </c:pt>
+                <c:pt idx="10">
+                  <c:v>0.02610540183636762</c:v>
+                </c:pt>
+                <c:pt idx="11">
+                  <c:v>0.036460688833222295</c:v>
+                </c:pt>
+                <c:pt idx="12">
+                  <c:v>0.057759383349128425</c:v>
+                </c:pt>
+                <c:pt idx="13">
+                  <c:v>0.10792131654404673</c:v>
+                </c:pt>
+                <c:pt idx="14">
+                  <c:v>0.2593420599041353</c:v>
+                </c:pt>
+                <c:pt idx="15">
+                  <c:v>0.8518568844317698</c:v>
+                </c:pt>
+                <c:pt idx="16">
+                  <c:v>1.029144907307609</c:v>
+                </c:pt>
+                <c:pt idx="17">
+                  <c:v>0.3518612567853239</c:v>
+                </c:pt>
+                <c:pt idx="18">
+                  <c:v>0.15858751889084632</c:v>
+                </c:pt>
+                <c:pt idx="19">
+                  <c:v>0.09192706794247414</c:v>
+                </c:pt>
+                <c:pt idx="20">
+                  <c:v>0.06236795377839927</c:v>
+                </c:pt>
+                <c:pt idx="21">
+                  <c:v>0.046928398906736</c:v>
+                </c:pt>
+                <c:pt idx="22">
+                  <c:v>0.03850081723166634</c:v>
+                </c:pt>
+                <c:pt idx="23">
+                  <c:v>0.03369809968070464</c:v>
+                </c:pt>
+                <c:pt idx="24">
+                  <c:v>0.03144085814594755</c:v>
+                </c:pt>
+                <c:pt idx="25">
+                  <c:v>0.03148258283859044</c:v>
+                </c:pt>
+                <c:pt idx="26">
+                  <c:v>0.03359061077340244</c:v>
+                </c:pt>
+                <c:pt idx="27">
+                  <c:v>0.038542226342439326</c:v>
+                </c:pt>
+                <c:pt idx="28">
+                  <c:v>0.04764055363143606</c:v>
+                </c:pt>
+                <c:pt idx="29">
+                  <c:v>0.06470872276082545</c:v>
+                </c:pt>
+                <c:pt idx="30">
+                  <c:v>0.09768557030919518</c:v>
+                </c:pt>
+                <c:pt idx="31">
+                  <c:v>0.16967640596422848</c:v>
+                </c:pt>
+                <c:pt idx="32">
+                  <c:v>0.3460720567410094</c:v>
+                </c:pt>
+                <c:pt idx="33">
+                  <c:v>0.7261308856555284</c:v>
+                </c:pt>
+                <c:pt idx="34">
+                  <c:v>0.7215694871441569</c:v>
+                </c:pt>
+                <c:pt idx="35">
+                  <c:v>0.36794367439534925</c:v>
+                </c:pt>
+                <c:pt idx="36">
+                  <c:v>0.19560877667044452</c:v>
+                </c:pt>
+                <c:pt idx="37">
+                  <c:v>0.1215277482826157</c:v>
+                </c:pt>
+                <c:pt idx="38">
+                  <c:v>0.08516218504055369</c:v>
+                </c:pt>
+                <c:pt idx="39">
+                  <c:v>0.06568116833992256</c:v>
+                </c:pt>
+                <c:pt idx="40">
+                  <c:v>0.05454747140106628</c:v>
+                </c:pt>
+                <c:pt idx="41">
+                  <c:v>0.048454575529414685</c:v>
+                </c:pt>
+                <c:pt idx="42">
+                  <c:v>0.04582187473697675</c:v>
+                </c:pt>
+                <c:pt idx="43">
+                  <c:v>0.04598893293048975</c:v>
+                </c:pt>
+                <c:pt idx="44">
+                  <c:v>0.049061899634206894</c:v>
+                </c:pt>
+                <c:pt idx="45">
+                  <c:v>0.0561691325984867</c:v>
+                </c:pt>
+                <c:pt idx="46">
+                  <c:v>0.06886767656072448</c:v>
+                </c:pt>
+                <c:pt idx="47">
+                  <c:v>0.0916959697045315</c:v>
+                </c:pt>
+                <c:pt idx="48">
+                  <c:v>0.1348165500023665</c:v>
+                </c:pt>
+                <c:pt idx="49">
+                  <c:v>0.21614990482654733</c:v>
+                </c:pt>
+                <c:pt idx="50">
+                  <c:v>0.37991095016080156</c:v>
+                </c:pt>
+                <c:pt idx="51">
+                  <c:v>0.5967046924289567</c:v>
+                </c:pt>
+                <c:pt idx="52">
+                  <c:v>0.5519200796673431</c:v>
+                </c:pt>
+                <c:pt idx="53">
+                  <c:v>0.3482922751924493</c:v>
+                </c:pt>
+                <c:pt idx="54">
+                  <c:v>0.2151660448905787</c:v>
+                </c:pt>
+                <c:pt idx="55">
+                  <c:v>0.14343771464759553</c:v>
+                </c:pt>
+                <c:pt idx="56">
+                  <c:v>0.10445175139974353</c:v>
+                </c:pt>
+                <c:pt idx="57">
+                  <c:v>0.08214921936967311</c:v>
+                </c:pt>
+                <c:pt idx="58">
+                  <c:v>0.06947065972636988</c:v>
+                </c:pt>
+                <c:pt idx="59">
+                  <c:v>0.0623388775927847</c:v>
+                </c:pt>
+                <c:pt idx="60">
+                  <c:v>0.05938081329876724</c:v>
+                </c:pt>
+                <c:pt idx="61">
+                  <c:v>0.059843365789566214</c:v>
+                </c:pt>
+                <c:pt idx="62">
+                  <c:v>0.0641627201045212</c:v>
+                </c:pt>
+                <c:pt idx="63">
+                  <c:v>0.07293322044854653</c:v>
+                </c:pt>
+                <c:pt idx="64">
+                  <c:v>0.08894376958305936</c:v>
+                </c:pt>
+                <c:pt idx="65">
+                  <c:v>0.11613327129001685</c:v>
+                </c:pt>
+                <c:pt idx="66">
+                  <c:v>0.16332798616880725</c:v>
+                </c:pt>
+                <c:pt idx="67">
+                  <c:v>0.24734891605783446</c:v>
+                </c:pt>
+                <c:pt idx="68">
+                  <c:v>0.377172194417475</c:v>
+                </c:pt>
+                <c:pt idx="69">
+                  <c:v>0.4920545644224204</c:v>
+                </c:pt>
+                <c:pt idx="70">
+                  <c:v>0.4540654849760811</c:v>
+                </c:pt>
+              </c:numCache>
+            </c:numRef>
+          </c:yVal>
+          <c:smooth val="0"/>
+        </c:ser>
+        <c:ser>
+          <c:idx val="1"/>
+          <c:order val="1"/>
+          <c:tx>
+            <c:strRef>
+              <c:f>Sheet1!$B$74</c:f>
+              <c:strCache>
+                <c:ptCount val="1"/>
+                <c:pt idx="0">
+                  <c:v>200 nm buffer, gap 3.65 µm</c:v>
+                </c:pt>
+              </c:strCache>
+            </c:strRef>
+          </c:tx>
+          <c:spPr>
+            <a:ln w="25400">
+              <a:solidFill>
+                <a:srgbClr val="1B9E77"/>
+              </a:solidFill>
+            </a:ln>
+          </c:spPr>
+          <c:marker>
+            <c:symbol val="circle"/>
+            <c:size val="4"/>
+            <c:spPr>
+              <a:solidFill>
+                <a:srgbClr val="1B9E77"/>
+              </a:solidFill>
+              <a:ln>
+                <a:solidFill>
+                  <a:srgbClr val="1B9E77"/>
+                </a:solidFill>
+              </a:ln>
+            </c:spPr>
+          </c:marker>
+          <c:xVal>
+            <c:numRef>
+              <c:f>Sheet1!$A$75:$A$145</c:f>
+              <c:numCache>
+                <c:formatCode>General</c:formatCode>
+                <c:ptCount val="71"/>
+                <c:pt idx="0">
+                  <c:v>5.45</c:v>
+                </c:pt>
+                <c:pt idx="1">
+                  <c:v>5.55</c:v>
+                </c:pt>
+                <c:pt idx="2">
+                  <c:v>5.65</c:v>
+                </c:pt>
+                <c:pt idx="3">
+                  <c:v>5.75</c:v>
+                </c:pt>
+                <c:pt idx="4">
+                  <c:v>5.85</c:v>
+                </c:pt>
+                <c:pt idx="5">
+                  <c:v>5.95</c:v>
+                </c:pt>
+                <c:pt idx="6">
+                  <c:v>6.05</c:v>
+                </c:pt>
+                <c:pt idx="7">
+                  <c:v>6.15</c:v>
+                </c:pt>
+                <c:pt idx="8">
+                  <c:v>6.25</c:v>
+                </c:pt>
+                <c:pt idx="9">
+                  <c:v>6.35</c:v>
+                </c:pt>
+                <c:pt idx="10">
+                  <c:v>6.45</c:v>
+                </c:pt>
+                <c:pt idx="11">
+                  <c:v>6.55</c:v>
+                </c:pt>
+                <c:pt idx="12">
+                  <c:v>6.65</c:v>
+                </c:pt>
+                <c:pt idx="13">
+                  <c:v>6.75</c:v>
+                </c:pt>
+                <c:pt idx="14">
+                  <c:v>6.85</c:v>
+                </c:pt>
+                <c:pt idx="15">
+                  <c:v>6.95</c:v>
+                </c:pt>
+                <c:pt idx="16">
+                  <c:v>7.05</c:v>
+                </c:pt>
+                <c:pt idx="17">
+                  <c:v>7.15</c:v>
+                </c:pt>
+                <c:pt idx="18">
+                  <c:v>7.25</c:v>
+                </c:pt>
+                <c:pt idx="19">
+                  <c:v>7.35</c:v>
+                </c:pt>
+                <c:pt idx="20">
+                  <c:v>7.45</c:v>
+                </c:pt>
+                <c:pt idx="21">
+                  <c:v>7.55</c:v>
+                </c:pt>
+                <c:pt idx="22">
+                  <c:v>7.65</c:v>
+                </c:pt>
+                <c:pt idx="23">
+                  <c:v>7.75</c:v>
+                </c:pt>
+                <c:pt idx="24">
+                  <c:v>7.85</c:v>
+                </c:pt>
+                <c:pt idx="25">
+                  <c:v>7.95</c:v>
+                </c:pt>
+                <c:pt idx="26">
+                  <c:v>8.05</c:v>
+                </c:pt>
+                <c:pt idx="27">
+                  <c:v>8.15</c:v>
+                </c:pt>
+                <c:pt idx="28">
+                  <c:v>8.25</c:v>
+                </c:pt>
+                <c:pt idx="29">
+                  <c:v>8.35</c:v>
+                </c:pt>
+                <c:pt idx="30">
+                  <c:v>8.45</c:v>
+                </c:pt>
+                <c:pt idx="31">
+                  <c:v>8.55</c:v>
+                </c:pt>
+                <c:pt idx="32">
+                  <c:v>8.65</c:v>
+                </c:pt>
+                <c:pt idx="33">
+                  <c:v>8.75</c:v>
+                </c:pt>
+                <c:pt idx="34">
+                  <c:v>8.85</c:v>
+                </c:pt>
+                <c:pt idx="35">
+                  <c:v>8.95</c:v>
+                </c:pt>
+                <c:pt idx="36">
+                  <c:v>9.05</c:v>
+                </c:pt>
+                <c:pt idx="37">
+                  <c:v>9.15</c:v>
+                </c:pt>
+                <c:pt idx="38">
+                  <c:v>9.25</c:v>
+                </c:pt>
+                <c:pt idx="39">
+                  <c:v>9.35</c:v>
+                </c:pt>
+                <c:pt idx="40">
+                  <c:v>9.45</c:v>
+                </c:pt>
+                <c:pt idx="41">
+                  <c:v>9.55</c:v>
+                </c:pt>
+                <c:pt idx="42">
+                  <c:v>9.65</c:v>
+                </c:pt>
+                <c:pt idx="43">
+                  <c:v>9.75</c:v>
+                </c:pt>
+                <c:pt idx="44">
+                  <c:v>9.85</c:v>
+                </c:pt>
+                <c:pt idx="45">
+                  <c:v>9.95</c:v>
+                </c:pt>
+                <c:pt idx="46">
+                  <c:v>10.05</c:v>
+                </c:pt>
+                <c:pt idx="47">
+                  <c:v>10.15</c:v>
+                </c:pt>
+                <c:pt idx="48">
+                  <c:v>10.25</c:v>
+                </c:pt>
+                <c:pt idx="49">
+                  <c:v>10.35</c:v>
+                </c:pt>
+                <c:pt idx="50">
+                  <c:v>10.45</c:v>
+                </c:pt>
+                <c:pt idx="51">
+                  <c:v>10.55</c:v>
+                </c:pt>
+                <c:pt idx="52">
+                  <c:v>10.65</c:v>
+                </c:pt>
+                <c:pt idx="53">
+                  <c:v>10.75</c:v>
+                </c:pt>
+                <c:pt idx="54">
+                  <c:v>10.85</c:v>
+                </c:pt>
+                <c:pt idx="55">
+                  <c:v>10.95</c:v>
+                </c:pt>
+                <c:pt idx="56">
+                  <c:v>11.05</c:v>
+                </c:pt>
+                <c:pt idx="57">
+                  <c:v>11.15</c:v>
+                </c:pt>
+                <c:pt idx="58">
+                  <c:v>11.25</c:v>
+                </c:pt>
+                <c:pt idx="59">
+                  <c:v>11.35</c:v>
+                </c:pt>
+                <c:pt idx="60">
+                  <c:v>11.45</c:v>
+                </c:pt>
+                <c:pt idx="61">
+                  <c:v>11.55</c:v>
+                </c:pt>
+                <c:pt idx="62">
+                  <c:v>11.65</c:v>
+                </c:pt>
+                <c:pt idx="63">
+                  <c:v>11.75</c:v>
+                </c:pt>
+                <c:pt idx="64">
+                  <c:v>11.85</c:v>
+                </c:pt>
+                <c:pt idx="65">
+                  <c:v>11.95</c:v>
+                </c:pt>
+                <c:pt idx="66">
+                  <c:v>12.05</c:v>
+                </c:pt>
+                <c:pt idx="67">
+                  <c:v>12.15</c:v>
+                </c:pt>
+                <c:pt idx="68">
+                  <c:v>12.25</c:v>
+                </c:pt>
+                <c:pt idx="69">
+                  <c:v>12.35</c:v>
+                </c:pt>
+                <c:pt idx="70">
+                  <c:v>12.45</c:v>
+                </c:pt>
+              </c:numCache>
+            </c:numRef>
+          </c:xVal>
+          <c:yVal>
+            <c:numRef>
+              <c:f>Sheet1!$B$75:$B$145</c:f>
+              <c:numCache>
+                <c:formatCode>General</c:formatCode>
+                <c:ptCount val="71"/>
+                <c:pt idx="0">
+                  <c:v>0.012533401493706953</c:v>
+                </c:pt>
+                <c:pt idx="1">
+                  <c:v>0.012549975242859003</c:v>
+                </c:pt>
+                <c:pt idx="2">
+                  <c:v>0.012573592116541766</c:v>
+                </c:pt>
+                <c:pt idx="3">
+                  <c:v>0.012584995804366299</c:v>
+                </c:pt>
+                <c:pt idx="4">
+                  <c:v>0.01258920242879591</c:v>
+                </c:pt>
+                <c:pt idx="5">
+                  <c:v>0.012591536492718764</c:v>
+                </c:pt>
+                <c:pt idx="6">
+                  <c:v>0.012596368885707395</c:v>
+                </c:pt>
+                <c:pt idx="7">
+                  <c:v>0.012605305582450805</c:v>
+                </c:pt>
+                <c:pt idx="8">
+                  <c:v>0.01260596959393052</c:v>
+                </c:pt>
+                <c:pt idx="9">
+                  <c:v>0.012609193173297601</c:v>
+                </c:pt>
+                <c:pt idx="10">
+                  <c:v>0.012608830085399177</c:v>
+                </c:pt>
+                <c:pt idx="11">
+                  <c:v>0.012614852842458352</c:v>
+                </c:pt>
+                <c:pt idx="12">
+                  <c:v>0.012616201440342591</c:v>
+                </c:pt>
+                <c:pt idx="13">
+                  <c:v>0.012618275684046935</c:v>
+                </c:pt>
+                <c:pt idx="14">
+                  <c:v>0.012620525559773322</c:v>
+                </c:pt>
+                <c:pt idx="15">
+                  <c:v>0.012608347793794519</c:v>
+                </c:pt>
+                <c:pt idx="16">
+                  <c:v>0.012606825997410304</c:v>
+                </c:pt>
+                <c:pt idx="17">
+                  <c:v>0.012609238962220628</c:v>
+                </c:pt>
+                <c:pt idx="18">
+                  <c:v>0.012611990728408781</c:v>
+                </c:pt>
+                <c:pt idx="19">
+                  <c:v>0.012612622200352213</c:v>
+                </c:pt>
+                <c:pt idx="20">
+                  <c:v>0.012613287093751977</c:v>
+                </c:pt>
+                <c:pt idx="21">
+                  <c:v>0.012612826327777106</c:v>
+                </c:pt>
+                <c:pt idx="22">
+                  <c:v>0.012619055810941535</c:v>
+                </c:pt>
+                <c:pt idx="23">
+                  <c:v>0.012623911887969854</c:v>
+                </c:pt>
+                <c:pt idx="24">
+                  <c:v>0.012611875068806797</c:v>
+                </c:pt>
+                <c:pt idx="25">
+                  <c:v>0.012614652117491465</c:v>
+                </c:pt>
+                <c:pt idx="26">
+                  <c:v>0.012622309846586235</c:v>
+                </c:pt>
+                <c:pt idx="27">
+                  <c:v>0.012621561159058358</c:v>
+                </c:pt>
+                <c:pt idx="28">
+                  <c:v>0.012612858845635087</c:v>
+                </c:pt>
+                <c:pt idx="29">
+                  <c:v>0.012612505838464436</c:v>
+                </c:pt>
+                <c:pt idx="30">
+                  <c:v>0.01261294479487928</c:v>
+                </c:pt>
+                <c:pt idx="31">
+                  <c:v>0.01262389266152046</c:v>
+                </c:pt>
+                <c:pt idx="32">
+                  <c:v>0.0126238555345207</c:v>
+                </c:pt>
+                <c:pt idx="33">
+                  <c:v>0.01260924757449251</c:v>
+                </c:pt>
+                <c:pt idx="34">
+                  <c:v>0.012608460733785888</c:v>
+                </c:pt>
+                <c:pt idx="35">
+                  <c:v>0.012611083393006048</c:v>
+                </c:pt>
+                <c:pt idx="36">
+                  <c:v>0.012611554352727093</c:v>
+                </c:pt>
+                <c:pt idx="37">
+                  <c:v>0.012610278922183199</c:v>
+                </c:pt>
+                <c:pt idx="38">
+                  <c:v>0.01260992955451049</c:v>
+                </c:pt>
+                <c:pt idx="39">
+                  <c:v>0.01261049305619125</c:v>
+                </c:pt>
+                <c:pt idx="40">
+                  <c:v>0.012611563074886535</c:v>
+                </c:pt>
+                <c:pt idx="41">
+                  <c:v>0.012612030667047424</c:v>
+                </c:pt>
+                <c:pt idx="42">
+                  <c:v>0.012607153811989562</c:v>
+                </c:pt>
+                <c:pt idx="43">
+                  <c:v>0.012605996243686008</c:v>
+                </c:pt>
+                <c:pt idx="44">
+                  <c:v>0.012611218083743601</c:v>
+                </c:pt>
+                <c:pt idx="45">
+                  <c:v>0.012611192296854437</c:v>
+                </c:pt>
+                <c:pt idx="46">
+                  <c:v>0.012609709699470718</c:v>
+                </c:pt>
+                <c:pt idx="47">
+                  <c:v>0.012609931064318463</c:v>
+                </c:pt>
+                <c:pt idx="48">
+                  <c:v>0.012608948458021114</c:v>
+                </c:pt>
+                <c:pt idx="49">
+                  <c:v>0.012609711837243007</c:v>
+                </c:pt>
+                <c:pt idx="50">
+                  <c:v>0.01261135747831697</c:v>
+                </c:pt>
+                <c:pt idx="51">
+                  <c:v>0.012609552513740858</c:v>
+                </c:pt>
+                <c:pt idx="52">
+                  <c:v>0.012608115390466022</c:v>
+                </c:pt>
+                <c:pt idx="53">
+                  <c:v>0.012610054443887114</c:v>
+                </c:pt>
+                <c:pt idx="54">
+                  <c:v>0.012610585919438635</c:v>
+                </c:pt>
+                <c:pt idx="55">
+                  <c:v>0.012610713958320578</c:v>
+                </c:pt>
+                <c:pt idx="56">
+                  <c:v>0.012611026183559679</c:v>
+                </c:pt>
+                <c:pt idx="57">
+                  <c:v>0.012611064106558195</c:v>
+                </c:pt>
+                <c:pt idx="58">
+                  <c:v>0.012611642545840695</c:v>
+                </c:pt>
+                <c:pt idx="59">
+                  <c:v>0.012612159721812944</c:v>
+                </c:pt>
+                <c:pt idx="60">
+                  <c:v>0.012610147310083912</c:v>
+                </c:pt>
+                <c:pt idx="61">
+                  <c:v>0.012610520120633304</c:v>
+                </c:pt>
+                <c:pt idx="62">
+                  <c:v>0.01261191496248544</c:v>
+                </c:pt>
+                <c:pt idx="63">
+                  <c:v>0.012609389118221093</c:v>
+                </c:pt>
+                <c:pt idx="64">
+                  <c:v>0.012606159636517025</c:v>
+                </c:pt>
+                <c:pt idx="65">
+                  <c:v>0.01261039007654997</c:v>
+                </c:pt>
+                <c:pt idx="66">
+                  <c:v>0.012609926472885176</c:v>
+                </c:pt>
+                <c:pt idx="67">
+                  <c:v>0.012612507626281291</c:v>
+                </c:pt>
+                <c:pt idx="68">
+                  <c:v>0.012612490856857238</c:v>
+                </c:pt>
+                <c:pt idx="69">
+                  <c:v>0.012609465083620845</c:v>
+                </c:pt>
+                <c:pt idx="70">
+                  <c:v>0.012609680293614627</c:v>
                 </c:pt>
               </c:numCache>
             </c:numRef>
@@ -6143,6 +9218,1821 @@
                 <a:latin typeface="Arial"/>
               </a:rPr>
               <a:t>Peaks 1.03 / 0.73 / 0.60 dB/cm, troughs 0.02–0.06 dB/cm: the nominal sits on the rising edge of a peak. Slab-edge offsets of a few hundred nm can explain the scattered loop IL measurements.</a:t>
+            </a:r>
+          </a:p>
+        </p:txBody>
+      </p:sp>
+    </p:spTree>
+  </p:cSld>
+  <p:clrMapOvr>
+    <a:masterClrMapping/>
+  </p:clrMapOvr>
+</p:sld>
+</file>
+
+<file path=ppt/slides/slide23.xml><?xml version="1.0" encoding="utf-8"?>
+<p:sld xmlns:a="http://schemas.openxmlformats.org/drawingml/2006/main" xmlns:p="http://schemas.openxmlformats.org/presentationml/2006/main" xmlns:r="http://schemas.openxmlformats.org/officeDocument/2006/relationships">
+  <p:cSld>
+    <p:spTree>
+      <p:nvGrpSpPr>
+        <p:cNvPr id="1" name=""/>
+        <p:cNvGrpSpPr/>
+        <p:nvPr/>
+      </p:nvGrpSpPr>
+      <p:grpSpPr/>
+      <p:sp>
+        <p:nvSpPr>
+          <p:cNvPr id="2" name="TextBox 1"/>
+          <p:cNvSpPr txBox="1"/>
+          <p:nvPr/>
+        </p:nvSpPr>
+        <p:spPr>
+          <a:xfrm>
+            <a:off x="502920" y="475488"/>
+            <a:ext cx="10241280" cy="685800"/>
+          </a:xfrm>
+          <a:prstGeom prst="rect">
+            <a:avLst/>
+          </a:prstGeom>
+          <a:noFill/>
+        </p:spPr>
+        <p:txBody>
+          <a:bodyPr wrap="square" lIns="45720" rIns="45720" tIns="27432" bIns="27432" anchor="ctr">
+            <a:spAutoFit/>
+          </a:bodyPr>
+          <a:lstStyle/>
+          <a:p>
+            <a:pPr algn="l">
+              <a:spcAft>
+                <a:spcPts val="600"/>
+              </a:spcAft>
+            </a:pPr>
+            <a:r>
+              <a:rPr sz="3000" b="0" i="0">
+                <a:solidFill>
+                  <a:srgbClr val="222222"/>
+                </a:solidFill>
+                <a:latin typeface="Arial"/>
+              </a:rPr>
+              <a:t>Wavelength: the ripple pattern shifts across the C band</a:t>
+            </a:r>
+          </a:p>
+        </p:txBody>
+      </p:sp>
+      <p:sp>
+        <p:nvSpPr>
+          <p:cNvPr id="3" name="TextBox 2"/>
+          <p:cNvSpPr txBox="1"/>
+          <p:nvPr/>
+        </p:nvSpPr>
+        <p:spPr>
+          <a:xfrm>
+            <a:off x="502920" y="1115568"/>
+            <a:ext cx="10789920" cy="411480"/>
+          </a:xfrm>
+          <a:prstGeom prst="rect">
+            <a:avLst/>
+          </a:prstGeom>
+          <a:noFill/>
+        </p:spPr>
+        <p:txBody>
+          <a:bodyPr wrap="square" lIns="45720" rIns="45720" tIns="27432" bIns="27432" anchor="t">
+            <a:spAutoFit/>
+          </a:bodyPr>
+          <a:lstStyle/>
+          <a:p>
+            <a:pPr algn="l">
+              <a:spcAft>
+                <a:spcPts val="600"/>
+              </a:spcAft>
+            </a:pPr>
+            <a:r>
+              <a:rPr sz="1500" b="0" i="1">
+                <a:solidFill>
+                  <a:srgbClr val="595959"/>
+                </a:solidFill>
+                <a:latin typeface="Arial"/>
+              </a:rPr>
+              <a:t>No buffer, gap 4.45 µm; same slab-width sweep at 1525, 1575 and 1625 nm</a:t>
+            </a:r>
+          </a:p>
+        </p:txBody>
+      </p:sp>
+      <p:graphicFrame>
+        <p:nvGraphicFramePr>
+          <p:cNvPr id="4" name="Chart 3"/>
+          <p:cNvGraphicFramePr>
+            <a:graphicFrameLocks noGrp="1"/>
+          </p:cNvGraphicFramePr>
+          <p:nvPr/>
+        </p:nvGraphicFramePr>
+        <p:xfrm>
+          <a:off x="548640" y="1645920"/>
+          <a:ext cx="7498079" cy="4023360"/>
+        </p:xfrm>
+        <a:graphic>
+          <a:graphicData uri="http://schemas.openxmlformats.org/drawingml/2006/chart">
+            <c:chart xmlns:c="http://schemas.openxmlformats.org/drawingml/2006/chart" r:id="rId2"/>
+          </a:graphicData>
+        </a:graphic>
+      </p:graphicFrame>
+      <p:graphicFrame>
+        <p:nvGraphicFramePr>
+          <p:cNvPr id="5" name="Table 4"/>
+          <p:cNvGraphicFramePr>
+            <a:graphicFrameLocks noGrp="1"/>
+          </p:cNvGraphicFramePr>
+          <p:nvPr/>
+        </p:nvGraphicFramePr>
+        <p:xfrm>
+          <a:off x="8321040" y="1737360"/>
+          <a:ext cx="3383280" cy="1170432"/>
+        </p:xfrm>
+        <a:graphic>
+          <a:graphicData uri="http://schemas.openxmlformats.org/drawingml/2006/table">
+            <a:tbl>
+              <a:tblPr firstRow="1" bandRow="1"/>
+              <a:tblGrid>
+                <a:gridCol w="822960"/>
+                <a:gridCol w="1234440"/>
+                <a:gridCol w="1325880"/>
+              </a:tblGrid>
+              <a:tr h="292608">
+                <a:tc>
+                  <a:txBody>
+                    <a:bodyPr wrap="square"/>
+                    <a:lstStyle/>
+                    <a:p>
+                      <a:pPr algn="l"/>
+                      <a:r>
+                        <a:rPr sz="1100" b="1" i="0">
+                          <a:solidFill>
+                            <a:srgbClr val="FFFFFF"/>
+                          </a:solidFill>
+                          <a:latin typeface="Arial"/>
+                        </a:rPr>
+                        <a:t>λ</a:t>
+                      </a:r>
+                    </a:p>
+                  </a:txBody>
+                  <a:tcPr marL="54864" marR="54864" marT="18288" marB="18288" anchor="ctr">
+                    <a:solidFill>
+                      <a:srgbClr val="1F4E79"/>
+                    </a:solidFill>
+                  </a:tcPr>
+                </a:tc>
+                <a:tc>
+                  <a:txBody>
+                    <a:bodyPr wrap="square"/>
+                    <a:lstStyle/>
+                    <a:p>
+                      <a:pPr algn="ctr"/>
+                      <a:r>
+                        <a:rPr sz="1100" b="1" i="0">
+                          <a:solidFill>
+                            <a:srgbClr val="FFFFFF"/>
+                          </a:solidFill>
+                          <a:latin typeface="Arial"/>
+                        </a:rPr>
+                        <a:t>IL @ 10.15 µm</a:t>
+                      </a:r>
+                    </a:p>
+                  </a:txBody>
+                  <a:tcPr marL="54864" marR="54864" marT="18288" marB="18288" anchor="ctr">
+                    <a:solidFill>
+                      <a:srgbClr val="1F4E79"/>
+                    </a:solidFill>
+                  </a:tcPr>
+                </a:tc>
+                <a:tc>
+                  <a:txBody>
+                    <a:bodyPr wrap="square"/>
+                    <a:lstStyle/>
+                    <a:p>
+                      <a:pPr algn="ctr"/>
+                      <a:r>
+                        <a:rPr sz="1100" b="1" i="0">
+                          <a:solidFill>
+                            <a:srgbClr val="FFFFFF"/>
+                          </a:solidFill>
+                          <a:latin typeface="Arial"/>
+                        </a:rPr>
+                        <a:t>Position</a:t>
+                      </a:r>
+                    </a:p>
+                  </a:txBody>
+                  <a:tcPr marL="54864" marR="54864" marT="18288" marB="18288" anchor="ctr">
+                    <a:solidFill>
+                      <a:srgbClr val="1F4E79"/>
+                    </a:solidFill>
+                  </a:tcPr>
+                </a:tc>
+              </a:tr>
+              <a:tr h="292608">
+                <a:tc>
+                  <a:txBody>
+                    <a:bodyPr wrap="square"/>
+                    <a:lstStyle/>
+                    <a:p>
+                      <a:pPr algn="l"/>
+                      <a:r>
+                        <a:rPr sz="1100" b="0" i="0">
+                          <a:solidFill>
+                            <a:srgbClr val="222222"/>
+                          </a:solidFill>
+                          <a:latin typeface="Arial"/>
+                        </a:rPr>
+                        <a:t>1525 nm</a:t>
+                      </a:r>
+                    </a:p>
+                  </a:txBody>
+                  <a:tcPr marL="54864" marR="54864" marT="18288" marB="18288" anchor="ctr">
+                    <a:solidFill>
+                      <a:srgbClr val="F4F6F9"/>
+                    </a:solidFill>
+                  </a:tcPr>
+                </a:tc>
+                <a:tc>
+                  <a:txBody>
+                    <a:bodyPr wrap="square"/>
+                    <a:lstStyle/>
+                    <a:p>
+                      <a:pPr algn="ctr"/>
+                      <a:r>
+                        <a:rPr sz="1100" b="0" i="0">
+                          <a:solidFill>
+                            <a:srgbClr val="222222"/>
+                          </a:solidFill>
+                          <a:latin typeface="Arial"/>
+                        </a:rPr>
+                        <a:t>0.262 dB/cm</a:t>
+                      </a:r>
+                    </a:p>
+                  </a:txBody>
+                  <a:tcPr marL="54864" marR="54864" marT="18288" marB="18288" anchor="ctr">
+                    <a:solidFill>
+                      <a:srgbClr val="F4F6F9"/>
+                    </a:solidFill>
+                  </a:tcPr>
+                </a:tc>
+                <a:tc>
+                  <a:txBody>
+                    <a:bodyPr wrap="square"/>
+                    <a:lstStyle/>
+                    <a:p>
+                      <a:pPr algn="ctr"/>
+                      <a:r>
+                        <a:rPr sz="1100" b="0" i="0">
+                          <a:solidFill>
+                            <a:srgbClr val="222222"/>
+                          </a:solidFill>
+                          <a:latin typeface="Arial"/>
+                        </a:rPr>
+                        <a:t>on a peak</a:t>
+                      </a:r>
+                    </a:p>
+                  </a:txBody>
+                  <a:tcPr marL="54864" marR="54864" marT="18288" marB="18288" anchor="ctr">
+                    <a:solidFill>
+                      <a:srgbClr val="F4F6F9"/>
+                    </a:solidFill>
+                  </a:tcPr>
+                </a:tc>
+              </a:tr>
+              <a:tr h="292608">
+                <a:tc>
+                  <a:txBody>
+                    <a:bodyPr wrap="square"/>
+                    <a:lstStyle/>
+                    <a:p>
+                      <a:pPr algn="l"/>
+                      <a:r>
+                        <a:rPr sz="1100" b="0" i="0">
+                          <a:solidFill>
+                            <a:srgbClr val="222222"/>
+                          </a:solidFill>
+                          <a:latin typeface="Arial"/>
+                        </a:rPr>
+                        <a:t>1575 nm</a:t>
+                      </a:r>
+                    </a:p>
+                  </a:txBody>
+                  <a:tcPr marL="54864" marR="54864" marT="18288" marB="18288" anchor="ctr">
+                    <a:solidFill>
+                      <a:srgbClr val="DDE3EA"/>
+                    </a:solidFill>
+                  </a:tcPr>
+                </a:tc>
+                <a:tc>
+                  <a:txBody>
+                    <a:bodyPr wrap="square"/>
+                    <a:lstStyle/>
+                    <a:p>
+                      <a:pPr algn="ctr"/>
+                      <a:r>
+                        <a:rPr sz="1100" b="0" i="0">
+                          <a:solidFill>
+                            <a:srgbClr val="222222"/>
+                          </a:solidFill>
+                          <a:latin typeface="Arial"/>
+                        </a:rPr>
+                        <a:t>0.092 dB/cm</a:t>
+                      </a:r>
+                    </a:p>
+                  </a:txBody>
+                  <a:tcPr marL="54864" marR="54864" marT="18288" marB="18288" anchor="ctr">
+                    <a:solidFill>
+                      <a:srgbClr val="DDE3EA"/>
+                    </a:solidFill>
+                  </a:tcPr>
+                </a:tc>
+                <a:tc>
+                  <a:txBody>
+                    <a:bodyPr wrap="square"/>
+                    <a:lstStyle/>
+                    <a:p>
+                      <a:pPr algn="ctr"/>
+                      <a:r>
+                        <a:rPr sz="1100" b="0" i="0">
+                          <a:solidFill>
+                            <a:srgbClr val="222222"/>
+                          </a:solidFill>
+                          <a:latin typeface="Arial"/>
+                        </a:rPr>
+                        <a:t>rising edge</a:t>
+                      </a:r>
+                    </a:p>
+                  </a:txBody>
+                  <a:tcPr marL="54864" marR="54864" marT="18288" marB="18288" anchor="ctr">
+                    <a:solidFill>
+                      <a:srgbClr val="DDE3EA"/>
+                    </a:solidFill>
+                  </a:tcPr>
+                </a:tc>
+              </a:tr>
+              <a:tr h="292608">
+                <a:tc>
+                  <a:txBody>
+                    <a:bodyPr wrap="square"/>
+                    <a:lstStyle/>
+                    <a:p>
+                      <a:pPr algn="l"/>
+                      <a:r>
+                        <a:rPr sz="1100" b="0" i="0">
+                          <a:solidFill>
+                            <a:srgbClr val="222222"/>
+                          </a:solidFill>
+                          <a:latin typeface="Arial"/>
+                        </a:rPr>
+                        <a:t>1625 nm</a:t>
+                      </a:r>
+                    </a:p>
+                  </a:txBody>
+                  <a:tcPr marL="54864" marR="54864" marT="18288" marB="18288" anchor="ctr">
+                    <a:solidFill>
+                      <a:srgbClr val="F4F6F9"/>
+                    </a:solidFill>
+                  </a:tcPr>
+                </a:tc>
+                <a:tc>
+                  <a:txBody>
+                    <a:bodyPr wrap="square"/>
+                    <a:lstStyle/>
+                    <a:p>
+                      <a:pPr algn="ctr"/>
+                      <a:r>
+                        <a:rPr sz="1100" b="0" i="0">
+                          <a:solidFill>
+                            <a:srgbClr val="222222"/>
+                          </a:solidFill>
+                          <a:latin typeface="Arial"/>
+                        </a:rPr>
+                        <a:t>0.080 dB/cm</a:t>
+                      </a:r>
+                    </a:p>
+                  </a:txBody>
+                  <a:tcPr marL="54864" marR="54864" marT="18288" marB="18288" anchor="ctr">
+                    <a:solidFill>
+                      <a:srgbClr val="F4F6F9"/>
+                    </a:solidFill>
+                  </a:tcPr>
+                </a:tc>
+                <a:tc>
+                  <a:txBody>
+                    <a:bodyPr wrap="square"/>
+                    <a:lstStyle/>
+                    <a:p>
+                      <a:pPr algn="ctr"/>
+                      <a:r>
+                        <a:rPr sz="1100" b="0" i="0">
+                          <a:solidFill>
+                            <a:srgbClr val="222222"/>
+                          </a:solidFill>
+                          <a:latin typeface="Arial"/>
+                        </a:rPr>
+                        <a:t>in a trough</a:t>
+                      </a:r>
+                    </a:p>
+                  </a:txBody>
+                  <a:tcPr marL="54864" marR="54864" marT="18288" marB="18288" anchor="ctr">
+                    <a:solidFill>
+                      <a:srgbClr val="F4F6F9"/>
+                    </a:solidFill>
+                  </a:tcPr>
+                </a:tc>
+              </a:tr>
+            </a:tbl>
+          </a:graphicData>
+        </a:graphic>
+      </p:graphicFrame>
+      <p:sp>
+        <p:nvSpPr>
+          <p:cNvPr id="6" name="Rounded Rectangle 5"/>
+          <p:cNvSpPr/>
+          <p:nvPr/>
+        </p:nvSpPr>
+        <p:spPr>
+          <a:xfrm>
+            <a:off x="8321040" y="3337560"/>
+            <a:ext cx="3383280" cy="2286000"/>
+          </a:xfrm>
+          <a:prstGeom prst="roundRect">
+            <a:avLst>
+              <a:gd name="adj" fmla="val 6000"/>
+            </a:avLst>
+          </a:prstGeom>
+          <a:solidFill>
+            <a:srgbClr val="EAF0F7"/>
+          </a:solidFill>
+          <a:ln>
+            <a:noFill/>
+          </a:ln>
+          <a:effectLst/>
+        </p:spPr>
+        <p:style>
+          <a:lnRef idx="1">
+            <a:schemeClr val="accent1"/>
+          </a:lnRef>
+          <a:fillRef idx="3">
+            <a:schemeClr val="accent1"/>
+          </a:fillRef>
+          <a:effectRef idx="2">
+            <a:schemeClr val="accent1"/>
+          </a:effectRef>
+          <a:fontRef idx="minor">
+            <a:schemeClr val="lt1"/>
+          </a:fontRef>
+        </p:style>
+        <p:txBody>
+          <a:bodyPr rtlCol="0" anchor="t" wrap="square" lIns="137160" rIns="137160" tIns="91440" bIns="91440"/>
+          <a:lstStyle/>
+          <a:p>
+            <a:pPr algn="l">
+              <a:spcAft>
+                <a:spcPts val="600"/>
+              </a:spcAft>
+            </a:pPr>
+            <a:r>
+              <a:rPr sz="1400" b="1" i="0">
+                <a:solidFill>
+                  <a:srgbClr val="1F4E79"/>
+                </a:solidFill>
+                <a:latin typeface="Arial"/>
+              </a:rPr>
+              <a:t>What changes with λ</a:t>
+            </a:r>
+          </a:p>
+          <a:p>
+            <a:pPr algn="l">
+              <a:spcAft>
+                <a:spcPts val="400"/>
+              </a:spcAft>
+            </a:pPr>
+            <a:r>
+              <a:rPr sz="1200" b="0" i="0">
+                <a:solidFill>
+                  <a:srgbClr val="222222"/>
+                </a:solidFill>
+                <a:latin typeface="Arial"/>
+              </a:rPr>
+              <a:t>Peaks move to wider slabs: ≈ +0.35 µm per +50 nm</a:t>
+            </a:r>
+          </a:p>
+          <a:p>
+            <a:pPr algn="l">
+              <a:spcAft>
+                <a:spcPts val="400"/>
+              </a:spcAft>
+            </a:pPr>
+            <a:r>
+              <a:rPr sz="1200" b="0" i="0">
+                <a:solidFill>
+                  <a:srgbClr val="222222"/>
+                </a:solidFill>
+                <a:latin typeface="Arial"/>
+              </a:rPr>
+              <a:t>Period 1.70 / 1.77 / 1.90 µm</a:t>
+            </a:r>
+          </a:p>
+          <a:p>
+            <a:pPr algn="l">
+              <a:spcAft>
+                <a:spcPts val="400"/>
+              </a:spcAft>
+            </a:pPr>
+            <a:r>
+              <a:rPr sz="1200" b="0" i="0">
+                <a:solidFill>
+                  <a:srgbClr val="222222"/>
+                </a:solidFill>
+                <a:latin typeface="Arial"/>
+              </a:rPr>
+              <a:t>Peaks grow with λ (≈ 0.5 → 1.3 dB/cm at 9 µm)</a:t>
+            </a:r>
+          </a:p>
+          <a:p>
+            <a:pPr algn="l">
+              <a:spcAft>
+                <a:spcPts val="500"/>
+              </a:spcAft>
+            </a:pPr>
+            <a:r>
+              <a:rPr sz="1200" b="0" i="0">
+                <a:solidFill>
+                  <a:srgbClr val="222222"/>
+                </a:solidFill>
+                <a:latin typeface="Arial"/>
+              </a:rPr>
+              <a:t>Vπ·L: 2.32 / 2.42 / 2.53 V·cm, flat vs slab</a:t>
+            </a:r>
+          </a:p>
+        </p:txBody>
+      </p:sp>
+      <p:sp>
+        <p:nvSpPr>
+          <p:cNvPr id="7" name="TextBox 6"/>
+          <p:cNvSpPr txBox="1"/>
+          <p:nvPr/>
+        </p:nvSpPr>
+        <p:spPr>
+          <a:xfrm>
+            <a:off x="548640" y="5806440"/>
+            <a:ext cx="11155680" cy="731520"/>
+          </a:xfrm>
+          <a:prstGeom prst="rect">
+            <a:avLst/>
+          </a:prstGeom>
+          <a:noFill/>
+        </p:spPr>
+        <p:txBody>
+          <a:bodyPr wrap="square" lIns="45720" rIns="45720" tIns="27432" bIns="27432" anchor="t">
+            <a:spAutoFit/>
+          </a:bodyPr>
+          <a:lstStyle/>
+          <a:p>
+            <a:pPr algn="l">
+              <a:spcAft>
+                <a:spcPts val="600"/>
+              </a:spcAft>
+            </a:pPr>
+            <a:r>
+              <a:rPr sz="1300" b="1" i="0">
+                <a:solidFill>
+                  <a:srgbClr val="1F4E79"/>
+                </a:solidFill>
+                <a:latin typeface="Arial"/>
+              </a:rPr>
+              <a:t>At the nominal slab, IL falls 3× from 1525 to 1625 nm, opposite to the normal gold-loss trend: a clear signature to look for in the measured C-band data.</a:t>
+            </a:r>
+          </a:p>
+        </p:txBody>
+      </p:sp>
+    </p:spTree>
+  </p:cSld>
+  <p:clrMapOvr>
+    <a:masterClrMapping/>
+  </p:clrMapOvr>
+</p:sld>
+</file>
+
+<file path=ppt/slides/slide24.xml><?xml version="1.0" encoding="utf-8"?>
+<p:sld xmlns:a="http://schemas.openxmlformats.org/drawingml/2006/main" xmlns:p="http://schemas.openxmlformats.org/presentationml/2006/main" xmlns:r="http://schemas.openxmlformats.org/officeDocument/2006/relationships">
+  <p:cSld>
+    <p:spTree>
+      <p:nvGrpSpPr>
+        <p:cNvPr id="1" name=""/>
+        <p:cNvGrpSpPr/>
+        <p:nvPr/>
+      </p:nvGrpSpPr>
+      <p:grpSpPr/>
+      <p:sp>
+        <p:nvSpPr>
+          <p:cNvPr id="2" name="TextBox 1"/>
+          <p:cNvSpPr txBox="1"/>
+          <p:nvPr/>
+        </p:nvSpPr>
+        <p:spPr>
+          <a:xfrm>
+            <a:off x="502920" y="475488"/>
+            <a:ext cx="10241280" cy="685800"/>
+          </a:xfrm>
+          <a:prstGeom prst="rect">
+            <a:avLst/>
+          </a:prstGeom>
+          <a:noFill/>
+        </p:spPr>
+        <p:txBody>
+          <a:bodyPr wrap="square" lIns="45720" rIns="45720" tIns="27432" bIns="27432" anchor="ctr">
+            <a:spAutoFit/>
+          </a:bodyPr>
+          <a:lstStyle/>
+          <a:p>
+            <a:pPr algn="l">
+              <a:spcAft>
+                <a:spcPts val="600"/>
+              </a:spcAft>
+            </a:pPr>
+            <a:r>
+              <a:rPr sz="3000" b="0" i="0">
+                <a:solidFill>
+                  <a:srgbClr val="222222"/>
+                </a:solidFill>
+                <a:latin typeface="Arial"/>
+              </a:rPr>
+              <a:t>Istanbul + 200 nm buffer: gap recovers Vπ·L</a:t>
+            </a:r>
+          </a:p>
+        </p:txBody>
+      </p:sp>
+      <p:sp>
+        <p:nvSpPr>
+          <p:cNvPr id="3" name="TextBox 2"/>
+          <p:cNvSpPr txBox="1"/>
+          <p:nvPr/>
+        </p:nvSpPr>
+        <p:spPr>
+          <a:xfrm>
+            <a:off x="502920" y="1115568"/>
+            <a:ext cx="10789920" cy="411480"/>
+          </a:xfrm>
+          <a:prstGeom prst="rect">
+            <a:avLst/>
+          </a:prstGeom>
+          <a:noFill/>
+        </p:spPr>
+        <p:txBody>
+          <a:bodyPr wrap="square" lIns="45720" rIns="45720" tIns="27432" bIns="27432" anchor="t">
+            <a:spAutoFit/>
+          </a:bodyPr>
+          <a:lstStyle/>
+          <a:p>
+            <a:pPr algn="l">
+              <a:spcAft>
+                <a:spcPts val="600"/>
+              </a:spcAft>
+            </a:pPr>
+            <a:r>
+              <a:rPr sz="1500" b="0" i="1">
+                <a:solidFill>
+                  <a:srgbClr val="595959"/>
+                </a:solidFill>
+                <a:latin typeface="Arial"/>
+              </a:rPr>
+              <a:t>Conformal buffer under all the gold; slab 10.15 µm, 1575 nm</a:t>
+            </a:r>
+          </a:p>
+        </p:txBody>
+      </p:sp>
+      <p:pic>
+        <p:nvPicPr>
+          <p:cNvPr id="4" name="Picture 3" descr="xs_buf_top.png"/>
+          <p:cNvPicPr>
+            <a:picLocks noChangeAspect="1"/>
+          </p:cNvPicPr>
+          <p:nvPr/>
+        </p:nvPicPr>
+        <p:blipFill>
+          <a:blip r:embed="rId2"/>
+          <a:stretch>
+            <a:fillRect/>
+          </a:stretch>
+        </p:blipFill>
+        <p:spPr>
+          <a:xfrm>
+            <a:off x="548640" y="1645920"/>
+            <a:ext cx="5852160" cy="1407911"/>
+          </a:xfrm>
+          <a:prstGeom prst="rect">
+            <a:avLst/>
+          </a:prstGeom>
+        </p:spPr>
+      </p:pic>
+      <p:graphicFrame>
+        <p:nvGraphicFramePr>
+          <p:cNvPr id="5" name="Chart 4"/>
+          <p:cNvGraphicFramePr>
+            <a:graphicFrameLocks noGrp="1"/>
+          </p:cNvGraphicFramePr>
+          <p:nvPr/>
+        </p:nvGraphicFramePr>
+        <p:xfrm>
+          <a:off x="6675120" y="1600200"/>
+          <a:ext cx="5029200" cy="3017520"/>
+        </p:xfrm>
+        <a:graphic>
+          <a:graphicData uri="http://schemas.openxmlformats.org/drawingml/2006/chart">
+            <c:chart xmlns:c="http://schemas.openxmlformats.org/drawingml/2006/chart" r:id="rId3"/>
+          </a:graphicData>
+        </a:graphic>
+      </p:graphicFrame>
+      <p:sp>
+        <p:nvSpPr>
+          <p:cNvPr id="6" name="Rounded Rectangle 5"/>
+          <p:cNvSpPr/>
+          <p:nvPr/>
+        </p:nvSpPr>
+        <p:spPr>
+          <a:xfrm>
+            <a:off x="548640" y="4709160"/>
+            <a:ext cx="2606040" cy="1051560"/>
+          </a:xfrm>
+          <a:prstGeom prst="roundRect">
+            <a:avLst>
+              <a:gd name="adj" fmla="val 8000"/>
+            </a:avLst>
+          </a:prstGeom>
+          <a:solidFill>
+            <a:srgbClr val="EAF0F7"/>
+          </a:solidFill>
+          <a:ln>
+            <a:noFill/>
+          </a:ln>
+          <a:effectLst/>
+        </p:spPr>
+        <p:style>
+          <a:lnRef idx="1">
+            <a:schemeClr val="accent1"/>
+          </a:lnRef>
+          <a:fillRef idx="3">
+            <a:schemeClr val="accent1"/>
+          </a:fillRef>
+          <a:effectRef idx="2">
+            <a:schemeClr val="accent1"/>
+          </a:effectRef>
+          <a:fontRef idx="minor">
+            <a:schemeClr val="lt1"/>
+          </a:fontRef>
+        </p:style>
+        <p:txBody>
+          <a:bodyPr rtlCol="0" anchor="ctr"/>
+          <a:lstStyle/>
+          <a:p>
+            <a:pPr algn="ctr"/>
+          </a:p>
+        </p:txBody>
+      </p:sp>
+      <p:sp>
+        <p:nvSpPr>
+          <p:cNvPr id="7" name="TextBox 6"/>
+          <p:cNvSpPr txBox="1"/>
+          <p:nvPr/>
+        </p:nvSpPr>
+        <p:spPr>
+          <a:xfrm>
+            <a:off x="548640" y="4818888"/>
+            <a:ext cx="2606040" cy="578358"/>
+          </a:xfrm>
+          <a:prstGeom prst="rect">
+            <a:avLst/>
+          </a:prstGeom>
+          <a:noFill/>
+        </p:spPr>
+        <p:txBody>
+          <a:bodyPr wrap="square" lIns="45720" rIns="45720" tIns="27432" bIns="27432" anchor="ctr">
+            <a:spAutoFit/>
+          </a:bodyPr>
+          <a:lstStyle/>
+          <a:p>
+            <a:pPr algn="ctr">
+              <a:spcAft>
+                <a:spcPts val="600"/>
+              </a:spcAft>
+            </a:pPr>
+            <a:r>
+              <a:rPr sz="3000" b="1" i="0">
+                <a:solidFill>
+                  <a:srgbClr val="C0392B"/>
+                </a:solidFill>
+                <a:latin typeface="Arial"/>
+              </a:rPr>
+              <a:t>+20 %</a:t>
+            </a:r>
+          </a:p>
+        </p:txBody>
+      </p:sp>
+      <p:sp>
+        <p:nvSpPr>
+          <p:cNvPr id="8" name="TextBox 7"/>
+          <p:cNvSpPr txBox="1"/>
+          <p:nvPr/>
+        </p:nvSpPr>
+        <p:spPr>
+          <a:xfrm>
+            <a:off x="640080" y="5340096"/>
+            <a:ext cx="2423160" cy="399592"/>
+          </a:xfrm>
+          <a:prstGeom prst="rect">
+            <a:avLst/>
+          </a:prstGeom>
+          <a:noFill/>
+        </p:spPr>
+        <p:txBody>
+          <a:bodyPr wrap="square" lIns="45720" rIns="45720" tIns="27432" bIns="27432" anchor="t">
+            <a:spAutoFit/>
+          </a:bodyPr>
+          <a:lstStyle/>
+          <a:p>
+            <a:pPr algn="ctr">
+              <a:spcAft>
+                <a:spcPts val="0"/>
+              </a:spcAft>
+            </a:pPr>
+            <a:r>
+              <a:rPr sz="1100" b="0" i="0">
+                <a:solidFill>
+                  <a:srgbClr val="595959"/>
+                </a:solidFill>
+                <a:latin typeface="Arial"/>
+              </a:rPr>
+              <a:t>Vπ·L with buffer at 4.45 µm</a:t>
+            </a:r>
+          </a:p>
+          <a:p>
+            <a:pPr algn="ctr">
+              <a:spcAft>
+                <a:spcPts val="0"/>
+              </a:spcAft>
+            </a:pPr>
+            <a:r>
+              <a:rPr sz="1100" b="0" i="0">
+                <a:solidFill>
+                  <a:srgbClr val="595959"/>
+                </a:solidFill>
+                <a:latin typeface="Arial"/>
+              </a:rPr>
+              <a:t>(2.42 → 2.90 V·cm)</a:t>
+            </a:r>
+          </a:p>
+        </p:txBody>
+      </p:sp>
+      <p:sp>
+        <p:nvSpPr>
+          <p:cNvPr id="9" name="Rounded Rectangle 8"/>
+          <p:cNvSpPr/>
+          <p:nvPr/>
+        </p:nvSpPr>
+        <p:spPr>
+          <a:xfrm>
+            <a:off x="3383280" y="4709160"/>
+            <a:ext cx="2606040" cy="1051560"/>
+          </a:xfrm>
+          <a:prstGeom prst="roundRect">
+            <a:avLst>
+              <a:gd name="adj" fmla="val 8000"/>
+            </a:avLst>
+          </a:prstGeom>
+          <a:solidFill>
+            <a:srgbClr val="EAF0F7"/>
+          </a:solidFill>
+          <a:ln>
+            <a:noFill/>
+          </a:ln>
+          <a:effectLst/>
+        </p:spPr>
+        <p:style>
+          <a:lnRef idx="1">
+            <a:schemeClr val="accent1"/>
+          </a:lnRef>
+          <a:fillRef idx="3">
+            <a:schemeClr val="accent1"/>
+          </a:fillRef>
+          <a:effectRef idx="2">
+            <a:schemeClr val="accent1"/>
+          </a:effectRef>
+          <a:fontRef idx="minor">
+            <a:schemeClr val="lt1"/>
+          </a:fontRef>
+        </p:style>
+        <p:txBody>
+          <a:bodyPr rtlCol="0" anchor="ctr"/>
+          <a:lstStyle/>
+          <a:p>
+            <a:pPr algn="ctr"/>
+          </a:p>
+        </p:txBody>
+      </p:sp>
+      <p:sp>
+        <p:nvSpPr>
+          <p:cNvPr id="10" name="TextBox 9"/>
+          <p:cNvSpPr txBox="1"/>
+          <p:nvPr/>
+        </p:nvSpPr>
+        <p:spPr>
+          <a:xfrm>
+            <a:off x="3383280" y="4818888"/>
+            <a:ext cx="2606040" cy="578358"/>
+          </a:xfrm>
+          <a:prstGeom prst="rect">
+            <a:avLst/>
+          </a:prstGeom>
+          <a:noFill/>
+        </p:spPr>
+        <p:txBody>
+          <a:bodyPr wrap="square" lIns="45720" rIns="45720" tIns="27432" bIns="27432" anchor="ctr">
+            <a:spAutoFit/>
+          </a:bodyPr>
+          <a:lstStyle/>
+          <a:p>
+            <a:pPr algn="ctr">
+              <a:spcAft>
+                <a:spcPts val="600"/>
+              </a:spcAft>
+            </a:pPr>
+            <a:r>
+              <a:rPr sz="3000" b="1" i="0">
+                <a:solidFill>
+                  <a:srgbClr val="1F4E79"/>
+                </a:solidFill>
+                <a:latin typeface="Arial"/>
+              </a:rPr>
+              <a:t>3.65 µm</a:t>
+            </a:r>
+          </a:p>
+        </p:txBody>
+      </p:sp>
+      <p:sp>
+        <p:nvSpPr>
+          <p:cNvPr id="11" name="TextBox 10"/>
+          <p:cNvSpPr txBox="1"/>
+          <p:nvPr/>
+        </p:nvSpPr>
+        <p:spPr>
+          <a:xfrm>
+            <a:off x="3474720" y="5340096"/>
+            <a:ext cx="2423160" cy="399592"/>
+          </a:xfrm>
+          <a:prstGeom prst="rect">
+            <a:avLst/>
+          </a:prstGeom>
+          <a:noFill/>
+        </p:spPr>
+        <p:txBody>
+          <a:bodyPr wrap="square" lIns="45720" rIns="45720" tIns="27432" bIns="27432" anchor="t">
+            <a:spAutoFit/>
+          </a:bodyPr>
+          <a:lstStyle/>
+          <a:p>
+            <a:pPr algn="ctr">
+              <a:spcAft>
+                <a:spcPts val="0"/>
+              </a:spcAft>
+            </a:pPr>
+            <a:r>
+              <a:rPr sz="1100" b="0" i="0">
+                <a:solidFill>
+                  <a:srgbClr val="595959"/>
+                </a:solidFill>
+                <a:latin typeface="Arial"/>
+              </a:rPr>
+              <a:t>gap that restores 2.42 V·cm</a:t>
+            </a:r>
+          </a:p>
+        </p:txBody>
+      </p:sp>
+      <p:sp>
+        <p:nvSpPr>
+          <p:cNvPr id="12" name="Rounded Rectangle 11"/>
+          <p:cNvSpPr/>
+          <p:nvPr/>
+        </p:nvSpPr>
+        <p:spPr>
+          <a:xfrm>
+            <a:off x="6217920" y="4709160"/>
+            <a:ext cx="2606040" cy="1051560"/>
+          </a:xfrm>
+          <a:prstGeom prst="roundRect">
+            <a:avLst>
+              <a:gd name="adj" fmla="val 8000"/>
+            </a:avLst>
+          </a:prstGeom>
+          <a:solidFill>
+            <a:srgbClr val="EAF0F7"/>
+          </a:solidFill>
+          <a:ln>
+            <a:noFill/>
+          </a:ln>
+          <a:effectLst/>
+        </p:spPr>
+        <p:style>
+          <a:lnRef idx="1">
+            <a:schemeClr val="accent1"/>
+          </a:lnRef>
+          <a:fillRef idx="3">
+            <a:schemeClr val="accent1"/>
+          </a:fillRef>
+          <a:effectRef idx="2">
+            <a:schemeClr val="accent1"/>
+          </a:effectRef>
+          <a:fontRef idx="minor">
+            <a:schemeClr val="lt1"/>
+          </a:fontRef>
+        </p:style>
+        <p:txBody>
+          <a:bodyPr rtlCol="0" anchor="ctr"/>
+          <a:lstStyle/>
+          <a:p>
+            <a:pPr algn="ctr"/>
+          </a:p>
+        </p:txBody>
+      </p:sp>
+      <p:sp>
+        <p:nvSpPr>
+          <p:cNvPr id="13" name="TextBox 12"/>
+          <p:cNvSpPr txBox="1"/>
+          <p:nvPr/>
+        </p:nvSpPr>
+        <p:spPr>
+          <a:xfrm>
+            <a:off x="6217920" y="4818888"/>
+            <a:ext cx="2606040" cy="578358"/>
+          </a:xfrm>
+          <a:prstGeom prst="rect">
+            <a:avLst/>
+          </a:prstGeom>
+          <a:noFill/>
+        </p:spPr>
+        <p:txBody>
+          <a:bodyPr wrap="square" lIns="45720" rIns="45720" tIns="27432" bIns="27432" anchor="ctr">
+            <a:spAutoFit/>
+          </a:bodyPr>
+          <a:lstStyle/>
+          <a:p>
+            <a:pPr algn="ctr">
+              <a:spcAft>
+                <a:spcPts val="600"/>
+              </a:spcAft>
+            </a:pPr>
+            <a:r>
+              <a:rPr sz="3000" b="1" i="0">
+                <a:solidFill>
+                  <a:srgbClr val="1B9E77"/>
+                </a:solidFill>
+                <a:latin typeface="Arial"/>
+              </a:rPr>
+              <a:t>0.013</a:t>
+            </a:r>
+          </a:p>
+        </p:txBody>
+      </p:sp>
+      <p:sp>
+        <p:nvSpPr>
+          <p:cNvPr id="14" name="TextBox 13"/>
+          <p:cNvSpPr txBox="1"/>
+          <p:nvPr/>
+        </p:nvSpPr>
+        <p:spPr>
+          <a:xfrm>
+            <a:off x="6309359" y="5340096"/>
+            <a:ext cx="2423160" cy="399592"/>
+          </a:xfrm>
+          <a:prstGeom prst="rect">
+            <a:avLst/>
+          </a:prstGeom>
+          <a:noFill/>
+        </p:spPr>
+        <p:txBody>
+          <a:bodyPr wrap="square" lIns="45720" rIns="45720" tIns="27432" bIns="27432" anchor="t">
+            <a:spAutoFit/>
+          </a:bodyPr>
+          <a:lstStyle/>
+          <a:p>
+            <a:pPr algn="ctr">
+              <a:spcAft>
+                <a:spcPts val="0"/>
+              </a:spcAft>
+            </a:pPr>
+            <a:r>
+              <a:rPr sz="1100" b="0" i="0">
+                <a:solidFill>
+                  <a:srgbClr val="595959"/>
+                </a:solidFill>
+                <a:latin typeface="Arial"/>
+              </a:rPr>
+              <a:t>dB/cm at 3.65 µm</a:t>
+            </a:r>
+          </a:p>
+        </p:txBody>
+      </p:sp>
+      <p:sp>
+        <p:nvSpPr>
+          <p:cNvPr id="15" name="Rounded Rectangle 14"/>
+          <p:cNvSpPr/>
+          <p:nvPr/>
+        </p:nvSpPr>
+        <p:spPr>
+          <a:xfrm>
+            <a:off x="9052560" y="4709160"/>
+            <a:ext cx="2606040" cy="1051560"/>
+          </a:xfrm>
+          <a:prstGeom prst="roundRect">
+            <a:avLst>
+              <a:gd name="adj" fmla="val 8000"/>
+            </a:avLst>
+          </a:prstGeom>
+          <a:solidFill>
+            <a:srgbClr val="EAF0F7"/>
+          </a:solidFill>
+          <a:ln>
+            <a:noFill/>
+          </a:ln>
+          <a:effectLst/>
+        </p:spPr>
+        <p:style>
+          <a:lnRef idx="1">
+            <a:schemeClr val="accent1"/>
+          </a:lnRef>
+          <a:fillRef idx="3">
+            <a:schemeClr val="accent1"/>
+          </a:fillRef>
+          <a:effectRef idx="2">
+            <a:schemeClr val="accent1"/>
+          </a:effectRef>
+          <a:fontRef idx="minor">
+            <a:schemeClr val="lt1"/>
+          </a:fontRef>
+        </p:style>
+        <p:txBody>
+          <a:bodyPr rtlCol="0" anchor="ctr"/>
+          <a:lstStyle/>
+          <a:p>
+            <a:pPr algn="ctr"/>
+          </a:p>
+        </p:txBody>
+      </p:sp>
+      <p:sp>
+        <p:nvSpPr>
+          <p:cNvPr id="16" name="TextBox 15"/>
+          <p:cNvSpPr txBox="1"/>
+          <p:nvPr/>
+        </p:nvSpPr>
+        <p:spPr>
+          <a:xfrm>
+            <a:off x="9052560" y="4818888"/>
+            <a:ext cx="2606040" cy="578358"/>
+          </a:xfrm>
+          <a:prstGeom prst="rect">
+            <a:avLst/>
+          </a:prstGeom>
+          <a:noFill/>
+        </p:spPr>
+        <p:txBody>
+          <a:bodyPr wrap="square" lIns="45720" rIns="45720" tIns="27432" bIns="27432" anchor="ctr">
+            <a:spAutoFit/>
+          </a:bodyPr>
+          <a:lstStyle/>
+          <a:p>
+            <a:pPr algn="ctr">
+              <a:spcAft>
+                <a:spcPts val="600"/>
+              </a:spcAft>
+            </a:pPr>
+            <a:r>
+              <a:rPr sz="3000" b="1" i="0">
+                <a:solidFill>
+                  <a:srgbClr val="1B9E77"/>
+                </a:solidFill>
+                <a:latin typeface="Arial"/>
+              </a:rPr>
+              <a:t>7×</a:t>
+            </a:r>
+          </a:p>
+        </p:txBody>
+      </p:sp>
+      <p:sp>
+        <p:nvSpPr>
+          <p:cNvPr id="17" name="TextBox 16"/>
+          <p:cNvSpPr txBox="1"/>
+          <p:nvPr/>
+        </p:nvSpPr>
+        <p:spPr>
+          <a:xfrm>
+            <a:off x="9144000" y="5340096"/>
+            <a:ext cx="2423160" cy="399592"/>
+          </a:xfrm>
+          <a:prstGeom prst="rect">
+            <a:avLst/>
+          </a:prstGeom>
+          <a:noFill/>
+        </p:spPr>
+        <p:txBody>
+          <a:bodyPr wrap="square" lIns="45720" rIns="45720" tIns="27432" bIns="27432" anchor="t">
+            <a:spAutoFit/>
+          </a:bodyPr>
+          <a:lstStyle/>
+          <a:p>
+            <a:pPr algn="ctr">
+              <a:spcAft>
+                <a:spcPts val="0"/>
+              </a:spcAft>
+            </a:pPr>
+            <a:r>
+              <a:rPr sz="1100" b="0" i="0">
+                <a:solidFill>
+                  <a:srgbClr val="595959"/>
+                </a:solidFill>
+                <a:latin typeface="Arial"/>
+              </a:rPr>
+              <a:t>lower IL than unbuffered</a:t>
+            </a:r>
+          </a:p>
+        </p:txBody>
+      </p:sp>
+      <p:sp>
+        <p:nvSpPr>
+          <p:cNvPr id="18" name="TextBox 17"/>
+          <p:cNvSpPr txBox="1"/>
+          <p:nvPr/>
+        </p:nvSpPr>
+        <p:spPr>
+          <a:xfrm>
+            <a:off x="548640" y="5943600"/>
+            <a:ext cx="11155680" cy="548640"/>
+          </a:xfrm>
+          <a:prstGeom prst="rect">
+            <a:avLst/>
+          </a:prstGeom>
+          <a:noFill/>
+        </p:spPr>
+        <p:txBody>
+          <a:bodyPr wrap="square" lIns="45720" rIns="45720" tIns="27432" bIns="27432" anchor="t">
+            <a:spAutoFit/>
+          </a:bodyPr>
+          <a:lstStyle/>
+          <a:p>
+            <a:pPr algn="l">
+              <a:spcAft>
+                <a:spcPts val="600"/>
+              </a:spcAft>
+            </a:pPr>
+            <a:r>
+              <a:rPr sz="1200" b="0" i="0">
+                <a:solidFill>
+                  <a:srgbClr val="595959"/>
+                </a:solidFill>
+                <a:latin typeface="Arial"/>
+              </a:rPr>
+              <a:t>Slope ≈ 0.6 V·cm per µm of gap; IL rises from 0.001 to 0.013 dB/cm as the gap closes.</a:t>
+            </a:r>
+          </a:p>
+        </p:txBody>
+      </p:sp>
+    </p:spTree>
+  </p:cSld>
+  <p:clrMapOvr>
+    <a:masterClrMapping/>
+  </p:clrMapOvr>
+</p:sld>
+</file>
+
+<file path=ppt/slides/slide25.xml><?xml version="1.0" encoding="utf-8"?>
+<p:sld xmlns:a="http://schemas.openxmlformats.org/drawingml/2006/main" xmlns:p="http://schemas.openxmlformats.org/presentationml/2006/main" xmlns:r="http://schemas.openxmlformats.org/officeDocument/2006/relationships">
+  <p:cSld>
+    <p:spTree>
+      <p:nvGrpSpPr>
+        <p:cNvPr id="1" name=""/>
+        <p:cNvGrpSpPr/>
+        <p:nvPr/>
+      </p:nvGrpSpPr>
+      <p:grpSpPr/>
+      <p:sp>
+        <p:nvSpPr>
+          <p:cNvPr id="2" name="TextBox 1"/>
+          <p:cNvSpPr txBox="1"/>
+          <p:nvPr/>
+        </p:nvSpPr>
+        <p:spPr>
+          <a:xfrm>
+            <a:off x="502920" y="475488"/>
+            <a:ext cx="10241280" cy="685800"/>
+          </a:xfrm>
+          <a:prstGeom prst="rect">
+            <a:avLst/>
+          </a:prstGeom>
+          <a:noFill/>
+        </p:spPr>
+        <p:txBody>
+          <a:bodyPr wrap="square" lIns="45720" rIns="45720" tIns="27432" bIns="27432" anchor="ctr">
+            <a:spAutoFit/>
+          </a:bodyPr>
+          <a:lstStyle/>
+          <a:p>
+            <a:pPr algn="l">
+              <a:spcAft>
+                <a:spcPts val="600"/>
+              </a:spcAft>
+            </a:pPr>
+            <a:r>
+              <a:rPr sz="3000" b="0" i="0">
+                <a:solidFill>
+                  <a:srgbClr val="222222"/>
+                </a:solidFill>
+                <a:latin typeface="Arial"/>
+              </a:rPr>
+              <a:t>With the buffer the ripples disappear</a:t>
+            </a:r>
+          </a:p>
+        </p:txBody>
+      </p:sp>
+      <p:sp>
+        <p:nvSpPr>
+          <p:cNvPr id="3" name="TextBox 2"/>
+          <p:cNvSpPr txBox="1"/>
+          <p:nvPr/>
+        </p:nvSpPr>
+        <p:spPr>
+          <a:xfrm>
+            <a:off x="502920" y="1115568"/>
+            <a:ext cx="10789920" cy="411480"/>
+          </a:xfrm>
+          <a:prstGeom prst="rect">
+            <a:avLst/>
+          </a:prstGeom>
+          <a:noFill/>
+        </p:spPr>
+        <p:txBody>
+          <a:bodyPr wrap="square" lIns="45720" rIns="45720" tIns="27432" bIns="27432" anchor="t">
+            <a:spAutoFit/>
+          </a:bodyPr>
+          <a:lstStyle/>
+          <a:p>
+            <a:pPr algn="l">
+              <a:spcAft>
+                <a:spcPts val="600"/>
+              </a:spcAft>
+            </a:pPr>
+            <a:r>
+              <a:rPr sz="1500" b="0" i="1">
+                <a:solidFill>
+                  <a:srgbClr val="595959"/>
+                </a:solidFill>
+                <a:latin typeface="Arial"/>
+              </a:rPr>
+              <a:t>Slab-width sweep at 1575 nm, both designs at the same nominal Vπ·L</a:t>
+            </a:r>
+          </a:p>
+        </p:txBody>
+      </p:sp>
+      <p:graphicFrame>
+        <p:nvGraphicFramePr>
+          <p:cNvPr id="4" name="Chart 3"/>
+          <p:cNvGraphicFramePr>
+            <a:graphicFrameLocks noGrp="1"/>
+          </p:cNvGraphicFramePr>
+          <p:nvPr/>
+        </p:nvGraphicFramePr>
+        <p:xfrm>
+          <a:off x="548640" y="1645920"/>
+          <a:ext cx="7498079" cy="4023360"/>
+        </p:xfrm>
+        <a:graphic>
+          <a:graphicData uri="http://schemas.openxmlformats.org/drawingml/2006/chart">
+            <c:chart xmlns:c="http://schemas.openxmlformats.org/drawingml/2006/chart" r:id="rId2"/>
+          </a:graphicData>
+        </a:graphic>
+      </p:graphicFrame>
+      <p:sp>
+        <p:nvSpPr>
+          <p:cNvPr id="5" name="Rounded Rectangle 4"/>
+          <p:cNvSpPr/>
+          <p:nvPr/>
+        </p:nvSpPr>
+        <p:spPr>
+          <a:xfrm>
+            <a:off x="8412480" y="1691640"/>
+            <a:ext cx="3291840" cy="1051560"/>
+          </a:xfrm>
+          <a:prstGeom prst="roundRect">
+            <a:avLst>
+              <a:gd name="adj" fmla="val 8000"/>
+            </a:avLst>
+          </a:prstGeom>
+          <a:solidFill>
+            <a:srgbClr val="EAF0F7"/>
+          </a:solidFill>
+          <a:ln>
+            <a:noFill/>
+          </a:ln>
+          <a:effectLst/>
+        </p:spPr>
+        <p:style>
+          <a:lnRef idx="1">
+            <a:schemeClr val="accent1"/>
+          </a:lnRef>
+          <a:fillRef idx="3">
+            <a:schemeClr val="accent1"/>
+          </a:fillRef>
+          <a:effectRef idx="2">
+            <a:schemeClr val="accent1"/>
+          </a:effectRef>
+          <a:fontRef idx="minor">
+            <a:schemeClr val="lt1"/>
+          </a:fontRef>
+        </p:style>
+        <p:txBody>
+          <a:bodyPr rtlCol="0" anchor="ctr"/>
+          <a:lstStyle/>
+          <a:p>
+            <a:pPr algn="ctr"/>
+          </a:p>
+        </p:txBody>
+      </p:sp>
+      <p:sp>
+        <p:nvSpPr>
+          <p:cNvPr id="6" name="TextBox 5"/>
+          <p:cNvSpPr txBox="1"/>
+          <p:nvPr/>
+        </p:nvSpPr>
+        <p:spPr>
+          <a:xfrm>
+            <a:off x="8412480" y="1801368"/>
+            <a:ext cx="3291840" cy="578358"/>
+          </a:xfrm>
+          <a:prstGeom prst="rect">
+            <a:avLst/>
+          </a:prstGeom>
+          <a:noFill/>
+        </p:spPr>
+        <p:txBody>
+          <a:bodyPr wrap="square" lIns="45720" rIns="45720" tIns="27432" bIns="27432" anchor="ctr">
+            <a:spAutoFit/>
+          </a:bodyPr>
+          <a:lstStyle/>
+          <a:p>
+            <a:pPr algn="ctr">
+              <a:spcAft>
+                <a:spcPts val="600"/>
+              </a:spcAft>
+            </a:pPr>
+            <a:r>
+              <a:rPr sz="3000" b="1" i="0">
+                <a:solidFill>
+                  <a:srgbClr val="1B9E77"/>
+                </a:solidFill>
+                <a:latin typeface="Arial"/>
+              </a:rPr>
+              <a:t>0.0126 dB/cm</a:t>
+            </a:r>
+          </a:p>
+        </p:txBody>
+      </p:sp>
+      <p:sp>
+        <p:nvSpPr>
+          <p:cNvPr id="7" name="TextBox 6"/>
+          <p:cNvSpPr txBox="1"/>
+          <p:nvPr/>
+        </p:nvSpPr>
+        <p:spPr>
+          <a:xfrm>
+            <a:off x="8503919" y="2322576"/>
+            <a:ext cx="3108960" cy="399592"/>
+          </a:xfrm>
+          <a:prstGeom prst="rect">
+            <a:avLst/>
+          </a:prstGeom>
+          <a:noFill/>
+        </p:spPr>
+        <p:txBody>
+          <a:bodyPr wrap="square" lIns="45720" rIns="45720" tIns="27432" bIns="27432" anchor="t">
+            <a:spAutoFit/>
+          </a:bodyPr>
+          <a:lstStyle/>
+          <a:p>
+            <a:pPr algn="ctr">
+              <a:spcAft>
+                <a:spcPts val="0"/>
+              </a:spcAft>
+            </a:pPr>
+            <a:r>
+              <a:rPr sz="1100" b="0" i="0">
+                <a:solidFill>
+                  <a:srgbClr val="595959"/>
+                </a:solidFill>
+                <a:latin typeface="Arial"/>
+              </a:rPr>
+              <a:t>buffered IL, ±0.4 % over</a:t>
+            </a:r>
+          </a:p>
+          <a:p>
+            <a:pPr algn="ctr">
+              <a:spcAft>
+                <a:spcPts val="0"/>
+              </a:spcAft>
+            </a:pPr>
+            <a:r>
+              <a:rPr sz="1100" b="0" i="0">
+                <a:solidFill>
+                  <a:srgbClr val="595959"/>
+                </a:solidFill>
+                <a:latin typeface="Arial"/>
+              </a:rPr>
+              <a:t>5.45–12.45 µm</a:t>
+            </a:r>
+          </a:p>
+        </p:txBody>
+      </p:sp>
+      <p:sp>
+        <p:nvSpPr>
+          <p:cNvPr id="8" name="Rounded Rectangle 7"/>
+          <p:cNvSpPr/>
+          <p:nvPr/>
+        </p:nvSpPr>
+        <p:spPr>
+          <a:xfrm>
+            <a:off x="8412480" y="2926080"/>
+            <a:ext cx="3291840" cy="1051560"/>
+          </a:xfrm>
+          <a:prstGeom prst="roundRect">
+            <a:avLst>
+              <a:gd name="adj" fmla="val 8000"/>
+            </a:avLst>
+          </a:prstGeom>
+          <a:solidFill>
+            <a:srgbClr val="EAF0F7"/>
+          </a:solidFill>
+          <a:ln>
+            <a:noFill/>
+          </a:ln>
+          <a:effectLst/>
+        </p:spPr>
+        <p:style>
+          <a:lnRef idx="1">
+            <a:schemeClr val="accent1"/>
+          </a:lnRef>
+          <a:fillRef idx="3">
+            <a:schemeClr val="accent1"/>
+          </a:fillRef>
+          <a:effectRef idx="2">
+            <a:schemeClr val="accent1"/>
+          </a:effectRef>
+          <a:fontRef idx="minor">
+            <a:schemeClr val="lt1"/>
+          </a:fontRef>
+        </p:style>
+        <p:txBody>
+          <a:bodyPr rtlCol="0" anchor="ctr"/>
+          <a:lstStyle/>
+          <a:p>
+            <a:pPr algn="ctr"/>
+          </a:p>
+        </p:txBody>
+      </p:sp>
+      <p:sp>
+        <p:nvSpPr>
+          <p:cNvPr id="9" name="TextBox 8"/>
+          <p:cNvSpPr txBox="1"/>
+          <p:nvPr/>
+        </p:nvSpPr>
+        <p:spPr>
+          <a:xfrm>
+            <a:off x="8412480" y="3035808"/>
+            <a:ext cx="3291840" cy="578358"/>
+          </a:xfrm>
+          <a:prstGeom prst="rect">
+            <a:avLst/>
+          </a:prstGeom>
+          <a:noFill/>
+        </p:spPr>
+        <p:txBody>
+          <a:bodyPr wrap="square" lIns="45720" rIns="45720" tIns="27432" bIns="27432" anchor="ctr">
+            <a:spAutoFit/>
+          </a:bodyPr>
+          <a:lstStyle/>
+          <a:p>
+            <a:pPr algn="ctr">
+              <a:spcAft>
+                <a:spcPts val="600"/>
+              </a:spcAft>
+            </a:pPr>
+            <a:r>
+              <a:rPr sz="3000" b="1" i="0">
+                <a:solidFill>
+                  <a:srgbClr val="C0392B"/>
+                </a:solidFill>
+                <a:latin typeface="Arial"/>
+              </a:rPr>
+              <a:t>0.017 → 1.03</a:t>
+            </a:r>
+          </a:p>
+        </p:txBody>
+      </p:sp>
+      <p:sp>
+        <p:nvSpPr>
+          <p:cNvPr id="10" name="TextBox 9"/>
+          <p:cNvSpPr txBox="1"/>
+          <p:nvPr/>
+        </p:nvSpPr>
+        <p:spPr>
+          <a:xfrm>
+            <a:off x="8503919" y="3557016"/>
+            <a:ext cx="3108960" cy="399592"/>
+          </a:xfrm>
+          <a:prstGeom prst="rect">
+            <a:avLst/>
+          </a:prstGeom>
+          <a:noFill/>
+        </p:spPr>
+        <p:txBody>
+          <a:bodyPr wrap="square" lIns="45720" rIns="45720" tIns="27432" bIns="27432" anchor="t">
+            <a:spAutoFit/>
+          </a:bodyPr>
+          <a:lstStyle/>
+          <a:p>
+            <a:pPr algn="ctr">
+              <a:spcAft>
+                <a:spcPts val="0"/>
+              </a:spcAft>
+            </a:pPr>
+            <a:r>
+              <a:rPr sz="1100" b="0" i="0">
+                <a:solidFill>
+                  <a:srgbClr val="595959"/>
+                </a:solidFill>
+                <a:latin typeface="Arial"/>
+              </a:rPr>
+              <a:t>unbuffered IL range (dB/cm)</a:t>
+            </a:r>
+          </a:p>
+        </p:txBody>
+      </p:sp>
+      <p:sp>
+        <p:nvSpPr>
+          <p:cNvPr id="11" name="Rounded Rectangle 10"/>
+          <p:cNvSpPr/>
+          <p:nvPr/>
+        </p:nvSpPr>
+        <p:spPr>
+          <a:xfrm>
+            <a:off x="8412480" y="4160520"/>
+            <a:ext cx="3291840" cy="1051560"/>
+          </a:xfrm>
+          <a:prstGeom prst="roundRect">
+            <a:avLst>
+              <a:gd name="adj" fmla="val 8000"/>
+            </a:avLst>
+          </a:prstGeom>
+          <a:solidFill>
+            <a:srgbClr val="EAF0F7"/>
+          </a:solidFill>
+          <a:ln>
+            <a:noFill/>
+          </a:ln>
+          <a:effectLst/>
+        </p:spPr>
+        <p:style>
+          <a:lnRef idx="1">
+            <a:schemeClr val="accent1"/>
+          </a:lnRef>
+          <a:fillRef idx="3">
+            <a:schemeClr val="accent1"/>
+          </a:fillRef>
+          <a:effectRef idx="2">
+            <a:schemeClr val="accent1"/>
+          </a:effectRef>
+          <a:fontRef idx="minor">
+            <a:schemeClr val="lt1"/>
+          </a:fontRef>
+        </p:style>
+        <p:txBody>
+          <a:bodyPr rtlCol="0" anchor="ctr"/>
+          <a:lstStyle/>
+          <a:p>
+            <a:pPr algn="ctr"/>
+          </a:p>
+        </p:txBody>
+      </p:sp>
+      <p:sp>
+        <p:nvSpPr>
+          <p:cNvPr id="12" name="TextBox 11"/>
+          <p:cNvSpPr txBox="1"/>
+          <p:nvPr/>
+        </p:nvSpPr>
+        <p:spPr>
+          <a:xfrm>
+            <a:off x="8412480" y="4270248"/>
+            <a:ext cx="3291840" cy="578358"/>
+          </a:xfrm>
+          <a:prstGeom prst="rect">
+            <a:avLst/>
+          </a:prstGeom>
+          <a:noFill/>
+        </p:spPr>
+        <p:txBody>
+          <a:bodyPr wrap="square" lIns="45720" rIns="45720" tIns="27432" bIns="27432" anchor="ctr">
+            <a:spAutoFit/>
+          </a:bodyPr>
+          <a:lstStyle/>
+          <a:p>
+            <a:pPr algn="ctr">
+              <a:spcAft>
+                <a:spcPts val="600"/>
+              </a:spcAft>
+            </a:pPr>
+            <a:r>
+              <a:rPr sz="3000" b="1" i="0">
+                <a:solidFill>
+                  <a:srgbClr val="1F4E79"/>
+                </a:solidFill>
+                <a:latin typeface="Arial"/>
+              </a:rPr>
+              <a:t>2.424 V·cm</a:t>
+            </a:r>
+          </a:p>
+        </p:txBody>
+      </p:sp>
+      <p:sp>
+        <p:nvSpPr>
+          <p:cNvPr id="13" name="TextBox 12"/>
+          <p:cNvSpPr txBox="1"/>
+          <p:nvPr/>
+        </p:nvSpPr>
+        <p:spPr>
+          <a:xfrm>
+            <a:off x="8503919" y="4791456"/>
+            <a:ext cx="3108960" cy="399592"/>
+          </a:xfrm>
+          <a:prstGeom prst="rect">
+            <a:avLst/>
+          </a:prstGeom>
+          <a:noFill/>
+        </p:spPr>
+        <p:txBody>
+          <a:bodyPr wrap="square" lIns="45720" rIns="45720" tIns="27432" bIns="27432" anchor="t">
+            <a:spAutoFit/>
+          </a:bodyPr>
+          <a:lstStyle/>
+          <a:p>
+            <a:pPr algn="ctr">
+              <a:spcAft>
+                <a:spcPts val="0"/>
+              </a:spcAft>
+            </a:pPr>
+            <a:r>
+              <a:rPr sz="1100" b="0" i="0">
+                <a:solidFill>
+                  <a:srgbClr val="595959"/>
+                </a:solidFill>
+                <a:latin typeface="Arial"/>
+              </a:rPr>
+              <a:t>buffered Vπ·L, flat above 7 µm</a:t>
+            </a:r>
+          </a:p>
+        </p:txBody>
+      </p:sp>
+      <p:sp>
+        <p:nvSpPr>
+          <p:cNvPr id="14" name="TextBox 13"/>
+          <p:cNvSpPr txBox="1"/>
+          <p:nvPr/>
+        </p:nvSpPr>
+        <p:spPr>
+          <a:xfrm>
+            <a:off x="548640" y="5806440"/>
+            <a:ext cx="11155680" cy="731520"/>
+          </a:xfrm>
+          <a:prstGeom prst="rect">
+            <a:avLst/>
+          </a:prstGeom>
+          <a:noFill/>
+        </p:spPr>
+        <p:txBody>
+          <a:bodyPr wrap="square" lIns="45720" rIns="45720" tIns="27432" bIns="27432" anchor="t">
+            <a:spAutoFit/>
+          </a:bodyPr>
+          <a:lstStyle/>
+          <a:p>
+            <a:pPr algn="l">
+              <a:spcAft>
+                <a:spcPts val="600"/>
+              </a:spcAft>
+            </a:pPr>
+            <a:r>
+              <a:rPr sz="1300" b="1" i="0">
+                <a:solidFill>
+                  <a:srgbClr val="1F4E79"/>
+                </a:solidFill>
+                <a:latin typeface="Arial"/>
+              </a:rPr>
+              <a:t>The buffer removes the gold contact at the slab end: no cavity, no ripples, IL independent of slab-width errors, at equal Vπ·L.</a:t>
             </a:r>
           </a:p>
         </p:txBody>

</xml_diff>

<commit_message>
Istanbul deck: 60 deg slab-etch slide
Co-Authored-By: Claude Opus 5.5 <noreply@anthropic.com>
Claude-Session: https://claude.ai/code/session_01EHQDy7yrZwCZyHELu6KFb3
</commit_message>
<xml_diff>
--- a/results/istanbul/Istanbul_results_AFR.pptx
+++ b/results/istanbul/Istanbul_results_AFR.pptx
@@ -13,6 +13,7 @@
     <p:sldId id="278" r:id="rId29"/>
     <p:sldId id="279" r:id="rId30"/>
     <p:sldId id="280" r:id="rId31"/>
+    <p:sldId id="281" r:id="rId32"/>
   </p:sldIdLst>
   <p:sldSz cx="12192000" cy="6858000"/>
   <p:notesSz cx="6858000" cy="9144000"/>
@@ -2473,6 +2474,1175 @@
               <c:strCache>
                 <c:ptCount val="1"/>
                 <c:pt idx="0">
+                  <c:v>Vertical slab end (90°)</c:v>
+                </c:pt>
+              </c:strCache>
+            </c:strRef>
+          </c:tx>
+          <c:spPr>
+            <a:ln w="22225">
+              <a:solidFill>
+                <a:srgbClr val="C0392B"/>
+              </a:solidFill>
+            </a:ln>
+          </c:spPr>
+          <c:marker>
+            <c:symbol val="circle"/>
+            <c:size val="4"/>
+            <c:spPr>
+              <a:solidFill>
+                <a:srgbClr val="C0392B"/>
+              </a:solidFill>
+              <a:ln>
+                <a:solidFill>
+                  <a:srgbClr val="C0392B"/>
+                </a:solidFill>
+              </a:ln>
+            </c:spPr>
+          </c:marker>
+          <c:xVal>
+            <c:numRef>
+              <c:f>Sheet1!$A$2:$A$72</c:f>
+              <c:numCache>
+                <c:formatCode>General</c:formatCode>
+                <c:ptCount val="71"/>
+                <c:pt idx="0">
+                  <c:v>5.45</c:v>
+                </c:pt>
+                <c:pt idx="1">
+                  <c:v>5.55</c:v>
+                </c:pt>
+                <c:pt idx="2">
+                  <c:v>5.65</c:v>
+                </c:pt>
+                <c:pt idx="3">
+                  <c:v>5.75</c:v>
+                </c:pt>
+                <c:pt idx="4">
+                  <c:v>5.85</c:v>
+                </c:pt>
+                <c:pt idx="5">
+                  <c:v>5.95</c:v>
+                </c:pt>
+                <c:pt idx="6">
+                  <c:v>6.05</c:v>
+                </c:pt>
+                <c:pt idx="7">
+                  <c:v>6.15</c:v>
+                </c:pt>
+                <c:pt idx="8">
+                  <c:v>6.25</c:v>
+                </c:pt>
+                <c:pt idx="9">
+                  <c:v>6.35</c:v>
+                </c:pt>
+                <c:pt idx="10">
+                  <c:v>6.45</c:v>
+                </c:pt>
+                <c:pt idx="11">
+                  <c:v>6.55</c:v>
+                </c:pt>
+                <c:pt idx="12">
+                  <c:v>6.65</c:v>
+                </c:pt>
+                <c:pt idx="13">
+                  <c:v>6.75</c:v>
+                </c:pt>
+                <c:pt idx="14">
+                  <c:v>6.85</c:v>
+                </c:pt>
+                <c:pt idx="15">
+                  <c:v>6.95</c:v>
+                </c:pt>
+                <c:pt idx="16">
+                  <c:v>7.05</c:v>
+                </c:pt>
+                <c:pt idx="17">
+                  <c:v>7.15</c:v>
+                </c:pt>
+                <c:pt idx="18">
+                  <c:v>7.25</c:v>
+                </c:pt>
+                <c:pt idx="19">
+                  <c:v>7.35</c:v>
+                </c:pt>
+                <c:pt idx="20">
+                  <c:v>7.45</c:v>
+                </c:pt>
+                <c:pt idx="21">
+                  <c:v>7.55</c:v>
+                </c:pt>
+                <c:pt idx="22">
+                  <c:v>7.65</c:v>
+                </c:pt>
+                <c:pt idx="23">
+                  <c:v>7.75</c:v>
+                </c:pt>
+                <c:pt idx="24">
+                  <c:v>7.85</c:v>
+                </c:pt>
+                <c:pt idx="25">
+                  <c:v>7.95</c:v>
+                </c:pt>
+                <c:pt idx="26">
+                  <c:v>8.05</c:v>
+                </c:pt>
+                <c:pt idx="27">
+                  <c:v>8.15</c:v>
+                </c:pt>
+                <c:pt idx="28">
+                  <c:v>8.25</c:v>
+                </c:pt>
+                <c:pt idx="29">
+                  <c:v>8.35</c:v>
+                </c:pt>
+                <c:pt idx="30">
+                  <c:v>8.45</c:v>
+                </c:pt>
+                <c:pt idx="31">
+                  <c:v>8.55</c:v>
+                </c:pt>
+                <c:pt idx="32">
+                  <c:v>8.65</c:v>
+                </c:pt>
+                <c:pt idx="33">
+                  <c:v>8.75</c:v>
+                </c:pt>
+                <c:pt idx="34">
+                  <c:v>8.85</c:v>
+                </c:pt>
+                <c:pt idx="35">
+                  <c:v>8.95</c:v>
+                </c:pt>
+                <c:pt idx="36">
+                  <c:v>9.05</c:v>
+                </c:pt>
+                <c:pt idx="37">
+                  <c:v>9.15</c:v>
+                </c:pt>
+                <c:pt idx="38">
+                  <c:v>9.25</c:v>
+                </c:pt>
+                <c:pt idx="39">
+                  <c:v>9.35</c:v>
+                </c:pt>
+                <c:pt idx="40">
+                  <c:v>9.45</c:v>
+                </c:pt>
+                <c:pt idx="41">
+                  <c:v>9.55</c:v>
+                </c:pt>
+                <c:pt idx="42">
+                  <c:v>9.65</c:v>
+                </c:pt>
+                <c:pt idx="43">
+                  <c:v>9.75</c:v>
+                </c:pt>
+                <c:pt idx="44">
+                  <c:v>9.85</c:v>
+                </c:pt>
+                <c:pt idx="45">
+                  <c:v>9.95</c:v>
+                </c:pt>
+                <c:pt idx="46">
+                  <c:v>10.05</c:v>
+                </c:pt>
+                <c:pt idx="47">
+                  <c:v>10.15</c:v>
+                </c:pt>
+                <c:pt idx="48">
+                  <c:v>10.25</c:v>
+                </c:pt>
+                <c:pt idx="49">
+                  <c:v>10.35</c:v>
+                </c:pt>
+                <c:pt idx="50">
+                  <c:v>10.45</c:v>
+                </c:pt>
+                <c:pt idx="51">
+                  <c:v>10.55</c:v>
+                </c:pt>
+                <c:pt idx="52">
+                  <c:v>10.65</c:v>
+                </c:pt>
+                <c:pt idx="53">
+                  <c:v>10.75</c:v>
+                </c:pt>
+                <c:pt idx="54">
+                  <c:v>10.85</c:v>
+                </c:pt>
+                <c:pt idx="55">
+                  <c:v>10.95</c:v>
+                </c:pt>
+                <c:pt idx="56">
+                  <c:v>11.05</c:v>
+                </c:pt>
+                <c:pt idx="57">
+                  <c:v>11.15</c:v>
+                </c:pt>
+                <c:pt idx="58">
+                  <c:v>11.25</c:v>
+                </c:pt>
+                <c:pt idx="59">
+                  <c:v>11.35</c:v>
+                </c:pt>
+                <c:pt idx="60">
+                  <c:v>11.45</c:v>
+                </c:pt>
+                <c:pt idx="61">
+                  <c:v>11.55</c:v>
+                </c:pt>
+                <c:pt idx="62">
+                  <c:v>11.65</c:v>
+                </c:pt>
+                <c:pt idx="63">
+                  <c:v>11.75</c:v>
+                </c:pt>
+                <c:pt idx="64">
+                  <c:v>11.85</c:v>
+                </c:pt>
+                <c:pt idx="65">
+                  <c:v>11.95</c:v>
+                </c:pt>
+                <c:pt idx="66">
+                  <c:v>12.05</c:v>
+                </c:pt>
+                <c:pt idx="67">
+                  <c:v>12.15</c:v>
+                </c:pt>
+                <c:pt idx="68">
+                  <c:v>12.25</c:v>
+                </c:pt>
+                <c:pt idx="69">
+                  <c:v>12.35</c:v>
+                </c:pt>
+                <c:pt idx="70">
+                  <c:v>12.45</c:v>
+                </c:pt>
+              </c:numCache>
+            </c:numRef>
+          </c:xVal>
+          <c:yVal>
+            <c:numRef>
+              <c:f>Sheet1!$B$2:$B$72</c:f>
+              <c:numCache>
+                <c:formatCode>General</c:formatCode>
+                <c:ptCount val="71"/>
+                <c:pt idx="0">
+                  <c:v>0.08872534541296766</c:v>
+                </c:pt>
+                <c:pt idx="1">
+                  <c:v>0.05091125228581376</c:v>
+                </c:pt>
+                <c:pt idx="2">
+                  <c:v>0.034449366507472295</c:v>
+                </c:pt>
+                <c:pt idx="3">
+                  <c:v>0.025855998935702004</c:v>
+                </c:pt>
+                <c:pt idx="4">
+                  <c:v>0.02100556675269085</c:v>
+                </c:pt>
+                <c:pt idx="5">
+                  <c:v>0.018231772287063342</c:v>
+                </c:pt>
+                <c:pt idx="6">
+                  <c:v>0.016882978491484048</c:v>
+                </c:pt>
+                <c:pt idx="7">
+                  <c:v>0.016733568307219365</c:v>
+                </c:pt>
+                <c:pt idx="8">
+                  <c:v>0.01783643633994232</c:v>
+                </c:pt>
+                <c:pt idx="9">
+                  <c:v>0.020606503343521286</c:v>
+                </c:pt>
+                <c:pt idx="10">
+                  <c:v>0.02610540183636762</c:v>
+                </c:pt>
+                <c:pt idx="11">
+                  <c:v>0.036460688833222295</c:v>
+                </c:pt>
+                <c:pt idx="12">
+                  <c:v>0.057759383349128425</c:v>
+                </c:pt>
+                <c:pt idx="13">
+                  <c:v>0.10792131654404673</c:v>
+                </c:pt>
+                <c:pt idx="14">
+                  <c:v>0.2593420599041353</c:v>
+                </c:pt>
+                <c:pt idx="15">
+                  <c:v>0.8518568844317698</c:v>
+                </c:pt>
+                <c:pt idx="16">
+                  <c:v>1.029144907307609</c:v>
+                </c:pt>
+                <c:pt idx="17">
+                  <c:v>0.3518612567853239</c:v>
+                </c:pt>
+                <c:pt idx="18">
+                  <c:v>0.15858751889084632</c:v>
+                </c:pt>
+                <c:pt idx="19">
+                  <c:v>0.09192706794247414</c:v>
+                </c:pt>
+                <c:pt idx="20">
+                  <c:v>0.06236795377839927</c:v>
+                </c:pt>
+                <c:pt idx="21">
+                  <c:v>0.046928398906736</c:v>
+                </c:pt>
+                <c:pt idx="22">
+                  <c:v>0.03850081723166634</c:v>
+                </c:pt>
+                <c:pt idx="23">
+                  <c:v>0.03369809968070464</c:v>
+                </c:pt>
+                <c:pt idx="24">
+                  <c:v>0.03144085814594755</c:v>
+                </c:pt>
+                <c:pt idx="25">
+                  <c:v>0.03148258283859044</c:v>
+                </c:pt>
+                <c:pt idx="26">
+                  <c:v>0.03359061077340244</c:v>
+                </c:pt>
+                <c:pt idx="27">
+                  <c:v>0.038542226342439326</c:v>
+                </c:pt>
+                <c:pt idx="28">
+                  <c:v>0.04764055363143606</c:v>
+                </c:pt>
+                <c:pt idx="29">
+                  <c:v>0.06470872276082545</c:v>
+                </c:pt>
+                <c:pt idx="30">
+                  <c:v>0.09768557030919518</c:v>
+                </c:pt>
+                <c:pt idx="31">
+                  <c:v>0.16967640596422848</c:v>
+                </c:pt>
+                <c:pt idx="32">
+                  <c:v>0.3460720567410094</c:v>
+                </c:pt>
+                <c:pt idx="33">
+                  <c:v>0.7261308856555284</c:v>
+                </c:pt>
+                <c:pt idx="34">
+                  <c:v>0.7215694871441569</c:v>
+                </c:pt>
+                <c:pt idx="35">
+                  <c:v>0.36794367439534925</c:v>
+                </c:pt>
+                <c:pt idx="36">
+                  <c:v>0.19560877667044452</c:v>
+                </c:pt>
+                <c:pt idx="37">
+                  <c:v>0.1215277482826157</c:v>
+                </c:pt>
+                <c:pt idx="38">
+                  <c:v>0.08516218504055369</c:v>
+                </c:pt>
+                <c:pt idx="39">
+                  <c:v>0.06568116833992256</c:v>
+                </c:pt>
+                <c:pt idx="40">
+                  <c:v>0.05454747140106628</c:v>
+                </c:pt>
+                <c:pt idx="41">
+                  <c:v>0.048454575529414685</c:v>
+                </c:pt>
+                <c:pt idx="42">
+                  <c:v>0.04582187473697675</c:v>
+                </c:pt>
+                <c:pt idx="43">
+                  <c:v>0.04598893293048975</c:v>
+                </c:pt>
+                <c:pt idx="44">
+                  <c:v>0.049061899634206894</c:v>
+                </c:pt>
+                <c:pt idx="45">
+                  <c:v>0.0561691325984867</c:v>
+                </c:pt>
+                <c:pt idx="46">
+                  <c:v>0.06886767656072448</c:v>
+                </c:pt>
+                <c:pt idx="47">
+                  <c:v>0.0916959697045315</c:v>
+                </c:pt>
+                <c:pt idx="48">
+                  <c:v>0.1348165500023665</c:v>
+                </c:pt>
+                <c:pt idx="49">
+                  <c:v>0.21614990482654733</c:v>
+                </c:pt>
+                <c:pt idx="50">
+                  <c:v>0.37991095016080156</c:v>
+                </c:pt>
+                <c:pt idx="51">
+                  <c:v>0.5967046924289567</c:v>
+                </c:pt>
+                <c:pt idx="52">
+                  <c:v>0.5519200796673431</c:v>
+                </c:pt>
+                <c:pt idx="53">
+                  <c:v>0.3482922751924493</c:v>
+                </c:pt>
+                <c:pt idx="54">
+                  <c:v>0.2151660448905787</c:v>
+                </c:pt>
+                <c:pt idx="55">
+                  <c:v>0.14343771464759553</c:v>
+                </c:pt>
+                <c:pt idx="56">
+                  <c:v>0.10445175139974353</c:v>
+                </c:pt>
+                <c:pt idx="57">
+                  <c:v>0.08214921936967311</c:v>
+                </c:pt>
+                <c:pt idx="58">
+                  <c:v>0.06947065972636988</c:v>
+                </c:pt>
+                <c:pt idx="59">
+                  <c:v>0.0623388775927847</c:v>
+                </c:pt>
+                <c:pt idx="60">
+                  <c:v>0.05938081329876724</c:v>
+                </c:pt>
+                <c:pt idx="61">
+                  <c:v>0.059843365789566214</c:v>
+                </c:pt>
+                <c:pt idx="62">
+                  <c:v>0.0641627201045212</c:v>
+                </c:pt>
+                <c:pt idx="63">
+                  <c:v>0.07293322044854653</c:v>
+                </c:pt>
+                <c:pt idx="64">
+                  <c:v>0.08894376958305936</c:v>
+                </c:pt>
+                <c:pt idx="65">
+                  <c:v>0.11613327129001685</c:v>
+                </c:pt>
+                <c:pt idx="66">
+                  <c:v>0.16332798616880725</c:v>
+                </c:pt>
+                <c:pt idx="67">
+                  <c:v>0.24734891605783446</c:v>
+                </c:pt>
+                <c:pt idx="68">
+                  <c:v>0.377172194417475</c:v>
+                </c:pt>
+                <c:pt idx="69">
+                  <c:v>0.4920545644224204</c:v>
+                </c:pt>
+                <c:pt idx="70">
+                  <c:v>0.4540654849760811</c:v>
+                </c:pt>
+              </c:numCache>
+            </c:numRef>
+          </c:yVal>
+          <c:smooth val="0"/>
+        </c:ser>
+        <c:ser>
+          <c:idx val="1"/>
+          <c:order val="1"/>
+          <c:tx>
+            <c:strRef>
+              <c:f>Sheet1!$B$74</c:f>
+              <c:strCache>
+                <c:ptCount val="1"/>
+                <c:pt idx="0">
+                  <c:v>60° slab end (process)</c:v>
+                </c:pt>
+              </c:strCache>
+            </c:strRef>
+          </c:tx>
+          <c:spPr>
+            <a:ln w="22225">
+              <a:solidFill>
+                <a:srgbClr val="1F4E79"/>
+              </a:solidFill>
+            </a:ln>
+          </c:spPr>
+          <c:marker>
+            <c:symbol val="circle"/>
+            <c:size val="4"/>
+            <c:spPr>
+              <a:solidFill>
+                <a:srgbClr val="1F4E79"/>
+              </a:solidFill>
+              <a:ln>
+                <a:solidFill>
+                  <a:srgbClr val="1F4E79"/>
+                </a:solidFill>
+              </a:ln>
+            </c:spPr>
+          </c:marker>
+          <c:xVal>
+            <c:numRef>
+              <c:f>Sheet1!$A$75:$A$145</c:f>
+              <c:numCache>
+                <c:formatCode>General</c:formatCode>
+                <c:ptCount val="71"/>
+                <c:pt idx="0">
+                  <c:v>5.45</c:v>
+                </c:pt>
+                <c:pt idx="1">
+                  <c:v>5.55</c:v>
+                </c:pt>
+                <c:pt idx="2">
+                  <c:v>5.65</c:v>
+                </c:pt>
+                <c:pt idx="3">
+                  <c:v>5.75</c:v>
+                </c:pt>
+                <c:pt idx="4">
+                  <c:v>5.85</c:v>
+                </c:pt>
+                <c:pt idx="5">
+                  <c:v>5.95</c:v>
+                </c:pt>
+                <c:pt idx="6">
+                  <c:v>6.05</c:v>
+                </c:pt>
+                <c:pt idx="7">
+                  <c:v>6.15</c:v>
+                </c:pt>
+                <c:pt idx="8">
+                  <c:v>6.25</c:v>
+                </c:pt>
+                <c:pt idx="9">
+                  <c:v>6.35</c:v>
+                </c:pt>
+                <c:pt idx="10">
+                  <c:v>6.45</c:v>
+                </c:pt>
+                <c:pt idx="11">
+                  <c:v>6.55</c:v>
+                </c:pt>
+                <c:pt idx="12">
+                  <c:v>6.65</c:v>
+                </c:pt>
+                <c:pt idx="13">
+                  <c:v>6.75</c:v>
+                </c:pt>
+                <c:pt idx="14">
+                  <c:v>6.85</c:v>
+                </c:pt>
+                <c:pt idx="15">
+                  <c:v>6.95</c:v>
+                </c:pt>
+                <c:pt idx="16">
+                  <c:v>7.05</c:v>
+                </c:pt>
+                <c:pt idx="17">
+                  <c:v>7.15</c:v>
+                </c:pt>
+                <c:pt idx="18">
+                  <c:v>7.25</c:v>
+                </c:pt>
+                <c:pt idx="19">
+                  <c:v>7.35</c:v>
+                </c:pt>
+                <c:pt idx="20">
+                  <c:v>7.45</c:v>
+                </c:pt>
+                <c:pt idx="21">
+                  <c:v>7.55</c:v>
+                </c:pt>
+                <c:pt idx="22">
+                  <c:v>7.65</c:v>
+                </c:pt>
+                <c:pt idx="23">
+                  <c:v>7.75</c:v>
+                </c:pt>
+                <c:pt idx="24">
+                  <c:v>7.85</c:v>
+                </c:pt>
+                <c:pt idx="25">
+                  <c:v>7.95</c:v>
+                </c:pt>
+                <c:pt idx="26">
+                  <c:v>8.05</c:v>
+                </c:pt>
+                <c:pt idx="27">
+                  <c:v>8.15</c:v>
+                </c:pt>
+                <c:pt idx="28">
+                  <c:v>8.25</c:v>
+                </c:pt>
+                <c:pt idx="29">
+                  <c:v>8.35</c:v>
+                </c:pt>
+                <c:pt idx="30">
+                  <c:v>8.45</c:v>
+                </c:pt>
+                <c:pt idx="31">
+                  <c:v>8.55</c:v>
+                </c:pt>
+                <c:pt idx="32">
+                  <c:v>8.65</c:v>
+                </c:pt>
+                <c:pt idx="33">
+                  <c:v>8.75</c:v>
+                </c:pt>
+                <c:pt idx="34">
+                  <c:v>8.85</c:v>
+                </c:pt>
+                <c:pt idx="35">
+                  <c:v>8.95</c:v>
+                </c:pt>
+                <c:pt idx="36">
+                  <c:v>9.05</c:v>
+                </c:pt>
+                <c:pt idx="37">
+                  <c:v>9.15</c:v>
+                </c:pt>
+                <c:pt idx="38">
+                  <c:v>9.25</c:v>
+                </c:pt>
+                <c:pt idx="39">
+                  <c:v>9.35</c:v>
+                </c:pt>
+                <c:pt idx="40">
+                  <c:v>9.45</c:v>
+                </c:pt>
+                <c:pt idx="41">
+                  <c:v>9.55</c:v>
+                </c:pt>
+                <c:pt idx="42">
+                  <c:v>9.65</c:v>
+                </c:pt>
+                <c:pt idx="43">
+                  <c:v>9.75</c:v>
+                </c:pt>
+                <c:pt idx="44">
+                  <c:v>9.85</c:v>
+                </c:pt>
+                <c:pt idx="45">
+                  <c:v>9.95</c:v>
+                </c:pt>
+                <c:pt idx="46">
+                  <c:v>10.05</c:v>
+                </c:pt>
+                <c:pt idx="47">
+                  <c:v>10.15</c:v>
+                </c:pt>
+                <c:pt idx="48">
+                  <c:v>10.25</c:v>
+                </c:pt>
+                <c:pt idx="49">
+                  <c:v>10.35</c:v>
+                </c:pt>
+                <c:pt idx="50">
+                  <c:v>10.45</c:v>
+                </c:pt>
+                <c:pt idx="51">
+                  <c:v>10.55</c:v>
+                </c:pt>
+                <c:pt idx="52">
+                  <c:v>10.65</c:v>
+                </c:pt>
+                <c:pt idx="53">
+                  <c:v>10.75</c:v>
+                </c:pt>
+                <c:pt idx="54">
+                  <c:v>10.85</c:v>
+                </c:pt>
+                <c:pt idx="55">
+                  <c:v>10.95</c:v>
+                </c:pt>
+                <c:pt idx="56">
+                  <c:v>11.05</c:v>
+                </c:pt>
+                <c:pt idx="57">
+                  <c:v>11.15</c:v>
+                </c:pt>
+                <c:pt idx="58">
+                  <c:v>11.25</c:v>
+                </c:pt>
+                <c:pt idx="59">
+                  <c:v>11.35</c:v>
+                </c:pt>
+                <c:pt idx="60">
+                  <c:v>11.45</c:v>
+                </c:pt>
+                <c:pt idx="61">
+                  <c:v>11.55</c:v>
+                </c:pt>
+                <c:pt idx="62">
+                  <c:v>11.65</c:v>
+                </c:pt>
+                <c:pt idx="63">
+                  <c:v>11.75</c:v>
+                </c:pt>
+                <c:pt idx="64">
+                  <c:v>11.85</c:v>
+                </c:pt>
+                <c:pt idx="65">
+                  <c:v>11.95</c:v>
+                </c:pt>
+                <c:pt idx="66">
+                  <c:v>12.05</c:v>
+                </c:pt>
+                <c:pt idx="67">
+                  <c:v>12.15</c:v>
+                </c:pt>
+                <c:pt idx="68">
+                  <c:v>12.25</c:v>
+                </c:pt>
+                <c:pt idx="69">
+                  <c:v>12.35</c:v>
+                </c:pt>
+                <c:pt idx="70">
+                  <c:v>12.45</c:v>
+                </c:pt>
+              </c:numCache>
+            </c:numRef>
+          </c:xVal>
+          <c:yVal>
+            <c:numRef>
+              <c:f>Sheet1!$B$75:$B$145</c:f>
+              <c:numCache>
+                <c:formatCode>General</c:formatCode>
+                <c:ptCount val="71"/>
+                <c:pt idx="0">
+                  <c:v>0.04581489070360358</c:v>
+                </c:pt>
+                <c:pt idx="1">
+                  <c:v>0.03182475673433785</c:v>
+                </c:pt>
+                <c:pt idx="2">
+                  <c:v>0.02416046580181874</c:v>
+                </c:pt>
+                <c:pt idx="3">
+                  <c:v>0.019769131670832215</c:v>
+                </c:pt>
+                <c:pt idx="4">
+                  <c:v>0.017249703954992014</c:v>
+                </c:pt>
+                <c:pt idx="5">
+                  <c:v>0.01606436880458409</c:v>
+                </c:pt>
+                <c:pt idx="6">
+                  <c:v>0.016029028509272975</c:v>
+                </c:pt>
+                <c:pt idx="7">
+                  <c:v>0.017296337466131278</c:v>
+                </c:pt>
+                <c:pt idx="8">
+                  <c:v>0.020105244711911267</c:v>
+                </c:pt>
+                <c:pt idx="9">
+                  <c:v>0.025644430982296657</c:v>
+                </c:pt>
+                <c:pt idx="10">
+                  <c:v>0.036471432965536454</c:v>
+                </c:pt>
+                <c:pt idx="11">
+                  <c:v>0.05827630009321813</c:v>
+                </c:pt>
+                <c:pt idx="12">
+                  <c:v>0.11231239773012032</c:v>
+                </c:pt>
+                <c:pt idx="13">
+                  <c:v>0.27720153678911563</c:v>
+                </c:pt>
+                <c:pt idx="14">
+                  <c:v>0.9344092547564996</c:v>
+                </c:pt>
+                <c:pt idx="15">
+                  <c:v>0.9549397999851682</c:v>
+                </c:pt>
+                <c:pt idx="16">
+                  <c:v>0.3254460261443611</c:v>
+                </c:pt>
+                <c:pt idx="17">
+                  <c:v>0.14999535011138734</c:v>
+                </c:pt>
+                <c:pt idx="18">
+                  <c:v>0.08805860198845739</c:v>
+                </c:pt>
+                <c:pt idx="19">
+                  <c:v>0.059981906810493</c:v>
+                </c:pt>
+                <c:pt idx="20">
+                  <c:v>0.045562833814645466</c:v>
+                </c:pt>
+                <c:pt idx="21">
+                  <c:v>0.03734395235172197</c:v>
+                </c:pt>
+                <c:pt idx="22">
+                  <c:v>0.032954667522491994</c:v>
+                </c:pt>
+                <c:pt idx="23">
+                  <c:v>0.030995711387914446</c:v>
+                </c:pt>
+                <c:pt idx="24">
+                  <c:v>0.031064018869066713</c:v>
+                </c:pt>
+                <c:pt idx="25">
+                  <c:v>0.03335537445318323</c:v>
+                </c:pt>
+                <c:pt idx="26">
+                  <c:v>0.03832174553511654</c:v>
+                </c:pt>
+                <c:pt idx="27">
+                  <c:v>0.04799263386392389</c:v>
+                </c:pt>
+                <c:pt idx="28">
+                  <c:v>0.0653878261065331</c:v>
+                </c:pt>
+                <c:pt idx="29">
+                  <c:v>0.09979780377214661</c:v>
+                </c:pt>
+                <c:pt idx="30">
+                  <c:v>0.17716272754660925</c:v>
+                </c:pt>
+                <c:pt idx="31">
+                  <c:v>0.3696063258206892</c:v>
+                </c:pt>
+                <c:pt idx="32">
+                  <c:v>0.7554895532033679</c:v>
+                </c:pt>
+                <c:pt idx="33">
+                  <c:v>0.6973032947531743</c:v>
+                </c:pt>
+                <c:pt idx="34">
+                  <c:v>0.353860984393623</c:v>
+                </c:pt>
+                <c:pt idx="35">
+                  <c:v>0.18768466043947246</c:v>
+                </c:pt>
+                <c:pt idx="36">
+                  <c:v>0.11673380392338892</c:v>
+                </c:pt>
+                <c:pt idx="37">
+                  <c:v>0.0825428245159376</c:v>
+                </c:pt>
+                <c:pt idx="38">
+                  <c:v>0.06421399458035422</c:v>
+                </c:pt>
+                <c:pt idx="39">
+                  <c:v>0.05353846058783595</c:v>
+                </c:pt>
+                <c:pt idx="40">
+                  <c:v>0.04773612094675082</c:v>
+                </c:pt>
+                <c:pt idx="41">
+                  <c:v>0.045251004885674524</c:v>
+                </c:pt>
+                <c:pt idx="42">
+                  <c:v>0.0456199170939368</c:v>
+                </c:pt>
+                <c:pt idx="43">
+                  <c:v>0.04893827545395357</c:v>
+                </c:pt>
+                <c:pt idx="44">
+                  <c:v>0.05630180157736555</c:v>
+                </c:pt>
+                <c:pt idx="45">
+                  <c:v>0.06952565251606378</c:v>
+                </c:pt>
+                <c:pt idx="46">
+                  <c:v>0.09308250982629446</c:v>
+                </c:pt>
+                <c:pt idx="47">
+                  <c:v>0.13795503437534937</c:v>
+                </c:pt>
+                <c:pt idx="48">
+                  <c:v>0.2273660480775433</c:v>
+                </c:pt>
+                <c:pt idx="49">
+                  <c:v>0.4010011155935137</c:v>
+                </c:pt>
+                <c:pt idx="50">
+                  <c:v>0.605711834118443</c:v>
+                </c:pt>
+                <c:pt idx="51">
+                  <c:v>0.5446382555033114</c:v>
+                </c:pt>
+                <c:pt idx="52">
+                  <c:v>0.3400734369866712</c:v>
+                </c:pt>
+                <c:pt idx="53">
+                  <c:v>0.20834341287108213</c:v>
+                </c:pt>
+                <c:pt idx="54">
+                  <c:v>0.13852450738474575</c:v>
+                </c:pt>
+                <c:pt idx="55">
+                  <c:v>0.10141905732814424</c:v>
+                </c:pt>
+                <c:pt idx="56">
+                  <c:v>0.08032045068497316</c:v>
+                </c:pt>
+                <c:pt idx="57">
+                  <c:v>0.06816645406675217</c:v>
+                </c:pt>
+                <c:pt idx="58">
+                  <c:v>0.06173369423334194</c:v>
+                </c:pt>
+                <c:pt idx="59">
+                  <c:v>0.05890245771189849</c:v>
+                </c:pt>
+                <c:pt idx="60">
+                  <c:v>0.05968449763836321</c:v>
+                </c:pt>
+                <c:pt idx="61">
+                  <c:v>0.06424916515235905</c:v>
+                </c:pt>
+                <c:pt idx="62">
+                  <c:v>0.07356587417860604</c:v>
+                </c:pt>
+                <c:pt idx="63">
+                  <c:v>0.08930711856771578</c:v>
+                </c:pt>
+                <c:pt idx="64">
+                  <c:v>0.1180661714549101</c:v>
+                </c:pt>
+                <c:pt idx="65">
+                  <c:v>0.16816514014727627</c:v>
+                </c:pt>
+                <c:pt idx="66">
+                  <c:v>0.2557869473713421</c:v>
+                </c:pt>
+                <c:pt idx="67">
+                  <c:v>0.3909098593347655</c:v>
+                </c:pt>
+                <c:pt idx="68">
+                  <c:v>0.49871272089024127</c:v>
+                </c:pt>
+                <c:pt idx="69">
+                  <c:v>0.44561089194708614</c:v>
+                </c:pt>
+                <c:pt idx="70">
+                  <c:v>0.31594449205567215</c:v>
+                </c:pt>
+              </c:numCache>
+            </c:numRef>
+          </c:yVal>
+          <c:smooth val="0"/>
+        </c:ser>
+        <c:ser>
+          <c:idx val="2"/>
+          <c:order val="2"/>
+          <c:tx>
+            <c:strRef>
+              <c:f>Sheet1!$B$147</c:f>
+              <c:strCache>
+                <c:ptCount val="1"/>
+                <c:pt idx="0">
+                  <c:v>Nominal 10.15 µm</c:v>
+                </c:pt>
+              </c:strCache>
+            </c:strRef>
+          </c:tx>
+          <c:spPr>
+            <a:ln w="19050">
+              <a:solidFill>
+                <a:srgbClr val="8A8A8A"/>
+              </a:solidFill>
+              <a:prstDash val="dash"/>
+            </a:ln>
+          </c:spPr>
+          <c:marker>
+            <c:symbol val="none"/>
+          </c:marker>
+          <c:xVal>
+            <c:numRef>
+              <c:f>Sheet1!$A$148:$A$149</c:f>
+              <c:numCache>
+                <c:formatCode>General</c:formatCode>
+                <c:ptCount val="2"/>
+                <c:pt idx="0">
+                  <c:v>10.15</c:v>
+                </c:pt>
+                <c:pt idx="1">
+                  <c:v>10.15</c:v>
+                </c:pt>
+              </c:numCache>
+            </c:numRef>
+          </c:xVal>
+          <c:yVal>
+            <c:numRef>
+              <c:f>Sheet1!$B$148:$B$149</c:f>
+              <c:numCache>
+                <c:formatCode>General</c:formatCode>
+                <c:ptCount val="2"/>
+                <c:pt idx="0">
+                  <c:v>0</c:v>
+                </c:pt>
+                <c:pt idx="1">
+                  <c:v>1.1</c:v>
+                </c:pt>
+              </c:numCache>
+            </c:numRef>
+          </c:yVal>
+          <c:smooth val="0"/>
+        </c:ser>
+        <c:axId val="-2128940872"/>
+        <c:axId val="-2129643912"/>
+      </c:scatterChart>
+      <c:valAx>
+        <c:axId val="-2128940872"/>
+        <c:scaling>
+          <c:orientation val="minMax"/>
+          <c:max val="13.0"/>
+          <c:min val="5.0"/>
+        </c:scaling>
+        <c:delete val="0"/>
+        <c:axPos val="b"/>
+        <c:title>
+          <c:tx>
+            <c:rich>
+              <a:bodyPr/>
+              <a:lstStyle/>
+              <a:p>
+                <a:r>
+                  <a:rPr sz="1100" b="0">
+                    <a:latin typeface="Arial"/>
+                  </a:rPr>
+                  <a:t>Slab top width (µm)</a:t>
+                </a:r>
+              </a:p>
+            </c:rich>
+          </c:tx>
+          <c:layout/>
+          <c:overlay val="0"/>
+        </c:title>
+        <c:numFmt formatCode="General" sourceLinked="1"/>
+        <c:majorTickMark val="out"/>
+        <c:minorTickMark val="none"/>
+        <c:tickLblPos val="nextTo"/>
+        <c:txPr>
+          <a:bodyPr/>
+          <a:lstStyle/>
+          <a:p>
+            <a:pPr>
+              <a:defRPr sz="1000">
+                <a:latin typeface="Arial"/>
+              </a:defRPr>
+            </a:pPr>
+          </a:p>
+        </c:txPr>
+        <c:crossAx val="-2129643912"/>
+        <c:crosses val="autoZero"/>
+        <c:crossBetween val="midCat"/>
+        <c:majorUnit val="1.0"/>
+      </c:valAx>
+      <c:valAx>
+        <c:axId val="-2129643912"/>
+        <c:scaling>
+          <c:orientation val="minMax"/>
+          <c:max val="1.1"/>
+          <c:min val="0.0"/>
+        </c:scaling>
+        <c:delete val="0"/>
+        <c:axPos val="l"/>
+        <c:majorGridlines>
+          <c:spPr>
+            <a:ln>
+              <a:solidFill>
+                <a:srgbClr val="E3E3E3"/>
+              </a:solidFill>
+            </a:ln>
+          </c:spPr>
+        </c:majorGridlines>
+        <c:title>
+          <c:tx>
+            <c:rich>
+              <a:bodyPr/>
+              <a:lstStyle/>
+              <a:p>
+                <a:r>
+                  <a:rPr sz="1100" b="0">
+                    <a:latin typeface="Arial"/>
+                  </a:rPr>
+                  <a:t>Insertion loss (dB/cm)</a:t>
+                </a:r>
+              </a:p>
+            </c:rich>
+          </c:tx>
+          <c:layout/>
+          <c:overlay val="0"/>
+        </c:title>
+        <c:numFmt formatCode="General" sourceLinked="0"/>
+        <c:majorTickMark val="out"/>
+        <c:minorTickMark val="none"/>
+        <c:tickLblPos val="nextTo"/>
+        <c:txPr>
+          <a:bodyPr/>
+          <a:lstStyle/>
+          <a:p>
+            <a:pPr>
+              <a:defRPr sz="1000">
+                <a:latin typeface="Arial"/>
+              </a:defRPr>
+            </a:pPr>
+          </a:p>
+        </c:txPr>
+        <c:crossAx val="-2128940872"/>
+        <c:crosses val="autoZero"/>
+        <c:crossBetween val="midCat"/>
+        <c:majorUnit val="0.1"/>
+      </c:valAx>
+    </c:plotArea>
+    <c:legend>
+      <c:legendPos val="t"/>
+      <c:layout/>
+      <c:overlay val="0"/>
+      <c:txPr>
+        <a:bodyPr/>
+        <a:lstStyle/>
+        <a:p>
+          <a:pPr>
+            <a:defRPr sz="1000">
+              <a:latin typeface="Arial"/>
+            </a:defRPr>
+          </a:pPr>
+        </a:p>
+      </c:txPr>
+    </c:legend>
+    <c:plotVisOnly val="1"/>
+    <c:dispBlanksAs val="gap"/>
+    <c:showDLblsOverMax val="0"/>
+  </c:chart>
+  <c:txPr>
+    <a:bodyPr/>
+    <a:lstStyle/>
+    <a:p>
+      <a:pPr>
+        <a:defRPr sz="1800"/>
+      </a:pPr>
+      <a:endParaRPr lang="en-US"/>
+    </a:p>
+  </c:txPr>
+  <c:externalData r:id="rId1">
+    <c:autoUpdate val="0"/>
+  </c:externalData>
+</c:chartSpace>
+</file>
+
+<file path=ppt/charts/chart21.xml><?xml version="1.0" encoding="utf-8"?>
+<c:chartSpace xmlns:c="http://schemas.openxmlformats.org/drawingml/2006/chart" xmlns:a="http://schemas.openxmlformats.org/drawingml/2006/main" xmlns:r="http://schemas.openxmlformats.org/officeDocument/2006/relationships">
+  <c:chart>
+    <c:plotArea>
+      <c:scatterChart>
+        <c:scatterStyle val="lineMarker"/>
+        <c:varyColors val="0"/>
+        <c:ser>
+          <c:idx val="0"/>
+          <c:order val="0"/>
+          <c:tx>
+            <c:strRef>
+              <c:f>Sheet1!$B$1</c:f>
+              <c:strCache>
+                <c:ptCount val="1"/>
+                <c:pt idx="0">
                   <c:v>Vπ·L</c:v>
                 </c:pt>
               </c:strCache>
@@ -2767,7 +3937,7 @@
 </c:chartSpace>
 </file>
 
-<file path=ppt/charts/chart21.xml><?xml version="1.0" encoding="utf-8"?>
+<file path=ppt/charts/chart22.xml><?xml version="1.0" encoding="utf-8"?>
 <c:chartSpace xmlns:c="http://schemas.openxmlformats.org/drawingml/2006/chart" xmlns:a="http://schemas.openxmlformats.org/drawingml/2006/main" xmlns:r="http://schemas.openxmlformats.org/officeDocument/2006/relationships">
   <c:chart>
     <c:plotArea>
@@ -9859,6 +11029,563 @@
                 </a:solidFill>
                 <a:latin typeface="Arial"/>
               </a:rPr>
+              <a:t>Real 60° slab etch: ripples survive, shifted by 0.1 µm</a:t>
+            </a:r>
+          </a:p>
+        </p:txBody>
+      </p:sp>
+      <p:sp>
+        <p:nvSpPr>
+          <p:cNvPr id="3" name="TextBox 2"/>
+          <p:cNvSpPr txBox="1"/>
+          <p:nvPr/>
+        </p:nvSpPr>
+        <p:spPr>
+          <a:xfrm>
+            <a:off x="502920" y="1115568"/>
+            <a:ext cx="10789920" cy="411480"/>
+          </a:xfrm>
+          <a:prstGeom prst="rect">
+            <a:avLst/>
+          </a:prstGeom>
+          <a:noFill/>
+        </p:spPr>
+        <p:txBody>
+          <a:bodyPr wrap="square" lIns="45720" rIns="45720" tIns="27432" bIns="27432" anchor="t">
+            <a:spAutoFit/>
+          </a:bodyPr>
+          <a:lstStyle/>
+          <a:p>
+            <a:pPr algn="l">
+              <a:spcAft>
+                <a:spcPts val="600"/>
+              </a:spcAft>
+            </a:pPr>
+            <a:r>
+              <a:rPr sz="1500" b="0" i="1">
+                <a:solidFill>
+                  <a:srgbClr val="595959"/>
+                </a:solidFill>
+                <a:latin typeface="Arial"/>
+              </a:rPr>
+              <a:t>No buffer, gap 4.45 µm, 1575 nm; slab width = top width for both</a:t>
+            </a:r>
+          </a:p>
+        </p:txBody>
+      </p:sp>
+      <p:graphicFrame>
+        <p:nvGraphicFramePr>
+          <p:cNvPr id="4" name="Chart 3"/>
+          <p:cNvGraphicFramePr>
+            <a:graphicFrameLocks noGrp="1"/>
+          </p:cNvGraphicFramePr>
+          <p:nvPr/>
+        </p:nvGraphicFramePr>
+        <p:xfrm>
+          <a:off x="548640" y="1645920"/>
+          <a:ext cx="7498079" cy="4023360"/>
+        </p:xfrm>
+        <a:graphic>
+          <a:graphicData uri="http://schemas.openxmlformats.org/drawingml/2006/chart">
+            <c:chart xmlns:c="http://schemas.openxmlformats.org/drawingml/2006/chart" r:id="rId2"/>
+          </a:graphicData>
+        </a:graphic>
+      </p:graphicFrame>
+      <p:pic>
+        <p:nvPicPr>
+          <p:cNvPr id="5" name="Picture 4" descr="xs_slant_zoom.png"/>
+          <p:cNvPicPr>
+            <a:picLocks noChangeAspect="1"/>
+          </p:cNvPicPr>
+          <p:nvPr/>
+        </p:nvPicPr>
+        <p:blipFill>
+          <a:blip r:embed="rId3"/>
+          <a:stretch>
+            <a:fillRect/>
+          </a:stretch>
+        </p:blipFill>
+        <p:spPr>
+          <a:xfrm>
+            <a:off x="8366760" y="1600200"/>
+            <a:ext cx="3337560" cy="2086624"/>
+          </a:xfrm>
+          <a:prstGeom prst="rect">
+            <a:avLst/>
+          </a:prstGeom>
+        </p:spPr>
+      </p:pic>
+      <p:graphicFrame>
+        <p:nvGraphicFramePr>
+          <p:cNvPr id="6" name="Table 5"/>
+          <p:cNvGraphicFramePr>
+            <a:graphicFrameLocks noGrp="1"/>
+          </p:cNvGraphicFramePr>
+          <p:nvPr/>
+        </p:nvGraphicFramePr>
+        <p:xfrm>
+          <a:off x="8366760" y="3749039"/>
+          <a:ext cx="3337560" cy="1463040"/>
+        </p:xfrm>
+        <a:graphic>
+          <a:graphicData uri="http://schemas.openxmlformats.org/drawingml/2006/table">
+            <a:tbl>
+              <a:tblPr firstRow="1" bandRow="1"/>
+              <a:tblGrid>
+                <a:gridCol w="1234440"/>
+                <a:gridCol w="1051560"/>
+                <a:gridCol w="1051560"/>
+              </a:tblGrid>
+              <a:tr h="292608">
+                <a:tc>
+                  <a:txBody>
+                    <a:bodyPr wrap="square"/>
+                    <a:lstStyle/>
+                    <a:p>
+                      <a:pPr algn="l"/>
+                      <a:r>
+                        <a:rPr sz="1000" b="1" i="0">
+                          <a:solidFill>
+                            <a:srgbClr val="FFFFFF"/>
+                          </a:solidFill>
+                          <a:latin typeface="Arial"/>
+                        </a:rPr>
+                        <a:t/>
+                      </a:r>
+                    </a:p>
+                  </a:txBody>
+                  <a:tcPr marL="54864" marR="54864" marT="18288" marB="18288" anchor="ctr">
+                    <a:solidFill>
+                      <a:srgbClr val="1F4E79"/>
+                    </a:solidFill>
+                  </a:tcPr>
+                </a:tc>
+                <a:tc>
+                  <a:txBody>
+                    <a:bodyPr wrap="square"/>
+                    <a:lstStyle/>
+                    <a:p>
+                      <a:pPr algn="ctr"/>
+                      <a:r>
+                        <a:rPr sz="1000" b="1" i="0">
+                          <a:solidFill>
+                            <a:srgbClr val="FFFFFF"/>
+                          </a:solidFill>
+                          <a:latin typeface="Arial"/>
+                        </a:rPr>
+                        <a:t>90°</a:t>
+                      </a:r>
+                    </a:p>
+                  </a:txBody>
+                  <a:tcPr marL="54864" marR="54864" marT="18288" marB="18288" anchor="ctr">
+                    <a:solidFill>
+                      <a:srgbClr val="1F4E79"/>
+                    </a:solidFill>
+                  </a:tcPr>
+                </a:tc>
+                <a:tc>
+                  <a:txBody>
+                    <a:bodyPr wrap="square"/>
+                    <a:lstStyle/>
+                    <a:p>
+                      <a:pPr algn="ctr"/>
+                      <a:r>
+                        <a:rPr sz="1000" b="1" i="0">
+                          <a:solidFill>
+                            <a:srgbClr val="FFFFFF"/>
+                          </a:solidFill>
+                          <a:latin typeface="Arial"/>
+                        </a:rPr>
+                        <a:t>60°</a:t>
+                      </a:r>
+                    </a:p>
+                  </a:txBody>
+                  <a:tcPr marL="54864" marR="54864" marT="18288" marB="18288" anchor="ctr">
+                    <a:solidFill>
+                      <a:srgbClr val="1F4E79"/>
+                    </a:solidFill>
+                  </a:tcPr>
+                </a:tc>
+              </a:tr>
+              <a:tr h="292608">
+                <a:tc>
+                  <a:txBody>
+                    <a:bodyPr wrap="square"/>
+                    <a:lstStyle/>
+                    <a:p>
+                      <a:pPr algn="l"/>
+                      <a:r>
+                        <a:rPr sz="1000" b="0" i="0">
+                          <a:solidFill>
+                            <a:srgbClr val="222222"/>
+                          </a:solidFill>
+                          <a:latin typeface="Arial"/>
+                        </a:rPr>
+                        <a:t>Period</a:t>
+                      </a:r>
+                    </a:p>
+                  </a:txBody>
+                  <a:tcPr marL="54864" marR="54864" marT="18288" marB="18288" anchor="ctr">
+                    <a:solidFill>
+                      <a:srgbClr val="F4F6F9"/>
+                    </a:solidFill>
+                  </a:tcPr>
+                </a:tc>
+                <a:tc>
+                  <a:txBody>
+                    <a:bodyPr wrap="square"/>
+                    <a:lstStyle/>
+                    <a:p>
+                      <a:pPr algn="ctr"/>
+                      <a:r>
+                        <a:rPr sz="1000" b="0" i="0">
+                          <a:solidFill>
+                            <a:srgbClr val="222222"/>
+                          </a:solidFill>
+                          <a:latin typeface="Arial"/>
+                        </a:rPr>
+                        <a:t>1.80 µm</a:t>
+                      </a:r>
+                    </a:p>
+                  </a:txBody>
+                  <a:tcPr marL="54864" marR="54864" marT="18288" marB="18288" anchor="ctr">
+                    <a:solidFill>
+                      <a:srgbClr val="F4F6F9"/>
+                    </a:solidFill>
+                  </a:tcPr>
+                </a:tc>
+                <a:tc>
+                  <a:txBody>
+                    <a:bodyPr wrap="square"/>
+                    <a:lstStyle/>
+                    <a:p>
+                      <a:pPr algn="ctr"/>
+                      <a:r>
+                        <a:rPr sz="1000" b="0" i="0">
+                          <a:solidFill>
+                            <a:srgbClr val="222222"/>
+                          </a:solidFill>
+                          <a:latin typeface="Arial"/>
+                        </a:rPr>
+                        <a:t>1.80 µm</a:t>
+                      </a:r>
+                    </a:p>
+                  </a:txBody>
+                  <a:tcPr marL="54864" marR="54864" marT="18288" marB="18288" anchor="ctr">
+                    <a:solidFill>
+                      <a:srgbClr val="F4F6F9"/>
+                    </a:solidFill>
+                  </a:tcPr>
+                </a:tc>
+              </a:tr>
+              <a:tr h="292608">
+                <a:tc>
+                  <a:txBody>
+                    <a:bodyPr wrap="square"/>
+                    <a:lstStyle/>
+                    <a:p>
+                      <a:pPr algn="l"/>
+                      <a:r>
+                        <a:rPr sz="1000" b="0" i="0">
+                          <a:solidFill>
+                            <a:srgbClr val="222222"/>
+                          </a:solidFill>
+                          <a:latin typeface="Arial"/>
+                        </a:rPr>
+                        <a:t>Peaks, dB/cm</a:t>
+                      </a:r>
+                    </a:p>
+                  </a:txBody>
+                  <a:tcPr marL="54864" marR="54864" marT="18288" marB="18288" anchor="ctr">
+                    <a:solidFill>
+                      <a:srgbClr val="DDE3EA"/>
+                    </a:solidFill>
+                  </a:tcPr>
+                </a:tc>
+                <a:tc>
+                  <a:txBody>
+                    <a:bodyPr wrap="square"/>
+                    <a:lstStyle/>
+                    <a:p>
+                      <a:pPr algn="ctr"/>
+                      <a:r>
+                        <a:rPr sz="1000" b="0" i="0">
+                          <a:solidFill>
+                            <a:srgbClr val="222222"/>
+                          </a:solidFill>
+                          <a:latin typeface="Arial"/>
+                        </a:rPr>
+                        <a:t>0.49–1.03</a:t>
+                      </a:r>
+                    </a:p>
+                  </a:txBody>
+                  <a:tcPr marL="54864" marR="54864" marT="18288" marB="18288" anchor="ctr">
+                    <a:solidFill>
+                      <a:srgbClr val="DDE3EA"/>
+                    </a:solidFill>
+                  </a:tcPr>
+                </a:tc>
+                <a:tc>
+                  <a:txBody>
+                    <a:bodyPr wrap="square"/>
+                    <a:lstStyle/>
+                    <a:p>
+                      <a:pPr algn="ctr"/>
+                      <a:r>
+                        <a:rPr sz="1000" b="0" i="0">
+                          <a:solidFill>
+                            <a:srgbClr val="222222"/>
+                          </a:solidFill>
+                          <a:latin typeface="Arial"/>
+                        </a:rPr>
+                        <a:t>0.50–0.96</a:t>
+                      </a:r>
+                    </a:p>
+                  </a:txBody>
+                  <a:tcPr marL="54864" marR="54864" marT="18288" marB="18288" anchor="ctr">
+                    <a:solidFill>
+                      <a:srgbClr val="DDE3EA"/>
+                    </a:solidFill>
+                  </a:tcPr>
+                </a:tc>
+              </a:tr>
+              <a:tr h="292608">
+                <a:tc>
+                  <a:txBody>
+                    <a:bodyPr wrap="square"/>
+                    <a:lstStyle/>
+                    <a:p>
+                      <a:pPr algn="l"/>
+                      <a:r>
+                        <a:rPr sz="1000" b="0" i="0">
+                          <a:solidFill>
+                            <a:srgbClr val="222222"/>
+                          </a:solidFill>
+                          <a:latin typeface="Arial"/>
+                        </a:rPr>
+                        <a:t>Troughs, dB/cm</a:t>
+                      </a:r>
+                    </a:p>
+                  </a:txBody>
+                  <a:tcPr marL="54864" marR="54864" marT="18288" marB="18288" anchor="ctr">
+                    <a:solidFill>
+                      <a:srgbClr val="F4F6F9"/>
+                    </a:solidFill>
+                  </a:tcPr>
+                </a:tc>
+                <a:tc>
+                  <a:txBody>
+                    <a:bodyPr wrap="square"/>
+                    <a:lstStyle/>
+                    <a:p>
+                      <a:pPr algn="ctr"/>
+                      <a:r>
+                        <a:rPr sz="1000" b="0" i="0">
+                          <a:solidFill>
+                            <a:srgbClr val="222222"/>
+                          </a:solidFill>
+                          <a:latin typeface="Arial"/>
+                        </a:rPr>
+                        <a:t>0.017–0.059</a:t>
+                      </a:r>
+                    </a:p>
+                  </a:txBody>
+                  <a:tcPr marL="54864" marR="54864" marT="18288" marB="18288" anchor="ctr">
+                    <a:solidFill>
+                      <a:srgbClr val="F4F6F9"/>
+                    </a:solidFill>
+                  </a:tcPr>
+                </a:tc>
+                <a:tc>
+                  <a:txBody>
+                    <a:bodyPr wrap="square"/>
+                    <a:lstStyle/>
+                    <a:p>
+                      <a:pPr algn="ctr"/>
+                      <a:r>
+                        <a:rPr sz="1000" b="0" i="0">
+                          <a:solidFill>
+                            <a:srgbClr val="222222"/>
+                          </a:solidFill>
+                          <a:latin typeface="Arial"/>
+                        </a:rPr>
+                        <a:t>0.016–0.059</a:t>
+                      </a:r>
+                    </a:p>
+                  </a:txBody>
+                  <a:tcPr marL="54864" marR="54864" marT="18288" marB="18288" anchor="ctr">
+                    <a:solidFill>
+                      <a:srgbClr val="F4F6F9"/>
+                    </a:solidFill>
+                  </a:tcPr>
+                </a:tc>
+              </a:tr>
+              <a:tr h="292608">
+                <a:tc>
+                  <a:txBody>
+                    <a:bodyPr wrap="square"/>
+                    <a:lstStyle/>
+                    <a:p>
+                      <a:pPr algn="l"/>
+                      <a:r>
+                        <a:rPr sz="1000" b="0" i="0">
+                          <a:solidFill>
+                            <a:srgbClr val="222222"/>
+                          </a:solidFill>
+                          <a:latin typeface="Arial"/>
+                        </a:rPr>
+                        <a:t>IL @ 10.15, dB/cm</a:t>
+                      </a:r>
+                    </a:p>
+                  </a:txBody>
+                  <a:tcPr marL="54864" marR="54864" marT="18288" marB="18288" anchor="ctr">
+                    <a:solidFill>
+                      <a:srgbClr val="FDE9D9"/>
+                    </a:solidFill>
+                  </a:tcPr>
+                </a:tc>
+                <a:tc>
+                  <a:txBody>
+                    <a:bodyPr wrap="square"/>
+                    <a:lstStyle/>
+                    <a:p>
+                      <a:pPr algn="ctr"/>
+                      <a:r>
+                        <a:rPr sz="1000" b="0" i="0">
+                          <a:solidFill>
+                            <a:srgbClr val="222222"/>
+                          </a:solidFill>
+                          <a:latin typeface="Arial"/>
+                        </a:rPr>
+                        <a:t>0.092</a:t>
+                      </a:r>
+                    </a:p>
+                  </a:txBody>
+                  <a:tcPr marL="54864" marR="54864" marT="18288" marB="18288" anchor="ctr">
+                    <a:solidFill>
+                      <a:srgbClr val="FDE9D9"/>
+                    </a:solidFill>
+                  </a:tcPr>
+                </a:tc>
+                <a:tc>
+                  <a:txBody>
+                    <a:bodyPr wrap="square"/>
+                    <a:lstStyle/>
+                    <a:p>
+                      <a:pPr algn="ctr"/>
+                      <a:r>
+                        <a:rPr sz="1000" b="0" i="0">
+                          <a:solidFill>
+                            <a:srgbClr val="222222"/>
+                          </a:solidFill>
+                          <a:latin typeface="Arial"/>
+                        </a:rPr>
+                        <a:t>0.138</a:t>
+                      </a:r>
+                    </a:p>
+                  </a:txBody>
+                  <a:tcPr marL="54864" marR="54864" marT="18288" marB="18288" anchor="ctr">
+                    <a:solidFill>
+                      <a:srgbClr val="FDE9D9"/>
+                    </a:solidFill>
+                  </a:tcPr>
+                </a:tc>
+              </a:tr>
+            </a:tbl>
+          </a:graphicData>
+        </a:graphic>
+      </p:graphicFrame>
+      <p:sp>
+        <p:nvSpPr>
+          <p:cNvPr id="7" name="TextBox 6"/>
+          <p:cNvSpPr txBox="1"/>
+          <p:nvPr/>
+        </p:nvSpPr>
+        <p:spPr>
+          <a:xfrm>
+            <a:off x="548640" y="5806440"/>
+            <a:ext cx="11155680" cy="731520"/>
+          </a:xfrm>
+          <a:prstGeom prst="rect">
+            <a:avLst/>
+          </a:prstGeom>
+          <a:noFill/>
+        </p:spPr>
+        <p:txBody>
+          <a:bodyPr wrap="square" lIns="45720" rIns="45720" tIns="27432" bIns="27432" anchor="t">
+            <a:spAutoFit/>
+          </a:bodyPr>
+          <a:lstStyle/>
+          <a:p>
+            <a:pPr algn="l">
+              <a:spcAft>
+                <a:spcPts val="600"/>
+              </a:spcAft>
+            </a:pPr>
+            <a:r>
+              <a:rPr sz="1300" b="1" i="0">
+                <a:solidFill>
+                  <a:srgbClr val="1F4E79"/>
+                </a:solidFill>
+                <a:latin typeface="Arial"/>
+              </a:rPr>
+              <a:t>The 275 nm, 60° slope still reflects the slab mode: same period and depth, pattern shifted by −0.10 µm (acts like a vertical end 0.10 µm wider). Vπ·L unchanged (2.421 V·cm).</a:t>
+            </a:r>
+          </a:p>
+        </p:txBody>
+      </p:sp>
+    </p:spTree>
+  </p:cSld>
+  <p:clrMapOvr>
+    <a:masterClrMapping/>
+  </p:clrMapOvr>
+</p:sld>
+</file>
+
+<file path=ppt/slides/slide25.xml><?xml version="1.0" encoding="utf-8"?>
+<p:sld xmlns:a="http://schemas.openxmlformats.org/drawingml/2006/main" xmlns:p="http://schemas.openxmlformats.org/presentationml/2006/main" xmlns:r="http://schemas.openxmlformats.org/officeDocument/2006/relationships">
+  <p:cSld>
+    <p:spTree>
+      <p:nvGrpSpPr>
+        <p:cNvPr id="1" name=""/>
+        <p:cNvGrpSpPr/>
+        <p:nvPr/>
+      </p:nvGrpSpPr>
+      <p:grpSpPr/>
+      <p:sp>
+        <p:nvSpPr>
+          <p:cNvPr id="2" name="TextBox 1"/>
+          <p:cNvSpPr txBox="1"/>
+          <p:nvPr/>
+        </p:nvSpPr>
+        <p:spPr>
+          <a:xfrm>
+            <a:off x="502920" y="475488"/>
+            <a:ext cx="10241280" cy="685800"/>
+          </a:xfrm>
+          <a:prstGeom prst="rect">
+            <a:avLst/>
+          </a:prstGeom>
+          <a:noFill/>
+        </p:spPr>
+        <p:txBody>
+          <a:bodyPr wrap="square" lIns="45720" rIns="45720" tIns="27432" bIns="27432" anchor="ctr">
+            <a:spAutoFit/>
+          </a:bodyPr>
+          <a:lstStyle/>
+          <a:p>
+            <a:pPr algn="l">
+              <a:spcAft>
+                <a:spcPts val="600"/>
+              </a:spcAft>
+            </a:pPr>
+            <a:r>
+              <a:rPr sz="3000" b="0" i="0">
+                <a:solidFill>
+                  <a:srgbClr val="222222"/>
+                </a:solidFill>
+                <a:latin typeface="Arial"/>
+              </a:rPr>
               <a:t>Istanbul + 200 nm buffer: gap recovers Vπ·L</a:t>
             </a:r>
           </a:p>
@@ -10504,7 +12231,7 @@
 </p:sld>
 </file>
 
-<file path=ppt/slides/slide25.xml><?xml version="1.0" encoding="utf-8"?>
+<file path=ppt/slides/slide26.xml><?xml version="1.0" encoding="utf-8"?>
 <p:sld xmlns:a="http://schemas.openxmlformats.org/drawingml/2006/main" xmlns:p="http://schemas.openxmlformats.org/presentationml/2006/main" xmlns:r="http://schemas.openxmlformats.org/officeDocument/2006/relationships">
   <p:cSld>
     <p:spTree>

</xml_diff>

<commit_message>
Istanbul deck: buffered + over-etch slides
Co-Authored-By: Claude Opus 5.5 <noreply@anthropic.com>
Claude-Session: https://claude.ai/code/session_01EHQDy7yrZwCZyHELu6KFb3
</commit_message>
<xml_diff>
--- a/results/istanbul/Istanbul_results_AFR.pptx
+++ b/results/istanbul/Istanbul_results_AFR.pptx
@@ -14,6 +14,8 @@
     <p:sldId id="279" r:id="rId30"/>
     <p:sldId id="280" r:id="rId31"/>
     <p:sldId id="281" r:id="rId32"/>
+    <p:sldId id="282" r:id="rId33"/>
+    <p:sldId id="283" r:id="rId34"/>
   </p:sldIdLst>
   <p:sldSz cx="12192000" cy="6858000"/>
   <p:notesSz cx="6858000" cy="9144000"/>
@@ -5029,6 +5031,624 @@
         </a:p>
       </c:txPr>
     </c:legend>
+    <c:plotVisOnly val="1"/>
+    <c:dispBlanksAs val="gap"/>
+    <c:showDLblsOverMax val="0"/>
+  </c:chart>
+  <c:txPr>
+    <a:bodyPr/>
+    <a:lstStyle/>
+    <a:p>
+      <a:pPr>
+        <a:defRPr sz="1800"/>
+      </a:pPr>
+      <a:endParaRPr lang="en-US"/>
+    </a:p>
+  </c:txPr>
+  <c:externalData r:id="rId1">
+    <c:autoUpdate val="0"/>
+  </c:externalData>
+</c:chartSpace>
+</file>
+
+<file path=ppt/charts/chart23.xml><?xml version="1.0" encoding="utf-8"?>
+<c:chartSpace xmlns:c="http://schemas.openxmlformats.org/drawingml/2006/chart" xmlns:a="http://schemas.openxmlformats.org/drawingml/2006/main" xmlns:r="http://schemas.openxmlformats.org/officeDocument/2006/relationships">
+  <c:chart>
+    <c:plotArea>
+      <c:scatterChart>
+        <c:scatterStyle val="lineMarker"/>
+        <c:varyColors val="0"/>
+        <c:ser>
+          <c:idx val="0"/>
+          <c:order val="0"/>
+          <c:tx>
+            <c:strRef>
+              <c:f>Sheet1!$B$1</c:f>
+              <c:strCache>
+                <c:ptCount val="1"/>
+                <c:pt idx="0">
+                  <c:v>IL</c:v>
+                </c:pt>
+              </c:strCache>
+            </c:strRef>
+          </c:tx>
+          <c:spPr>
+            <a:ln w="25400">
+              <a:solidFill>
+                <a:srgbClr val="1B9E77"/>
+              </a:solidFill>
+            </a:ln>
+          </c:spPr>
+          <c:marker>
+            <c:symbol val="circle"/>
+            <c:size val="6"/>
+            <c:spPr>
+              <a:solidFill>
+                <a:srgbClr val="1B9E77"/>
+              </a:solidFill>
+              <a:ln>
+                <a:solidFill>
+                  <a:srgbClr val="1B9E77"/>
+                </a:solidFill>
+              </a:ln>
+            </c:spPr>
+          </c:marker>
+          <c:xVal>
+            <c:numRef>
+              <c:f>Sheet1!$A$2:$A$20</c:f>
+              <c:numCache>
+                <c:formatCode>General</c:formatCode>
+                <c:ptCount val="19"/>
+                <c:pt idx="0">
+                  <c:v>0</c:v>
+                </c:pt>
+                <c:pt idx="1">
+                  <c:v>50</c:v>
+                </c:pt>
+                <c:pt idx="2">
+                  <c:v>100</c:v>
+                </c:pt>
+                <c:pt idx="3">
+                  <c:v>150</c:v>
+                </c:pt>
+                <c:pt idx="4">
+                  <c:v>200</c:v>
+                </c:pt>
+                <c:pt idx="5">
+                  <c:v>250</c:v>
+                </c:pt>
+                <c:pt idx="6">
+                  <c:v>300</c:v>
+                </c:pt>
+                <c:pt idx="7">
+                  <c:v>350</c:v>
+                </c:pt>
+                <c:pt idx="8">
+                  <c:v>400</c:v>
+                </c:pt>
+                <c:pt idx="9">
+                  <c:v>450</c:v>
+                </c:pt>
+                <c:pt idx="10">
+                  <c:v>500</c:v>
+                </c:pt>
+                <c:pt idx="11">
+                  <c:v>550</c:v>
+                </c:pt>
+                <c:pt idx="12">
+                  <c:v>600</c:v>
+                </c:pt>
+                <c:pt idx="13">
+                  <c:v>650</c:v>
+                </c:pt>
+                <c:pt idx="14">
+                  <c:v>700</c:v>
+                </c:pt>
+                <c:pt idx="15">
+                  <c:v>750</c:v>
+                </c:pt>
+                <c:pt idx="16">
+                  <c:v>800</c:v>
+                </c:pt>
+                <c:pt idx="17">
+                  <c:v>850</c:v>
+                </c:pt>
+                <c:pt idx="18">
+                  <c:v>900</c:v>
+                </c:pt>
+              </c:numCache>
+            </c:numRef>
+          </c:xVal>
+          <c:yVal>
+            <c:numRef>
+              <c:f>Sheet1!$B$2:$B$20</c:f>
+              <c:numCache>
+                <c:formatCode>General</c:formatCode>
+                <c:ptCount val="19"/>
+                <c:pt idx="0">
+                  <c:v>0.012614069724079906</c:v>
+                </c:pt>
+                <c:pt idx="1">
+                  <c:v>0.012612644000975943</c:v>
+                </c:pt>
+                <c:pt idx="2">
+                  <c:v>0.012612189628661997</c:v>
+                </c:pt>
+                <c:pt idx="3">
+                  <c:v>0.012612407812770378</c:v>
+                </c:pt>
+                <c:pt idx="4">
+                  <c:v>0.012686174140443065</c:v>
+                </c:pt>
+                <c:pt idx="5">
+                  <c:v>0.012612259173632371</c:v>
+                </c:pt>
+                <c:pt idx="6">
+                  <c:v>0.012613529069366929</c:v>
+                </c:pt>
+                <c:pt idx="7">
+                  <c:v>0.012613671016065205</c:v>
+                </c:pt>
+                <c:pt idx="8">
+                  <c:v>0.012611844573536403</c:v>
+                </c:pt>
+                <c:pt idx="9">
+                  <c:v>0.01261434404698179</c:v>
+                </c:pt>
+                <c:pt idx="10">
+                  <c:v>0.012612930767171493</c:v>
+                </c:pt>
+                <c:pt idx="11">
+                  <c:v>0.012614115199438971</c:v>
+                </c:pt>
+                <c:pt idx="12">
+                  <c:v>0.012611299826584361</c:v>
+                </c:pt>
+                <c:pt idx="13">
+                  <c:v>0.01261457809405426</c:v>
+                </c:pt>
+                <c:pt idx="14">
+                  <c:v>0.012611095567661773</c:v>
+                </c:pt>
+                <c:pt idx="15">
+                  <c:v>0.012613352267934948</c:v>
+                </c:pt>
+                <c:pt idx="16">
+                  <c:v>0.012615290398139634</c:v>
+                </c:pt>
+                <c:pt idx="17">
+                  <c:v>0.012613106113848244</c:v>
+                </c:pt>
+                <c:pt idx="18">
+                  <c:v>0.012614935894586001</c:v>
+                </c:pt>
+              </c:numCache>
+            </c:numRef>
+          </c:yVal>
+          <c:smooth val="0"/>
+        </c:ser>
+        <c:axId val="-2128940872"/>
+        <c:axId val="-2129643912"/>
+      </c:scatterChart>
+      <c:valAx>
+        <c:axId val="-2128940872"/>
+        <c:scaling>
+          <c:orientation val="minMax"/>
+          <c:max val="900.0"/>
+          <c:min val="0.0"/>
+        </c:scaling>
+        <c:delete val="0"/>
+        <c:axPos val="b"/>
+        <c:title>
+          <c:tx>
+            <c:rich>
+              <a:bodyPr/>
+              <a:lstStyle/>
+              <a:p>
+                <a:r>
+                  <a:rPr sz="1100" b="0">
+                    <a:latin typeface="Arial"/>
+                  </a:rPr>
+                  <a:t>Over-etch (nm)   [lateral buffer 200 nm]</a:t>
+                </a:r>
+              </a:p>
+            </c:rich>
+          </c:tx>
+          <c:layout/>
+          <c:overlay val="0"/>
+        </c:title>
+        <c:numFmt formatCode="General" sourceLinked="1"/>
+        <c:majorTickMark val="out"/>
+        <c:minorTickMark val="none"/>
+        <c:tickLblPos val="nextTo"/>
+        <c:txPr>
+          <a:bodyPr/>
+          <a:lstStyle/>
+          <a:p>
+            <a:pPr>
+              <a:defRPr sz="1000">
+                <a:latin typeface="Arial"/>
+              </a:defRPr>
+            </a:pPr>
+          </a:p>
+        </c:txPr>
+        <c:crossAx val="-2129643912"/>
+        <c:crosses val="autoZero"/>
+        <c:crossBetween val="midCat"/>
+        <c:majorUnit val="100.0"/>
+      </c:valAx>
+      <c:valAx>
+        <c:axId val="-2129643912"/>
+        <c:scaling>
+          <c:orientation val="minMax"/>
+          <c:max val="0.03"/>
+          <c:min val="0.0"/>
+        </c:scaling>
+        <c:delete val="0"/>
+        <c:axPos val="l"/>
+        <c:majorGridlines>
+          <c:spPr>
+            <a:ln>
+              <a:solidFill>
+                <a:srgbClr val="E3E3E3"/>
+              </a:solidFill>
+            </a:ln>
+          </c:spPr>
+        </c:majorGridlines>
+        <c:title>
+          <c:tx>
+            <c:rich>
+              <a:bodyPr/>
+              <a:lstStyle/>
+              <a:p>
+                <a:r>
+                  <a:rPr sz="1100" b="0">
+                    <a:latin typeface="Arial"/>
+                  </a:rPr>
+                  <a:t>IL (dB/cm)</a:t>
+                </a:r>
+              </a:p>
+            </c:rich>
+          </c:tx>
+          <c:layout/>
+          <c:overlay val="0"/>
+        </c:title>
+        <c:numFmt formatCode="General" sourceLinked="0"/>
+        <c:majorTickMark val="out"/>
+        <c:minorTickMark val="none"/>
+        <c:tickLblPos val="nextTo"/>
+        <c:txPr>
+          <a:bodyPr/>
+          <a:lstStyle/>
+          <a:p>
+            <a:pPr>
+              <a:defRPr sz="1000">
+                <a:latin typeface="Arial"/>
+              </a:defRPr>
+            </a:pPr>
+          </a:p>
+        </c:txPr>
+        <c:crossAx val="-2128940872"/>
+        <c:crosses val="autoZero"/>
+        <c:crossBetween val="midCat"/>
+        <c:majorUnit val="0.005"/>
+      </c:valAx>
+    </c:plotArea>
+    <c:plotVisOnly val="1"/>
+    <c:dispBlanksAs val="gap"/>
+    <c:showDLblsOverMax val="0"/>
+  </c:chart>
+  <c:txPr>
+    <a:bodyPr/>
+    <a:lstStyle/>
+    <a:p>
+      <a:pPr>
+        <a:defRPr sz="1800"/>
+      </a:pPr>
+      <a:endParaRPr lang="en-US"/>
+    </a:p>
+  </c:txPr>
+  <c:externalData r:id="rId1">
+    <c:autoUpdate val="0"/>
+  </c:externalData>
+</c:chartSpace>
+</file>
+
+<file path=ppt/charts/chart24.xml><?xml version="1.0" encoding="utf-8"?>
+<c:chartSpace xmlns:c="http://schemas.openxmlformats.org/drawingml/2006/chart" xmlns:a="http://schemas.openxmlformats.org/drawingml/2006/main" xmlns:r="http://schemas.openxmlformats.org/officeDocument/2006/relationships">
+  <c:chart>
+    <c:plotArea>
+      <c:scatterChart>
+        <c:scatterStyle val="lineMarker"/>
+        <c:varyColors val="0"/>
+        <c:ser>
+          <c:idx val="0"/>
+          <c:order val="0"/>
+          <c:tx>
+            <c:strRef>
+              <c:f>Sheet1!$B$1</c:f>
+              <c:strCache>
+                <c:ptCount val="1"/>
+                <c:pt idx="0">
+                  <c:v>IL</c:v>
+                </c:pt>
+              </c:strCache>
+            </c:strRef>
+          </c:tx>
+          <c:spPr>
+            <a:ln w="25400">
+              <a:solidFill>
+                <a:srgbClr val="1B9E77"/>
+              </a:solidFill>
+            </a:ln>
+          </c:spPr>
+          <c:marker>
+            <c:symbol val="circle"/>
+            <c:size val="6"/>
+            <c:spPr>
+              <a:solidFill>
+                <a:srgbClr val="1B9E77"/>
+              </a:solidFill>
+              <a:ln>
+                <a:solidFill>
+                  <a:srgbClr val="1B9E77"/>
+                </a:solidFill>
+              </a:ln>
+            </c:spPr>
+          </c:marker>
+          <c:xVal>
+            <c:numRef>
+              <c:f>Sheet1!$A$2:$A$22</c:f>
+              <c:numCache>
+                <c:formatCode>General</c:formatCode>
+                <c:ptCount val="21"/>
+                <c:pt idx="0">
+                  <c:v>0</c:v>
+                </c:pt>
+                <c:pt idx="1">
+                  <c:v>20</c:v>
+                </c:pt>
+                <c:pt idx="2">
+                  <c:v>40</c:v>
+                </c:pt>
+                <c:pt idx="3">
+                  <c:v>60</c:v>
+                </c:pt>
+                <c:pt idx="4">
+                  <c:v>80</c:v>
+                </c:pt>
+                <c:pt idx="5">
+                  <c:v>100</c:v>
+                </c:pt>
+                <c:pt idx="6">
+                  <c:v>120</c:v>
+                </c:pt>
+                <c:pt idx="7">
+                  <c:v>140</c:v>
+                </c:pt>
+                <c:pt idx="8">
+                  <c:v>160</c:v>
+                </c:pt>
+                <c:pt idx="9">
+                  <c:v>180</c:v>
+                </c:pt>
+                <c:pt idx="10">
+                  <c:v>200</c:v>
+                </c:pt>
+                <c:pt idx="11">
+                  <c:v>220</c:v>
+                </c:pt>
+                <c:pt idx="12">
+                  <c:v>240</c:v>
+                </c:pt>
+                <c:pt idx="13">
+                  <c:v>260</c:v>
+                </c:pt>
+                <c:pt idx="14">
+                  <c:v>280</c:v>
+                </c:pt>
+                <c:pt idx="15">
+                  <c:v>300</c:v>
+                </c:pt>
+                <c:pt idx="16">
+                  <c:v>320</c:v>
+                </c:pt>
+                <c:pt idx="17">
+                  <c:v>340</c:v>
+                </c:pt>
+                <c:pt idx="18">
+                  <c:v>360</c:v>
+                </c:pt>
+                <c:pt idx="19">
+                  <c:v>380</c:v>
+                </c:pt>
+                <c:pt idx="20">
+                  <c:v>400</c:v>
+                </c:pt>
+              </c:numCache>
+            </c:numRef>
+          </c:xVal>
+          <c:yVal>
+            <c:numRef>
+              <c:f>Sheet1!$B$2:$B$22</c:f>
+              <c:numCache>
+                <c:formatCode>General</c:formatCode>
+                <c:ptCount val="21"/>
+                <c:pt idx="0">
+                  <c:v>0.012615557845356905</c:v>
+                </c:pt>
+                <c:pt idx="1">
+                  <c:v>0.012787776127421546</c:v>
+                </c:pt>
+                <c:pt idx="2">
+                  <c:v>0.01270896557437052</c:v>
+                </c:pt>
+                <c:pt idx="3">
+                  <c:v>0.012676565775779594</c:v>
+                </c:pt>
+                <c:pt idx="4">
+                  <c:v>0.012695711906396488</c:v>
+                </c:pt>
+                <c:pt idx="5">
+                  <c:v>0.012614909277240783</c:v>
+                </c:pt>
+                <c:pt idx="6">
+                  <c:v>0.012608844876111833</c:v>
+                </c:pt>
+                <c:pt idx="7">
+                  <c:v>0.012612105080198438</c:v>
+                </c:pt>
+                <c:pt idx="8">
+                  <c:v>0.012613305998377794</c:v>
+                </c:pt>
+                <c:pt idx="9">
+                  <c:v>0.01261103165042904</c:v>
+                </c:pt>
+                <c:pt idx="10">
+                  <c:v>0.012611095567661773</c:v>
+                </c:pt>
+                <c:pt idx="11">
+                  <c:v>0.012611020820362409</c:v>
+                </c:pt>
+                <c:pt idx="12">
+                  <c:v>0.01261494669757366</c:v>
+                </c:pt>
+                <c:pt idx="13">
+                  <c:v>0.012614015297089089</c:v>
+                </c:pt>
+                <c:pt idx="14">
+                  <c:v>0.01261466692917814</c:v>
+                </c:pt>
+                <c:pt idx="15">
+                  <c:v>0.012610465077833316</c:v>
+                </c:pt>
+                <c:pt idx="16">
+                  <c:v>0.012612861217743666</c:v>
+                </c:pt>
+                <c:pt idx="17">
+                  <c:v>0.01261254638998317</c:v>
+                </c:pt>
+                <c:pt idx="18">
+                  <c:v>0.012612973530032016</c:v>
+                </c:pt>
+                <c:pt idx="19">
+                  <c:v>0.012612213995815406</c:v>
+                </c:pt>
+                <c:pt idx="20">
+                  <c:v>0.012612722488070055</c:v>
+                </c:pt>
+              </c:numCache>
+            </c:numRef>
+          </c:yVal>
+          <c:smooth val="0"/>
+        </c:ser>
+        <c:axId val="-2128940872"/>
+        <c:axId val="-2129643912"/>
+      </c:scatterChart>
+      <c:valAx>
+        <c:axId val="-2128940872"/>
+        <c:scaling>
+          <c:orientation val="minMax"/>
+          <c:max val="400.0"/>
+          <c:min val="0.0"/>
+        </c:scaling>
+        <c:delete val="0"/>
+        <c:axPos val="b"/>
+        <c:title>
+          <c:tx>
+            <c:rich>
+              <a:bodyPr/>
+              <a:lstStyle/>
+              <a:p>
+                <a:r>
+                  <a:rPr sz="1100" b="0">
+                    <a:latin typeface="Arial"/>
+                  </a:rPr>
+                  <a:t>Lateral buffer (nm)   [over-etch 700 nm]</a:t>
+                </a:r>
+              </a:p>
+            </c:rich>
+          </c:tx>
+          <c:layout/>
+          <c:overlay val="0"/>
+        </c:title>
+        <c:numFmt formatCode="General" sourceLinked="1"/>
+        <c:majorTickMark val="out"/>
+        <c:minorTickMark val="none"/>
+        <c:tickLblPos val="nextTo"/>
+        <c:txPr>
+          <a:bodyPr/>
+          <a:lstStyle/>
+          <a:p>
+            <a:pPr>
+              <a:defRPr sz="1000">
+                <a:latin typeface="Arial"/>
+              </a:defRPr>
+            </a:pPr>
+          </a:p>
+        </c:txPr>
+        <c:crossAx val="-2129643912"/>
+        <c:crosses val="autoZero"/>
+        <c:crossBetween val="midCat"/>
+        <c:majorUnit val="50.0"/>
+      </c:valAx>
+      <c:valAx>
+        <c:axId val="-2129643912"/>
+        <c:scaling>
+          <c:orientation val="minMax"/>
+          <c:max val="0.03"/>
+          <c:min val="0.0"/>
+        </c:scaling>
+        <c:delete val="0"/>
+        <c:axPos val="l"/>
+        <c:majorGridlines>
+          <c:spPr>
+            <a:ln>
+              <a:solidFill>
+                <a:srgbClr val="E3E3E3"/>
+              </a:solidFill>
+            </a:ln>
+          </c:spPr>
+        </c:majorGridlines>
+        <c:title>
+          <c:tx>
+            <c:rich>
+              <a:bodyPr/>
+              <a:lstStyle/>
+              <a:p>
+                <a:r>
+                  <a:rPr sz="1100" b="0">
+                    <a:latin typeface="Arial"/>
+                  </a:rPr>
+                  <a:t>IL (dB/cm)</a:t>
+                </a:r>
+              </a:p>
+            </c:rich>
+          </c:tx>
+          <c:layout/>
+          <c:overlay val="0"/>
+        </c:title>
+        <c:numFmt formatCode="General" sourceLinked="0"/>
+        <c:majorTickMark val="out"/>
+        <c:minorTickMark val="none"/>
+        <c:tickLblPos val="nextTo"/>
+        <c:txPr>
+          <a:bodyPr/>
+          <a:lstStyle/>
+          <a:p>
+            <a:pPr>
+              <a:defRPr sz="1000">
+                <a:latin typeface="Arial"/>
+              </a:defRPr>
+            </a:pPr>
+          </a:p>
+        </c:txPr>
+        <c:crossAx val="-2128940872"/>
+        <c:crosses val="autoZero"/>
+        <c:crossBetween val="midCat"/>
+        <c:majorUnit val="0.005"/>
+      </c:valAx>
+    </c:plotArea>
     <c:plotVisOnly val="1"/>
     <c:dispBlanksAs val="gap"/>
     <c:showDLblsOverMax val="0"/>
@@ -12760,6 +13380,832 @@
                 <a:latin typeface="Arial"/>
               </a:rPr>
               <a:t>The buffer removes the gold contact at the slab end: no cavity, no ripples, IL independent of slab-width errors, at equal Vπ·L.</a:t>
+            </a:r>
+          </a:p>
+        </p:txBody>
+      </p:sp>
+    </p:spTree>
+  </p:cSld>
+  <p:clrMapOvr>
+    <a:masterClrMapping/>
+  </p:clrMapOvr>
+</p:sld>
+</file>
+
+<file path=ppt/slides/slide27.xml><?xml version="1.0" encoding="utf-8"?>
+<p:sld xmlns:a="http://schemas.openxmlformats.org/drawingml/2006/main" xmlns:p="http://schemas.openxmlformats.org/presentationml/2006/main" xmlns:r="http://schemas.openxmlformats.org/officeDocument/2006/relationships">
+  <p:cSld>
+    <p:spTree>
+      <p:nvGrpSpPr>
+        <p:cNvPr id="1" name=""/>
+        <p:cNvGrpSpPr/>
+        <p:nvPr/>
+      </p:nvGrpSpPr>
+      <p:grpSpPr/>
+      <p:sp>
+        <p:nvSpPr>
+          <p:cNvPr id="2" name="TextBox 1"/>
+          <p:cNvSpPr txBox="1"/>
+          <p:nvPr/>
+        </p:nvSpPr>
+        <p:spPr>
+          <a:xfrm>
+            <a:off x="502920" y="475488"/>
+            <a:ext cx="10241280" cy="685800"/>
+          </a:xfrm>
+          <a:prstGeom prst="rect">
+            <a:avLst/>
+          </a:prstGeom>
+          <a:noFill/>
+        </p:spPr>
+        <p:txBody>
+          <a:bodyPr wrap="square" lIns="45720" rIns="45720" tIns="27432" bIns="27432" anchor="ctr">
+            <a:spAutoFit/>
+          </a:bodyPr>
+          <a:lstStyle/>
+          <a:p>
+            <a:pPr algn="l">
+              <a:spcAft>
+                <a:spcPts val="600"/>
+              </a:spcAft>
+            </a:pPr>
+            <a:r>
+              <a:rPr sz="3000" b="0" i="0">
+                <a:solidFill>
+                  <a:srgbClr val="222222"/>
+                </a:solidFill>
+                <a:latin typeface="Arial"/>
+              </a:rPr>
+              <a:t>Buffered Istanbul with the 700 nm BOX over-etch</a:t>
+            </a:r>
+          </a:p>
+        </p:txBody>
+      </p:sp>
+      <p:sp>
+        <p:nvSpPr>
+          <p:cNvPr id="3" name="TextBox 2"/>
+          <p:cNvSpPr txBox="1"/>
+          <p:nvPr/>
+        </p:nvSpPr>
+        <p:spPr>
+          <a:xfrm>
+            <a:off x="502920" y="1115568"/>
+            <a:ext cx="10789920" cy="411480"/>
+          </a:xfrm>
+          <a:prstGeom prst="rect">
+            <a:avLst/>
+          </a:prstGeom>
+          <a:noFill/>
+        </p:spPr>
+        <p:txBody>
+          <a:bodyPr wrap="square" lIns="45720" rIns="45720" tIns="27432" bIns="27432" anchor="t">
+            <a:spAutoFit/>
+          </a:bodyPr>
+          <a:lstStyle/>
+          <a:p>
+            <a:pPr algn="l">
+              <a:spcAft>
+                <a:spcPts val="600"/>
+              </a:spcAft>
+            </a:pPr>
+            <a:r>
+              <a:rPr sz="1500" b="0" i="1">
+                <a:solidFill>
+                  <a:srgbClr val="595959"/>
+                </a:solidFill>
+                <a:latin typeface="Arial"/>
+              </a:rPr>
+              <a:t>Gap 3.65 µm, slab 10.15 µm, 60° slab ends, 200 nm buffer, 1575 nm</a:t>
+            </a:r>
+          </a:p>
+        </p:txBody>
+      </p:sp>
+      <p:pic>
+        <p:nvPicPr>
+          <p:cNvPr id="4" name="Picture 3" descr="preview_nominal.png"/>
+          <p:cNvPicPr>
+            <a:picLocks noChangeAspect="1"/>
+          </p:cNvPicPr>
+          <p:nvPr/>
+        </p:nvPicPr>
+        <p:blipFill>
+          <a:blip r:embed="rId2"/>
+          <a:stretch>
+            <a:fillRect/>
+          </a:stretch>
+        </p:blipFill>
+        <p:spPr>
+          <a:xfrm>
+            <a:off x="548640" y="1554480"/>
+            <a:ext cx="11064240" cy="3063943"/>
+          </a:xfrm>
+          <a:prstGeom prst="rect">
+            <a:avLst/>
+          </a:prstGeom>
+        </p:spPr>
+      </p:pic>
+      <p:pic>
+        <p:nvPicPr>
+          <p:cNvPr id="5" name="Picture 4" descr="xs_buf_oe_zooms.png"/>
+          <p:cNvPicPr>
+            <a:picLocks noChangeAspect="1"/>
+          </p:cNvPicPr>
+          <p:nvPr/>
+        </p:nvPicPr>
+        <p:blipFill>
+          <a:blip r:embed="rId3"/>
+          <a:stretch>
+            <a:fillRect/>
+          </a:stretch>
+        </p:blipFill>
+        <p:spPr>
+          <a:xfrm>
+            <a:off x="548640" y="4434840"/>
+            <a:ext cx="5538184" cy="1828800"/>
+          </a:xfrm>
+          <a:prstGeom prst="rect">
+            <a:avLst/>
+          </a:prstGeom>
+        </p:spPr>
+      </p:pic>
+      <p:sp>
+        <p:nvSpPr>
+          <p:cNvPr id="6" name="Rounded Rectangle 5"/>
+          <p:cNvSpPr/>
+          <p:nvPr/>
+        </p:nvSpPr>
+        <p:spPr>
+          <a:xfrm>
+            <a:off x="8503920" y="4572000"/>
+            <a:ext cx="3200400" cy="1508760"/>
+          </a:xfrm>
+          <a:prstGeom prst="roundRect">
+            <a:avLst>
+              <a:gd name="adj" fmla="val 6000"/>
+            </a:avLst>
+          </a:prstGeom>
+          <a:solidFill>
+            <a:srgbClr val="EAF0F7"/>
+          </a:solidFill>
+          <a:ln>
+            <a:noFill/>
+          </a:ln>
+          <a:effectLst/>
+        </p:spPr>
+        <p:style>
+          <a:lnRef idx="1">
+            <a:schemeClr val="accent1"/>
+          </a:lnRef>
+          <a:fillRef idx="3">
+            <a:schemeClr val="accent1"/>
+          </a:fillRef>
+          <a:effectRef idx="2">
+            <a:schemeClr val="accent1"/>
+          </a:effectRef>
+          <a:fontRef idx="minor">
+            <a:schemeClr val="lt1"/>
+          </a:fontRef>
+        </p:style>
+        <p:txBody>
+          <a:bodyPr rtlCol="0" anchor="t" wrap="square" lIns="137160" rIns="137160" tIns="91440" bIns="91440"/>
+          <a:lstStyle/>
+          <a:p>
+            <a:pPr algn="l">
+              <a:spcAft>
+                <a:spcPts val="400"/>
+              </a:spcAft>
+            </a:pPr>
+            <a:r>
+              <a:rPr sz="1400" b="1" i="0">
+                <a:solidFill>
+                  <a:srgbClr val="1F4E79"/>
+                </a:solidFill>
+                <a:latin typeface="Arial"/>
+              </a:rPr>
+              <a:t>Two sweeps</a:t>
+            </a:r>
+          </a:p>
+          <a:p>
+            <a:pPr algn="l">
+              <a:spcAft>
+                <a:spcPts val="200"/>
+              </a:spcAft>
+            </a:pPr>
+            <a:r>
+              <a:rPr sz="1200" b="0" i="0">
+                <a:solidFill>
+                  <a:srgbClr val="222222"/>
+                </a:solidFill>
+                <a:latin typeface="Arial"/>
+              </a:rPr>
+              <a:t>Over-etch 0 → 900 nm</a:t>
+            </a:r>
+          </a:p>
+          <a:p>
+            <a:pPr algn="l">
+              <a:spcAft>
+                <a:spcPts val="200"/>
+              </a:spcAft>
+            </a:pPr>
+            <a:r>
+              <a:rPr sz="1200" b="0" i="0">
+                <a:solidFill>
+                  <a:srgbClr val="222222"/>
+                </a:solidFill>
+                <a:latin typeface="Arial"/>
+              </a:rPr>
+              <a:t>Lateral (side-wall) buffer 0 → 400 nm</a:t>
+            </a:r>
+          </a:p>
+          <a:p>
+            <a:pPr algn="l">
+              <a:spcAft>
+                <a:spcPts val="500"/>
+              </a:spcAft>
+            </a:pPr>
+            <a:r>
+              <a:rPr sz="1100" b="0" i="0">
+                <a:solidFill>
+                  <a:srgbClr val="595959"/>
+                </a:solidFill>
+                <a:latin typeface="Arial"/>
+              </a:rPr>
+              <a:t>Top and floor buffer fixed at 200 nm</a:t>
+            </a:r>
+          </a:p>
+        </p:txBody>
+      </p:sp>
+    </p:spTree>
+  </p:cSld>
+  <p:clrMapOvr>
+    <a:masterClrMapping/>
+  </p:clrMapOvr>
+</p:sld>
+</file>
+
+<file path=ppt/slides/slide28.xml><?xml version="1.0" encoding="utf-8"?>
+<p:sld xmlns:a="http://schemas.openxmlformats.org/drawingml/2006/main" xmlns:p="http://schemas.openxmlformats.org/presentationml/2006/main" xmlns:r="http://schemas.openxmlformats.org/officeDocument/2006/relationships">
+  <p:cSld>
+    <p:spTree>
+      <p:nvGrpSpPr>
+        <p:cNvPr id="1" name=""/>
+        <p:cNvGrpSpPr/>
+        <p:nvPr/>
+      </p:nvGrpSpPr>
+      <p:grpSpPr/>
+      <p:sp>
+        <p:nvSpPr>
+          <p:cNvPr id="2" name="TextBox 1"/>
+          <p:cNvSpPr txBox="1"/>
+          <p:nvPr/>
+        </p:nvSpPr>
+        <p:spPr>
+          <a:xfrm>
+            <a:off x="502920" y="475488"/>
+            <a:ext cx="10241280" cy="685800"/>
+          </a:xfrm>
+          <a:prstGeom prst="rect">
+            <a:avLst/>
+          </a:prstGeom>
+          <a:noFill/>
+        </p:spPr>
+        <p:txBody>
+          <a:bodyPr wrap="square" lIns="45720" rIns="45720" tIns="27432" bIns="27432" anchor="ctr">
+            <a:spAutoFit/>
+          </a:bodyPr>
+          <a:lstStyle/>
+          <a:p>
+            <a:pPr algn="l">
+              <a:spcAft>
+                <a:spcPts val="600"/>
+              </a:spcAft>
+            </a:pPr>
+            <a:r>
+              <a:rPr sz="3000" b="0" i="0">
+                <a:solidFill>
+                  <a:srgbClr val="222222"/>
+                </a:solidFill>
+                <a:latin typeface="Arial"/>
+              </a:rPr>
+              <a:t>Over-etch and lateral buffer: no effect on IL</a:t>
+            </a:r>
+          </a:p>
+        </p:txBody>
+      </p:sp>
+      <p:sp>
+        <p:nvSpPr>
+          <p:cNvPr id="3" name="TextBox 2"/>
+          <p:cNvSpPr txBox="1"/>
+          <p:nvPr/>
+        </p:nvSpPr>
+        <p:spPr>
+          <a:xfrm>
+            <a:off x="502920" y="1115568"/>
+            <a:ext cx="10789920" cy="411480"/>
+          </a:xfrm>
+          <a:prstGeom prst="rect">
+            <a:avLst/>
+          </a:prstGeom>
+          <a:noFill/>
+        </p:spPr>
+        <p:txBody>
+          <a:bodyPr wrap="square" lIns="45720" rIns="45720" tIns="27432" bIns="27432" anchor="t">
+            <a:spAutoFit/>
+          </a:bodyPr>
+          <a:lstStyle/>
+          <a:p>
+            <a:pPr algn="l">
+              <a:spcAft>
+                <a:spcPts val="600"/>
+              </a:spcAft>
+            </a:pPr>
+            <a:r>
+              <a:rPr sz="1500" b="0" i="1">
+                <a:solidFill>
+                  <a:srgbClr val="595959"/>
+                </a:solidFill>
+                <a:latin typeface="Arial"/>
+              </a:rPr>
+              <a:t>Same buffered design; IL axis 0–0.03 dB/cm</a:t>
+            </a:r>
+          </a:p>
+        </p:txBody>
+      </p:sp>
+      <p:graphicFrame>
+        <p:nvGraphicFramePr>
+          <p:cNvPr id="4" name="Chart 3"/>
+          <p:cNvGraphicFramePr>
+            <a:graphicFrameLocks noGrp="1"/>
+          </p:cNvGraphicFramePr>
+          <p:nvPr/>
+        </p:nvGraphicFramePr>
+        <p:xfrm>
+          <a:off x="548640" y="1600200"/>
+          <a:ext cx="5486400" cy="3017520"/>
+        </p:xfrm>
+        <a:graphic>
+          <a:graphicData uri="http://schemas.openxmlformats.org/drawingml/2006/chart">
+            <c:chart xmlns:c="http://schemas.openxmlformats.org/drawingml/2006/chart" r:id="rId2"/>
+          </a:graphicData>
+        </a:graphic>
+      </p:graphicFrame>
+      <p:graphicFrame>
+        <p:nvGraphicFramePr>
+          <p:cNvPr id="5" name="Chart 4"/>
+          <p:cNvGraphicFramePr>
+            <a:graphicFrameLocks noGrp="1"/>
+          </p:cNvGraphicFramePr>
+          <p:nvPr/>
+        </p:nvGraphicFramePr>
+        <p:xfrm>
+          <a:off x="6217920" y="1600200"/>
+          <a:ext cx="5486400" cy="3017520"/>
+        </p:xfrm>
+        <a:graphic>
+          <a:graphicData uri="http://schemas.openxmlformats.org/drawingml/2006/chart">
+            <c:chart xmlns:c="http://schemas.openxmlformats.org/drawingml/2006/chart" r:id="rId3"/>
+          </a:graphicData>
+        </a:graphic>
+      </p:graphicFrame>
+      <p:sp>
+        <p:nvSpPr>
+          <p:cNvPr id="6" name="Rounded Rectangle 5"/>
+          <p:cNvSpPr/>
+          <p:nvPr/>
+        </p:nvSpPr>
+        <p:spPr>
+          <a:xfrm>
+            <a:off x="548640" y="4800600"/>
+            <a:ext cx="3566160" cy="1051560"/>
+          </a:xfrm>
+          <a:prstGeom prst="roundRect">
+            <a:avLst>
+              <a:gd name="adj" fmla="val 8000"/>
+            </a:avLst>
+          </a:prstGeom>
+          <a:solidFill>
+            <a:srgbClr val="EAF0F7"/>
+          </a:solidFill>
+          <a:ln>
+            <a:noFill/>
+          </a:ln>
+          <a:effectLst/>
+        </p:spPr>
+        <p:style>
+          <a:lnRef idx="1">
+            <a:schemeClr val="accent1"/>
+          </a:lnRef>
+          <a:fillRef idx="3">
+            <a:schemeClr val="accent1"/>
+          </a:fillRef>
+          <a:effectRef idx="2">
+            <a:schemeClr val="accent1"/>
+          </a:effectRef>
+          <a:fontRef idx="minor">
+            <a:schemeClr val="lt1"/>
+          </a:fontRef>
+        </p:style>
+        <p:txBody>
+          <a:bodyPr rtlCol="0" anchor="ctr"/>
+          <a:lstStyle/>
+          <a:p>
+            <a:pPr algn="ctr"/>
+          </a:p>
+        </p:txBody>
+      </p:sp>
+      <p:sp>
+        <p:nvSpPr>
+          <p:cNvPr id="7" name="TextBox 6"/>
+          <p:cNvSpPr txBox="1"/>
+          <p:nvPr/>
+        </p:nvSpPr>
+        <p:spPr>
+          <a:xfrm>
+            <a:off x="548640" y="4910328"/>
+            <a:ext cx="3566160" cy="578358"/>
+          </a:xfrm>
+          <a:prstGeom prst="rect">
+            <a:avLst/>
+          </a:prstGeom>
+          <a:noFill/>
+        </p:spPr>
+        <p:txBody>
+          <a:bodyPr wrap="square" lIns="45720" rIns="45720" tIns="27432" bIns="27432" anchor="ctr">
+            <a:spAutoFit/>
+          </a:bodyPr>
+          <a:lstStyle/>
+          <a:p>
+            <a:pPr algn="ctr">
+              <a:spcAft>
+                <a:spcPts val="600"/>
+              </a:spcAft>
+            </a:pPr>
+            <a:r>
+              <a:rPr sz="3000" b="1" i="0">
+                <a:solidFill>
+                  <a:srgbClr val="1B9E77"/>
+                </a:solidFill>
+                <a:latin typeface="Arial"/>
+              </a:rPr>
+              <a:t>0.0126 dB/cm</a:t>
+            </a:r>
+          </a:p>
+        </p:txBody>
+      </p:sp>
+      <p:sp>
+        <p:nvSpPr>
+          <p:cNvPr id="8" name="TextBox 7"/>
+          <p:cNvSpPr txBox="1"/>
+          <p:nvPr/>
+        </p:nvSpPr>
+        <p:spPr>
+          <a:xfrm>
+            <a:off x="640080" y="5431536"/>
+            <a:ext cx="3383279" cy="399592"/>
+          </a:xfrm>
+          <a:prstGeom prst="rect">
+            <a:avLst/>
+          </a:prstGeom>
+          <a:noFill/>
+        </p:spPr>
+        <p:txBody>
+          <a:bodyPr wrap="square" lIns="45720" rIns="45720" tIns="27432" bIns="27432" anchor="t">
+            <a:spAutoFit/>
+          </a:bodyPr>
+          <a:lstStyle/>
+          <a:p>
+            <a:pPr algn="ctr">
+              <a:spcAft>
+                <a:spcPts val="0"/>
+              </a:spcAft>
+            </a:pPr>
+            <a:r>
+              <a:rPr sz="1100" b="0" i="0">
+                <a:solidFill>
+                  <a:srgbClr val="595959"/>
+                </a:solidFill>
+                <a:latin typeface="Arial"/>
+              </a:rPr>
+              <a:t>IL at every point (within 1.4 %)</a:t>
+            </a:r>
+          </a:p>
+        </p:txBody>
+      </p:sp>
+      <p:sp>
+        <p:nvSpPr>
+          <p:cNvPr id="9" name="Rounded Rectangle 8"/>
+          <p:cNvSpPr/>
+          <p:nvPr/>
+        </p:nvSpPr>
+        <p:spPr>
+          <a:xfrm>
+            <a:off x="4343400" y="4800600"/>
+            <a:ext cx="3566160" cy="1051560"/>
+          </a:xfrm>
+          <a:prstGeom prst="roundRect">
+            <a:avLst>
+              <a:gd name="adj" fmla="val 8000"/>
+            </a:avLst>
+          </a:prstGeom>
+          <a:solidFill>
+            <a:srgbClr val="EAF0F7"/>
+          </a:solidFill>
+          <a:ln>
+            <a:noFill/>
+          </a:ln>
+          <a:effectLst/>
+        </p:spPr>
+        <p:style>
+          <a:lnRef idx="1">
+            <a:schemeClr val="accent1"/>
+          </a:lnRef>
+          <a:fillRef idx="3">
+            <a:schemeClr val="accent1"/>
+          </a:fillRef>
+          <a:effectRef idx="2">
+            <a:schemeClr val="accent1"/>
+          </a:effectRef>
+          <a:fontRef idx="minor">
+            <a:schemeClr val="lt1"/>
+          </a:fontRef>
+        </p:style>
+        <p:txBody>
+          <a:bodyPr rtlCol="0" anchor="ctr"/>
+          <a:lstStyle/>
+          <a:p>
+            <a:pPr algn="ctr"/>
+          </a:p>
+        </p:txBody>
+      </p:sp>
+      <p:sp>
+        <p:nvSpPr>
+          <p:cNvPr id="10" name="TextBox 9"/>
+          <p:cNvSpPr txBox="1"/>
+          <p:nvPr/>
+        </p:nvSpPr>
+        <p:spPr>
+          <a:xfrm>
+            <a:off x="4343400" y="4910328"/>
+            <a:ext cx="3566160" cy="578358"/>
+          </a:xfrm>
+          <a:prstGeom prst="rect">
+            <a:avLst/>
+          </a:prstGeom>
+          <a:noFill/>
+        </p:spPr>
+        <p:txBody>
+          <a:bodyPr wrap="square" lIns="45720" rIns="45720" tIns="27432" bIns="27432" anchor="ctr">
+            <a:spAutoFit/>
+          </a:bodyPr>
+          <a:lstStyle/>
+          <a:p>
+            <a:pPr algn="ctr">
+              <a:spcAft>
+                <a:spcPts val="600"/>
+              </a:spcAft>
+            </a:pPr>
+            <a:r>
+              <a:rPr sz="3000" b="1" i="0">
+                <a:solidFill>
+                  <a:srgbClr val="1F4E79"/>
+                </a:solidFill>
+                <a:latin typeface="Arial"/>
+              </a:rPr>
+              <a:t>−0.24 %</a:t>
+            </a:r>
+          </a:p>
+        </p:txBody>
+      </p:sp>
+      <p:sp>
+        <p:nvSpPr>
+          <p:cNvPr id="11" name="TextBox 10"/>
+          <p:cNvSpPr txBox="1"/>
+          <p:nvPr/>
+        </p:nvSpPr>
+        <p:spPr>
+          <a:xfrm>
+            <a:off x="4434840" y="5431536"/>
+            <a:ext cx="3383279" cy="399592"/>
+          </a:xfrm>
+          <a:prstGeom prst="rect">
+            <a:avLst/>
+          </a:prstGeom>
+          <a:noFill/>
+        </p:spPr>
+        <p:txBody>
+          <a:bodyPr wrap="square" lIns="45720" rIns="45720" tIns="27432" bIns="27432" anchor="t">
+            <a:spAutoFit/>
+          </a:bodyPr>
+          <a:lstStyle/>
+          <a:p>
+            <a:pPr algn="ctr">
+              <a:spcAft>
+                <a:spcPts val="0"/>
+              </a:spcAft>
+            </a:pPr>
+            <a:r>
+              <a:rPr sz="1100" b="0" i="0">
+                <a:solidFill>
+                  <a:srgbClr val="595959"/>
+                </a:solidFill>
+                <a:latin typeface="Arial"/>
+              </a:rPr>
+              <a:t>Vπ·L from 0 to 900 nm over-etch</a:t>
+            </a:r>
+          </a:p>
+          <a:p>
+            <a:pPr algn="ctr">
+              <a:spcAft>
+                <a:spcPts val="0"/>
+              </a:spcAft>
+            </a:pPr>
+            <a:r>
+              <a:rPr sz="1100" b="0" i="0">
+                <a:solidFill>
+                  <a:srgbClr val="595959"/>
+                </a:solidFill>
+                <a:latin typeface="Arial"/>
+              </a:rPr>
+              <a:t>(2.424 → 2.418 V·cm)</a:t>
+            </a:r>
+          </a:p>
+        </p:txBody>
+      </p:sp>
+      <p:sp>
+        <p:nvSpPr>
+          <p:cNvPr id="12" name="Rounded Rectangle 11"/>
+          <p:cNvSpPr/>
+          <p:nvPr/>
+        </p:nvSpPr>
+        <p:spPr>
+          <a:xfrm>
+            <a:off x="8138160" y="4800600"/>
+            <a:ext cx="3566160" cy="1051560"/>
+          </a:xfrm>
+          <a:prstGeom prst="roundRect">
+            <a:avLst>
+              <a:gd name="adj" fmla="val 8000"/>
+            </a:avLst>
+          </a:prstGeom>
+          <a:solidFill>
+            <a:srgbClr val="EAF0F7"/>
+          </a:solidFill>
+          <a:ln>
+            <a:noFill/>
+          </a:ln>
+          <a:effectLst/>
+        </p:spPr>
+        <p:style>
+          <a:lnRef idx="1">
+            <a:schemeClr val="accent1"/>
+          </a:lnRef>
+          <a:fillRef idx="3">
+            <a:schemeClr val="accent1"/>
+          </a:fillRef>
+          <a:effectRef idx="2">
+            <a:schemeClr val="accent1"/>
+          </a:effectRef>
+          <a:fontRef idx="minor">
+            <a:schemeClr val="lt1"/>
+          </a:fontRef>
+        </p:style>
+        <p:txBody>
+          <a:bodyPr rtlCol="0" anchor="ctr"/>
+          <a:lstStyle/>
+          <a:p>
+            <a:pPr algn="ctr"/>
+          </a:p>
+        </p:txBody>
+      </p:sp>
+      <p:sp>
+        <p:nvSpPr>
+          <p:cNvPr id="13" name="TextBox 12"/>
+          <p:cNvSpPr txBox="1"/>
+          <p:nvPr/>
+        </p:nvSpPr>
+        <p:spPr>
+          <a:xfrm>
+            <a:off x="8138160" y="4910328"/>
+            <a:ext cx="3566160" cy="578358"/>
+          </a:xfrm>
+          <a:prstGeom prst="rect">
+            <a:avLst/>
+          </a:prstGeom>
+          <a:noFill/>
+        </p:spPr>
+        <p:txBody>
+          <a:bodyPr wrap="square" lIns="45720" rIns="45720" tIns="27432" bIns="27432" anchor="ctr">
+            <a:spAutoFit/>
+          </a:bodyPr>
+          <a:lstStyle/>
+          <a:p>
+            <a:pPr algn="ctr">
+              <a:spcAft>
+                <a:spcPts val="600"/>
+              </a:spcAft>
+            </a:pPr>
+            <a:r>
+              <a:rPr sz="3000" b="1" i="0">
+                <a:solidFill>
+                  <a:srgbClr val="1F4E79"/>
+                </a:solidFill>
+                <a:latin typeface="Arial"/>
+              </a:rPr>
+              <a:t>0 nm OK</a:t>
+            </a:r>
+          </a:p>
+        </p:txBody>
+      </p:sp>
+      <p:sp>
+        <p:nvSpPr>
+          <p:cNvPr id="14" name="TextBox 13"/>
+          <p:cNvSpPr txBox="1"/>
+          <p:nvPr/>
+        </p:nvSpPr>
+        <p:spPr>
+          <a:xfrm>
+            <a:off x="8229600" y="5431536"/>
+            <a:ext cx="3383279" cy="399592"/>
+          </a:xfrm>
+          <a:prstGeom prst="rect">
+            <a:avLst/>
+          </a:prstGeom>
+          <a:noFill/>
+        </p:spPr>
+        <p:txBody>
+          <a:bodyPr wrap="square" lIns="45720" rIns="45720" tIns="27432" bIns="27432" anchor="t">
+            <a:spAutoFit/>
+          </a:bodyPr>
+          <a:lstStyle/>
+          <a:p>
+            <a:pPr algn="ctr">
+              <a:spcAft>
+                <a:spcPts val="0"/>
+              </a:spcAft>
+            </a:pPr>
+            <a:r>
+              <a:rPr sz="1100" b="0" i="0">
+                <a:solidFill>
+                  <a:srgbClr val="595959"/>
+                </a:solidFill>
+                <a:latin typeface="Arial"/>
+              </a:rPr>
+              <a:t>even gold on the LN slope</a:t>
+            </a:r>
+          </a:p>
+          <a:p>
+            <a:pPr algn="ctr">
+              <a:spcAft>
+                <a:spcPts val="0"/>
+              </a:spcAft>
+            </a:pPr>
+            <a:r>
+              <a:rPr sz="1100" b="0" i="0">
+                <a:solidFill>
+                  <a:srgbClr val="595959"/>
+                </a:solidFill>
+                <a:latin typeface="Arial"/>
+              </a:rPr>
+              <a:t>gives the same IL</a:t>
+            </a:r>
+          </a:p>
+        </p:txBody>
+      </p:sp>
+      <p:sp>
+        <p:nvSpPr>
+          <p:cNvPr id="15" name="TextBox 14"/>
+          <p:cNvSpPr txBox="1"/>
+          <p:nvPr/>
+        </p:nvSpPr>
+        <p:spPr>
+          <a:xfrm>
+            <a:off x="548640" y="5989320"/>
+            <a:ext cx="11155680" cy="548640"/>
+          </a:xfrm>
+          <a:prstGeom prst="rect">
+            <a:avLst/>
+          </a:prstGeom>
+          <a:noFill/>
+        </p:spPr>
+        <p:txBody>
+          <a:bodyPr wrap="square" lIns="45720" rIns="45720" tIns="27432" bIns="27432" anchor="t">
+            <a:spAutoFit/>
+          </a:bodyPr>
+          <a:lstStyle/>
+          <a:p>
+            <a:pPr algn="l">
+              <a:spcAft>
+                <a:spcPts val="600"/>
+              </a:spcAft>
+            </a:pPr>
+            <a:r>
+              <a:rPr sz="1300" b="1" i="0">
+                <a:solidFill>
+                  <a:srgbClr val="1F4E79"/>
+                </a:solidFill>
+                <a:latin typeface="Arial"/>
+              </a:rPr>
+              <a:t>The top buffer removes the guided slab wave under the gold: no power reaches the slab end, so what surrounds it (recess, side buffer, gold) no longer matters.</a:t>
             </a:r>
           </a:p>
         </p:txBody>

</xml_diff>